<commit_message>
Identity system V0.3: institutional precision pass
Replace doctrine-equivalent products with formal framework publications.
Descriptor no longer asserts an unendorsed capability label and is marked
as settled at endorsement. Army logo rule applies at artefact level
rather than every component. Red and risk reconciled: red marks decision
nodes and defined threshold states, risk is otherwise structural. Pilot
notation set named explicitly with Governance replacing Doctrine until
authority arrangements exist. Architecture notes the pilot tests type
versus metadata. Running footer shortened, sharpest absolutes softened,
and the stray wordmark in governance step 02 corrected, with the chevron
field derivation added to the expected DPA challenges.

Co-Authored-By: Claude Fable 5 <noreply@anthropic.com>
Claude-Session: https://claude.ai/code/session_01YLo1WfwUDkbwfJEF3ZNVbB
</commit_message>
<xml_diff>
--- a/output/combat-mindset-identity-system.pptx
+++ b/output/combat-mindset-identity-system.pptx
@@ -3349,7 +3349,7 @@
                 <a:ea typeface="Arial" pitchFamily="34" charset="-122"/>
                 <a:cs typeface="Arial" pitchFamily="34" charset="-120"/>
               </a:rPr>
-              <a:t>V0.2, August 2026</a:t>
+              <a:t>V0.3, August 2026</a:t>
             </a:r>
             <a:endParaRPr lang="en-US" sz="800" dirty="0"/>
           </a:p>
@@ -3599,7 +3599,7 @@
                 <a:ea typeface="Arial" pitchFamily="34" charset="-122"/>
                 <a:cs typeface="Arial" pitchFamily="34" charset="-120"/>
               </a:rPr>
-              <a:t>NZ ARMY   COMBAT MINDSET   VISUAL IDENTITY SYSTEM</a:t>
+              <a:t>COMBAT MINDSET   VISUAL IDENTITY</a:t>
             </a:r>
             <a:endParaRPr lang="en-US" sz="600" dirty="0"/>
           </a:p>
@@ -3638,7 +3638,7 @@
                 <a:ea typeface="Arial" pitchFamily="34" charset="-122"/>
                 <a:cs typeface="Arial" pitchFamily="34" charset="-120"/>
               </a:rPr>
-              <a:t>DRAFT FOR REVIEW   |   V0.2   |   AUGUST 2026</a:t>
+              <a:t>DRAFT V0.3   |   AUGUST 2026</a:t>
             </a:r>
             <a:endParaRPr lang="en-US" sz="600" dirty="0"/>
           </a:p>
@@ -6593,7 +6593,7 @@
                 <a:ea typeface="Arial" pitchFamily="34" charset="-122"/>
                 <a:cs typeface="Arial" pitchFamily="34" charset="-120"/>
               </a:rPr>
-              <a:t>Six typographic approaches for how Combat Mindset names itself. None is a logo and none is a freestanding asset: these are repeatable heading constructions. Set in Arial; production is Neue Haas Grotesk.</a:t>
+              <a:t>Six typographic approaches to presenting the Combat Mindset title. None is a logo and none is a freestanding asset: these are repeatable heading constructions. Set in Arial; production is Neue Haas Grotesk.</a:t>
             </a:r>
             <a:endParaRPr lang="en-US" sz="960" dirty="0"/>
           </a:p>
@@ -6632,7 +6632,7 @@
                 <a:ea typeface="Arial" pitchFamily="34" charset="-122"/>
                 <a:cs typeface="Arial" pitchFamily="34" charset="-120"/>
               </a:rPr>
-              <a:t>NZ ARMY   COMBAT MINDSET   VISUAL IDENTITY SYSTEM</a:t>
+              <a:t>COMBAT MINDSET   VISUAL IDENTITY</a:t>
             </a:r>
             <a:endParaRPr lang="en-US" sz="600" dirty="0"/>
           </a:p>
@@ -6671,7 +6671,7 @@
                 <a:ea typeface="Arial" pitchFamily="34" charset="-122"/>
                 <a:cs typeface="Arial" pitchFamily="34" charset="-120"/>
               </a:rPr>
-              <a:t>DRAFT FOR REVIEW   |   V0.2   |   AUGUST 2026</a:t>
+              <a:t>DRAFT V0.3   |   AUGUST 2026</a:t>
             </a:r>
             <a:endParaRPr lang="en-US" sz="600" dirty="0"/>
           </a:p>
@@ -7458,7 +7458,7 @@
                 <a:ea typeface="Arial" pitchFamily="34" charset="-122"/>
                 <a:cs typeface="Arial" pitchFamily="34" charset="-120"/>
               </a:rPr>
-              <a:t>NZ ARMY CAPABILITY FRAMEWORK</a:t>
+              <a:t>NZ ARMY COMBAT MINDSET FRAMEWORK</a:t>
             </a:r>
             <a:endParaRPr lang="en-US" sz="660" dirty="0"/>
           </a:p>
@@ -8418,7 +8418,7 @@
                 <a:ea typeface="Arial" pitchFamily="34" charset="-122"/>
                 <a:cs typeface="Arial" pitchFamily="34" charset="-120"/>
               </a:rPr>
-              <a:t>Carry 03 as the primary title treatment and 04 as the formal variant on covers, title pages and doctrine-equivalent products. Retain 02 for running headers and spines. Options 05 and 06 are recorded so that the reasons for rejecting them survive the people who rejected them.</a:t>
+              <a:t>Carry 03 as the primary title treatment and 04 as the formal variant on covers, title pages and formal framework publications. Retain 02 for running headers and spines. Options 05 and 06 are recorded so that the reasons for rejecting them survive the people who rejected them.</a:t>
             </a:r>
             <a:endParaRPr lang="en-US" sz="900" dirty="0"/>
           </a:p>
@@ -8668,7 +8668,7 @@
                 <a:ea typeface="Arial" pitchFamily="34" charset="-122"/>
                 <a:cs typeface="Arial" pitchFamily="34" charset="-120"/>
               </a:rPr>
-              <a:t>NZ ARMY   COMBAT MINDSET   VISUAL IDENTITY SYSTEM</a:t>
+              <a:t>COMBAT MINDSET   VISUAL IDENTITY</a:t>
             </a:r>
             <a:endParaRPr lang="en-US" sz="600" dirty="0"/>
           </a:p>
@@ -8707,7 +8707,7 @@
                 <a:ea typeface="Arial" pitchFamily="34" charset="-122"/>
                 <a:cs typeface="Arial" pitchFamily="34" charset="-120"/>
               </a:rPr>
-              <a:t>DRAFT FOR REVIEW   |   V0.2   |   AUGUST 2026</a:t>
+              <a:t>DRAFT V0.3   |   AUGUST 2026</a:t>
             </a:r>
             <a:endParaRPr lang="en-US" sz="600" dirty="0"/>
           </a:p>
@@ -8884,7 +8884,7 @@
                 <a:ea typeface="Arial" pitchFamily="34" charset="-122"/>
                 <a:cs typeface="Arial" pitchFamily="34" charset="-120"/>
               </a:rPr>
-              <a:t>NZ ARMY CAPABILITY FRAMEWORK</a:t>
+              <a:t>NZ ARMY COMBAT MINDSET FRAMEWORK</a:t>
             </a:r>
             <a:endParaRPr lang="en-US" sz="800" dirty="0"/>
           </a:p>
@@ -9327,7 +9327,7 @@
                 <a:ea typeface="Arial" pitchFamily="34" charset="-122"/>
                 <a:cs typeface="Arial" pitchFamily="34" charset="-120"/>
               </a:rPr>
-              <a:t>Set at one third of the title size, letterspaced 1.6. It may be omitted where context already establishes it. It may not be reworded.</a:t>
+              <a:t>One third of the title size, letterspaced 1.6. Wording settled at endorsement; until then, NZ Army Combat Mindset Framework. Omit where context establishes it; never reword locally.</a:t>
             </a:r>
             <a:endParaRPr lang="en-US" sz="860" dirty="0"/>
           </a:p>
@@ -9529,7 +9529,7 @@
                 <a:ea typeface="Arial" pitchFamily="34" charset="-122"/>
                 <a:cs typeface="Arial" pitchFamily="34" charset="-120"/>
               </a:rPr>
-              <a:t>The Army logo is always present and always larger in visual weight. The treatment never sits closer than the logo's own clear space, and never on the same baseline.</a:t>
+              <a:t>Appears on every complete formal artefact, at greater visual weight. It need not repeat inside every internal component or screen. The treatment stays outside the logo's clear space and off its baseline.</a:t>
             </a:r>
             <a:endParaRPr lang="en-US" sz="860" dirty="0"/>
           </a:p>
@@ -10343,7 +10343,7 @@
                 <a:ea typeface="Arial" pitchFamily="34" charset="-122"/>
                 <a:cs typeface="Arial" pitchFamily="34" charset="-120"/>
               </a:rPr>
-              <a:t>NZ ARMY   COMBAT MINDSET   VISUAL IDENTITY SYSTEM</a:t>
+              <a:t>COMBAT MINDSET   VISUAL IDENTITY</a:t>
             </a:r>
             <a:endParaRPr lang="en-US" sz="600" dirty="0"/>
           </a:p>
@@ -10382,7 +10382,7 @@
                 <a:ea typeface="Arial" pitchFamily="34" charset="-122"/>
                 <a:cs typeface="Arial" pitchFamily="34" charset="-120"/>
               </a:rPr>
-              <a:t>DRAFT FOR REVIEW   |   V0.2   |   AUGUST 2026</a:t>
+              <a:t>DRAFT V0.3   |   AUGUST 2026</a:t>
             </a:r>
             <a:endParaRPr lang="en-US" sz="600" dirty="0"/>
           </a:p>
@@ -11999,7 +11999,7 @@
                 <a:ea typeface="Arial" pitchFamily="34" charset="-122"/>
                 <a:cs typeface="Arial" pitchFamily="34" charset="-120"/>
               </a:rPr>
-              <a:t>Red used as a surface, a heading colour or a fill. Red marks decision and risk. Spending it elsewhere destroys the only signal in the system that carries urgency.</a:t>
+              <a:t>Red used as a surface, a heading colour or a fill. Red marks decision nodes and defined threshold states; risk is otherwise carried structurally by the broken datum. Spending it elsewhere destroys the only signal in the system that carries urgency.</a:t>
             </a:r>
             <a:endParaRPr lang="en-US" sz="880" dirty="0"/>
           </a:p>
@@ -12273,7 +12273,7 @@
                 <a:ea typeface="Arial" pitchFamily="34" charset="-122"/>
                 <a:cs typeface="Arial" pitchFamily="34" charset="-120"/>
               </a:rPr>
-              <a:t>NZ ARMY   COMBAT MINDSET   VISUAL IDENTITY SYSTEM</a:t>
+              <a:t>COMBAT MINDSET   VISUAL IDENTITY</a:t>
             </a:r>
             <a:endParaRPr lang="en-US" sz="600" dirty="0"/>
           </a:p>
@@ -12312,7 +12312,7 @@
                 <a:ea typeface="Arial" pitchFamily="34" charset="-122"/>
                 <a:cs typeface="Arial" pitchFamily="34" charset="-120"/>
               </a:rPr>
-              <a:t>DRAFT FOR REVIEW   |   V0.2   |   AUGUST 2026</a:t>
+              <a:t>DRAFT V0.3   |   AUGUST 2026</a:t>
             </a:r>
             <a:endParaRPr lang="en-US" sz="600" dirty="0"/>
           </a:p>
@@ -12386,7 +12386,7 @@
         <p:spPr>
           <a:xfrm>
             <a:off x="566928" y="2121408"/>
-            <a:ext cx="6428232" cy="713232"/>
+            <a:ext cx="6428232" cy="896112"/>
           </a:xfrm>
           <a:prstGeom prst="rect">
             <a:avLst/>
@@ -12413,7 +12413,7 @@
                 <a:ea typeface="Arial" pitchFamily="34" charset="-122"/>
                 <a:cs typeface="Arial" pitchFamily="34" charset="-120"/>
               </a:rPr>
-              <a:t>Every mark is drawn on a 24 unit grid at 2 unit stroke, and every mark contains the datum at y=17. What differs is what happens to that datum, and what sits on it. A reader who learns the grammar once can interpret a mark they have never seen, which is the property a pictogram set can never have. Six marks form the pilot set; the remainder are drafted to prove the grammar extends, and are introduced only when repository content shows the distinction is needed.</a:t>
+              <a:t>Every mark is drawn on a 24 unit grid at 2 unit stroke, and every mark contains the datum at y=17. What differs is what happens to that datum, and what sits on it. A reader who learns the grammar once can interpret a mark they have never seen, which is the property a pictogram set can never have. Six marks form the pilot set: Framework, Governance, Evidence, Assessment, Product and Decision, the minimum spread across the four families. Doctrine and the other marks are drafted to prove the grammar extends, and join when authority arrangements and repository content warrant them.</a:t>
             </a:r>
             <a:endParaRPr lang="en-US" sz="900" dirty="0"/>
           </a:p>
@@ -12427,7 +12427,7 @@
         </p:nvSpPr>
         <p:spPr>
           <a:xfrm>
-            <a:off x="566928" y="2944368"/>
+            <a:off x="566928" y="3127248"/>
             <a:ext cx="6428232" cy="182880"/>
           </a:xfrm>
           <a:prstGeom prst="rect">
@@ -12466,7 +12466,7 @@
         </p:nvSpPr>
         <p:spPr>
           <a:xfrm>
-            <a:off x="566928" y="3127248"/>
+            <a:off x="566928" y="3310128"/>
             <a:ext cx="6428232" cy="7315"/>
           </a:xfrm>
           <a:prstGeom prst="rect">
@@ -12486,7 +12486,7 @@
         </p:nvSpPr>
         <p:spPr>
           <a:xfrm>
-            <a:off x="566928" y="3236976"/>
+            <a:off x="566928" y="3419856"/>
             <a:ext cx="1524762" cy="658368"/>
           </a:xfrm>
           <a:prstGeom prst="rect">
@@ -12511,7 +12511,7 @@
         </p:nvSpPr>
         <p:spPr>
           <a:xfrm>
-            <a:off x="566928" y="3236976"/>
+            <a:off x="566928" y="3419856"/>
             <a:ext cx="1524762" cy="36576"/>
           </a:xfrm>
           <a:prstGeom prst="rect">
@@ -12531,7 +12531,7 @@
         </p:nvSpPr>
         <p:spPr>
           <a:xfrm>
-            <a:off x="676656" y="3310128"/>
+            <a:off x="676656" y="3493008"/>
             <a:ext cx="1305306" cy="164592"/>
           </a:xfrm>
           <a:prstGeom prst="rect">
@@ -12570,7 +12570,7 @@
         </p:nvSpPr>
         <p:spPr>
           <a:xfrm>
-            <a:off x="676656" y="3493008"/>
+            <a:off x="676656" y="3675888"/>
             <a:ext cx="1305306" cy="365760"/>
           </a:xfrm>
           <a:prstGeom prst="rect">
@@ -12612,7 +12612,7 @@
         </p:nvSpPr>
         <p:spPr>
           <a:xfrm>
-            <a:off x="2201418" y="3236976"/>
+            <a:off x="2201418" y="3419856"/>
             <a:ext cx="1524762" cy="658368"/>
           </a:xfrm>
           <a:prstGeom prst="rect">
@@ -12637,7 +12637,7 @@
         </p:nvSpPr>
         <p:spPr>
           <a:xfrm>
-            <a:off x="2201418" y="3236976"/>
+            <a:off x="2201418" y="3419856"/>
             <a:ext cx="1524762" cy="36576"/>
           </a:xfrm>
           <a:prstGeom prst="rect">
@@ -12657,7 +12657,7 @@
         </p:nvSpPr>
         <p:spPr>
           <a:xfrm>
-            <a:off x="2311146" y="3310128"/>
+            <a:off x="2311146" y="3493008"/>
             <a:ext cx="1305306" cy="164592"/>
           </a:xfrm>
           <a:prstGeom prst="rect">
@@ -12696,7 +12696,7 @@
         </p:nvSpPr>
         <p:spPr>
           <a:xfrm>
-            <a:off x="2311146" y="3493008"/>
+            <a:off x="2311146" y="3675888"/>
             <a:ext cx="1305306" cy="365760"/>
           </a:xfrm>
           <a:prstGeom prst="rect">
@@ -12738,7 +12738,7 @@
         </p:nvSpPr>
         <p:spPr>
           <a:xfrm>
-            <a:off x="3835908" y="3236976"/>
+            <a:off x="3835908" y="3419856"/>
             <a:ext cx="1524762" cy="658368"/>
           </a:xfrm>
           <a:prstGeom prst="rect">
@@ -12763,7 +12763,7 @@
         </p:nvSpPr>
         <p:spPr>
           <a:xfrm>
-            <a:off x="3835908" y="3236976"/>
+            <a:off x="3835908" y="3419856"/>
             <a:ext cx="1524762" cy="36576"/>
           </a:xfrm>
           <a:prstGeom prst="rect">
@@ -12783,7 +12783,7 @@
         </p:nvSpPr>
         <p:spPr>
           <a:xfrm>
-            <a:off x="3945636" y="3310128"/>
+            <a:off x="3945636" y="3493008"/>
             <a:ext cx="1305306" cy="164592"/>
           </a:xfrm>
           <a:prstGeom prst="rect">
@@ -12822,7 +12822,7 @@
         </p:nvSpPr>
         <p:spPr>
           <a:xfrm>
-            <a:off x="3945636" y="3493008"/>
+            <a:off x="3945636" y="3675888"/>
             <a:ext cx="1305306" cy="365760"/>
           </a:xfrm>
           <a:prstGeom prst="rect">
@@ -12864,7 +12864,7 @@
         </p:nvSpPr>
         <p:spPr>
           <a:xfrm>
-            <a:off x="5470398" y="3236976"/>
+            <a:off x="5470398" y="3419856"/>
             <a:ext cx="1524762" cy="658368"/>
           </a:xfrm>
           <a:prstGeom prst="rect">
@@ -12889,7 +12889,7 @@
         </p:nvSpPr>
         <p:spPr>
           <a:xfrm>
-            <a:off x="5470398" y="3236976"/>
+            <a:off x="5470398" y="3419856"/>
             <a:ext cx="1524762" cy="36576"/>
           </a:xfrm>
           <a:prstGeom prst="rect">
@@ -12909,7 +12909,7 @@
         </p:nvSpPr>
         <p:spPr>
           <a:xfrm>
-            <a:off x="5580126" y="3310128"/>
+            <a:off x="5580126" y="3493008"/>
             <a:ext cx="1305306" cy="164592"/>
           </a:xfrm>
           <a:prstGeom prst="rect">
@@ -12948,7 +12948,7 @@
         </p:nvSpPr>
         <p:spPr>
           <a:xfrm>
-            <a:off x="5580126" y="3493008"/>
+            <a:off x="5580126" y="3675888"/>
             <a:ext cx="1305306" cy="365760"/>
           </a:xfrm>
           <a:prstGeom prst="rect">
@@ -12990,7 +12990,7 @@
         </p:nvSpPr>
         <p:spPr>
           <a:xfrm>
-            <a:off x="566928" y="4023360"/>
+            <a:off x="566928" y="4206240"/>
             <a:ext cx="6428232" cy="182880"/>
           </a:xfrm>
           <a:prstGeom prst="rect">
@@ -13029,7 +13029,7 @@
         </p:nvSpPr>
         <p:spPr>
           <a:xfrm>
-            <a:off x="566928" y="4206240"/>
+            <a:off x="566928" y="4389120"/>
             <a:ext cx="6428232" cy="7315"/>
           </a:xfrm>
           <a:prstGeom prst="rect">
@@ -13049,7 +13049,7 @@
         </p:nvSpPr>
         <p:spPr>
           <a:xfrm>
-            <a:off x="566928" y="4315968"/>
+            <a:off x="566928" y="4498848"/>
             <a:ext cx="1511046" cy="1207008"/>
           </a:xfrm>
           <a:prstGeom prst="rect">
@@ -13082,7 +13082,7 @@
         </p:blipFill>
         <p:spPr>
           <a:xfrm>
-            <a:off x="694944" y="4443984"/>
+            <a:off x="694944" y="4626864"/>
             <a:ext cx="402336" cy="402336"/>
           </a:xfrm>
           <a:prstGeom prst="rect">
@@ -13098,7 +13098,7 @@
         </p:nvSpPr>
         <p:spPr>
           <a:xfrm>
-            <a:off x="1170432" y="4462272"/>
+            <a:off x="1170432" y="4645152"/>
             <a:ext cx="816102" cy="182880"/>
           </a:xfrm>
           <a:prstGeom prst="rect">
@@ -13137,7 +13137,7 @@
         </p:nvSpPr>
         <p:spPr>
           <a:xfrm>
-            <a:off x="1529334" y="4389120"/>
+            <a:off x="1529334" y="4572000"/>
             <a:ext cx="475488" cy="128016"/>
           </a:xfrm>
           <a:prstGeom prst="rect">
@@ -13176,7 +13176,7 @@
         </p:nvSpPr>
         <p:spPr>
           <a:xfrm>
-            <a:off x="1170432" y="4636008"/>
+            <a:off x="1170432" y="4818888"/>
             <a:ext cx="816102" cy="146304"/>
           </a:xfrm>
           <a:prstGeom prst="rect">
@@ -13215,7 +13215,7 @@
         </p:nvSpPr>
         <p:spPr>
           <a:xfrm>
-            <a:off x="694944" y="4919472"/>
+            <a:off x="694944" y="5102352"/>
             <a:ext cx="1255014" cy="548640"/>
           </a:xfrm>
           <a:prstGeom prst="rect">
@@ -13257,7 +13257,7 @@
         </p:nvSpPr>
         <p:spPr>
           <a:xfrm>
-            <a:off x="2205990" y="4315968"/>
+            <a:off x="2205990" y="4498848"/>
             <a:ext cx="1511046" cy="1207008"/>
           </a:xfrm>
           <a:prstGeom prst="rect">
@@ -13290,7 +13290,7 @@
         </p:blipFill>
         <p:spPr>
           <a:xfrm>
-            <a:off x="2334006" y="4443984"/>
+            <a:off x="2334006" y="4626864"/>
             <a:ext cx="402336" cy="402336"/>
           </a:xfrm>
           <a:prstGeom prst="rect">
@@ -13306,7 +13306,7 @@
         </p:nvSpPr>
         <p:spPr>
           <a:xfrm>
-            <a:off x="2809494" y="4462272"/>
+            <a:off x="2809494" y="4645152"/>
             <a:ext cx="816102" cy="182880"/>
           </a:xfrm>
           <a:prstGeom prst="rect">
@@ -13345,34 +13345,34 @@
         </p:nvSpPr>
         <p:spPr>
           <a:xfrm>
-            <a:off x="3168396" y="4389120"/>
-            <a:ext cx="475488" cy="128016"/>
-          </a:xfrm>
-          <a:prstGeom prst="rect">
-            <a:avLst/>
-          </a:prstGeom>
-          <a:noFill/>
-          <a:ln/>
-        </p:spPr>
-        <p:txBody>
-          <a:bodyPr wrap="square" lIns="0" tIns="0" rIns="0" bIns="0" rtlCol="0" anchor="ctr"/>
-          <a:lstStyle/>
-          <a:p>
-            <a:pPr algn="r" indent="0" marL="0">
-              <a:buNone/>
-            </a:pPr>
-            <a:r>
-              <a:rPr lang="en-US" sz="560" b="1" spc="100" kern="0" dirty="0">
-                <a:solidFill>
-                  <a:srgbClr val="6E6E6E"/>
-                </a:solidFill>
-                <a:latin typeface="Arial" pitchFamily="34" charset="0"/>
-                <a:ea typeface="Arial" pitchFamily="34" charset="-122"/>
-                <a:cs typeface="Arial" pitchFamily="34" charset="-120"/>
-              </a:rPr>
-              <a:t>PILOT</a:t>
-            </a:r>
-            <a:endParaRPr lang="en-US" sz="560" dirty="0"/>
+            <a:off x="2809494" y="4818888"/>
+            <a:ext cx="816102" cy="146304"/>
+          </a:xfrm>
+          <a:prstGeom prst="rect">
+            <a:avLst/>
+          </a:prstGeom>
+          <a:noFill/>
+          <a:ln/>
+        </p:spPr>
+        <p:txBody>
+          <a:bodyPr wrap="square" lIns="0" tIns="0" rIns="0" bIns="0" rtlCol="0" anchor="ctr"/>
+          <a:lstStyle/>
+          <a:p>
+            <a:pPr algn="l" indent="0" marL="0">
+              <a:buNone/>
+            </a:pPr>
+            <a:r>
+              <a:rPr lang="en-US" sz="600" spc="100" kern="0" dirty="0">
+                <a:solidFill>
+                  <a:srgbClr val="000000"/>
+                </a:solidFill>
+                <a:latin typeface="Arial" pitchFamily="34" charset="0"/>
+                <a:ea typeface="Arial" pitchFamily="34" charset="-122"/>
+                <a:cs typeface="Arial" pitchFamily="34" charset="-120"/>
+              </a:rPr>
+              <a:t>STRUCTURE</a:t>
+            </a:r>
+            <a:endParaRPr lang="en-US" sz="600" dirty="0"/>
           </a:p>
         </p:txBody>
       </p:sp>
@@ -13384,46 +13384,7 @@
         </p:nvSpPr>
         <p:spPr>
           <a:xfrm>
-            <a:off x="2809494" y="4636008"/>
-            <a:ext cx="816102" cy="146304"/>
-          </a:xfrm>
-          <a:prstGeom prst="rect">
-            <a:avLst/>
-          </a:prstGeom>
-          <a:noFill/>
-          <a:ln/>
-        </p:spPr>
-        <p:txBody>
-          <a:bodyPr wrap="square" lIns="0" tIns="0" rIns="0" bIns="0" rtlCol="0" anchor="ctr"/>
-          <a:lstStyle/>
-          <a:p>
-            <a:pPr algn="l" indent="0" marL="0">
-              <a:buNone/>
-            </a:pPr>
-            <a:r>
-              <a:rPr lang="en-US" sz="600" spc="100" kern="0" dirty="0">
-                <a:solidFill>
-                  <a:srgbClr val="000000"/>
-                </a:solidFill>
-                <a:latin typeface="Arial" pitchFamily="34" charset="0"/>
-                <a:ea typeface="Arial" pitchFamily="34" charset="-122"/>
-                <a:cs typeface="Arial" pitchFamily="34" charset="-120"/>
-              </a:rPr>
-              <a:t>STRUCTURE</a:t>
-            </a:r>
-            <a:endParaRPr lang="en-US" sz="600" dirty="0"/>
-          </a:p>
-        </p:txBody>
-      </p:sp>
-      <p:sp>
-        <p:nvSpPr>
-          <p:cNvPr id="43" name="Text 39"/>
-          <p:cNvSpPr/>
-          <p:nvPr/>
-        </p:nvSpPr>
-        <p:spPr>
-          <a:xfrm>
-            <a:off x="2334006" y="4919472"/>
+            <a:off x="2334006" y="5102352"/>
             <a:ext cx="1255014" cy="548640"/>
           </a:xfrm>
           <a:prstGeom prst="rect">
@@ -13459,13 +13420,13 @@
       </p:sp>
       <p:sp>
         <p:nvSpPr>
-          <p:cNvPr id="44" name="Shape 40"/>
-          <p:cNvSpPr/>
-          <p:nvPr/>
-        </p:nvSpPr>
-        <p:spPr>
-          <a:xfrm>
-            <a:off x="3845052" y="4315968"/>
+          <p:cNvPr id="43" name="Shape 39"/>
+          <p:cNvSpPr/>
+          <p:nvPr/>
+        </p:nvSpPr>
+        <p:spPr>
+          <a:xfrm>
+            <a:off x="3845052" y="4498848"/>
             <a:ext cx="1511046" cy="1207008"/>
           </a:xfrm>
           <a:prstGeom prst="rect">
@@ -13484,7 +13445,7 @@
       </p:sp>
       <p:pic>
         <p:nvPicPr>
-          <p:cNvPr id="45" name="Image 2" descr="preencoded.png">    </p:cNvPr>
+          <p:cNvPr id="44" name="Image 2" descr="preencoded.png">    </p:cNvPr>
           <p:cNvPicPr>
             <a:picLocks noChangeAspect="1"/>
           </p:cNvPicPr>
@@ -13498,7 +13459,7 @@
         </p:blipFill>
         <p:spPr>
           <a:xfrm>
-            <a:off x="3973068" y="4443984"/>
+            <a:off x="3973068" y="4626864"/>
             <a:ext cx="402336" cy="402336"/>
           </a:xfrm>
           <a:prstGeom prst="rect">
@@ -13508,40 +13469,79 @@
       </p:pic>
       <p:sp>
         <p:nvSpPr>
+          <p:cNvPr id="45" name="Text 40"/>
+          <p:cNvSpPr/>
+          <p:nvPr/>
+        </p:nvSpPr>
+        <p:spPr>
+          <a:xfrm>
+            <a:off x="4448556" y="4645152"/>
+            <a:ext cx="816102" cy="182880"/>
+          </a:xfrm>
+          <a:prstGeom prst="rect">
+            <a:avLst/>
+          </a:prstGeom>
+          <a:noFill/>
+          <a:ln/>
+        </p:spPr>
+        <p:txBody>
+          <a:bodyPr wrap="square" lIns="0" tIns="0" rIns="0" bIns="0" rtlCol="0" anchor="ctr"/>
+          <a:lstStyle/>
+          <a:p>
+            <a:pPr algn="l" indent="0" marL="0">
+              <a:buNone/>
+            </a:pPr>
+            <a:r>
+              <a:rPr lang="en-US" sz="800" b="1" spc="60" kern="0" dirty="0">
+                <a:solidFill>
+                  <a:srgbClr val="1A1A1A"/>
+                </a:solidFill>
+                <a:latin typeface="Arial" pitchFamily="34" charset="0"/>
+                <a:ea typeface="Arial" pitchFamily="34" charset="-122"/>
+                <a:cs typeface="Arial" pitchFamily="34" charset="-120"/>
+              </a:rPr>
+              <a:t>POLICY</a:t>
+            </a:r>
+            <a:endParaRPr lang="en-US" sz="800" dirty="0"/>
+          </a:p>
+        </p:txBody>
+      </p:sp>
+      <p:sp>
+        <p:nvSpPr>
           <p:cNvPr id="46" name="Text 41"/>
           <p:cNvSpPr/>
           <p:nvPr/>
         </p:nvSpPr>
         <p:spPr>
           <a:xfrm>
-            <a:off x="4448556" y="4462272"/>
-            <a:ext cx="816102" cy="182880"/>
-          </a:xfrm>
-          <a:prstGeom prst="rect">
-            <a:avLst/>
-          </a:prstGeom>
-          <a:noFill/>
-          <a:ln/>
-        </p:spPr>
-        <p:txBody>
-          <a:bodyPr wrap="square" lIns="0" tIns="0" rIns="0" bIns="0" rtlCol="0" anchor="ctr"/>
-          <a:lstStyle/>
-          <a:p>
-            <a:pPr algn="l" indent="0" marL="0">
-              <a:buNone/>
-            </a:pPr>
-            <a:r>
-              <a:rPr lang="en-US" sz="800" b="1" spc="60" kern="0" dirty="0">
-                <a:solidFill>
-                  <a:srgbClr val="1A1A1A"/>
-                </a:solidFill>
-                <a:latin typeface="Arial" pitchFamily="34" charset="0"/>
-                <a:ea typeface="Arial" pitchFamily="34" charset="-122"/>
-                <a:cs typeface="Arial" pitchFamily="34" charset="-120"/>
-              </a:rPr>
-              <a:t>POLICY</a:t>
-            </a:r>
-            <a:endParaRPr lang="en-US" sz="800" dirty="0"/>
+            <a:off x="4448556" y="4818888"/>
+            <a:ext cx="816102" cy="146304"/>
+          </a:xfrm>
+          <a:prstGeom prst="rect">
+            <a:avLst/>
+          </a:prstGeom>
+          <a:noFill/>
+          <a:ln/>
+        </p:spPr>
+        <p:txBody>
+          <a:bodyPr wrap="square" lIns="0" tIns="0" rIns="0" bIns="0" rtlCol="0" anchor="ctr"/>
+          <a:lstStyle/>
+          <a:p>
+            <a:pPr algn="l" indent="0" marL="0">
+              <a:buNone/>
+            </a:pPr>
+            <a:r>
+              <a:rPr lang="en-US" sz="600" spc="100" kern="0" dirty="0">
+                <a:solidFill>
+                  <a:srgbClr val="000000"/>
+                </a:solidFill>
+                <a:latin typeface="Arial" pitchFamily="34" charset="0"/>
+                <a:ea typeface="Arial" pitchFamily="34" charset="-122"/>
+                <a:cs typeface="Arial" pitchFamily="34" charset="-120"/>
+              </a:rPr>
+              <a:t>STRUCTURE</a:t>
+            </a:r>
+            <a:endParaRPr lang="en-US" sz="600" dirty="0"/>
           </a:p>
         </p:txBody>
       </p:sp>
@@ -13553,46 +13553,7 @@
         </p:nvSpPr>
         <p:spPr>
           <a:xfrm>
-            <a:off x="4448556" y="4636008"/>
-            <a:ext cx="816102" cy="146304"/>
-          </a:xfrm>
-          <a:prstGeom prst="rect">
-            <a:avLst/>
-          </a:prstGeom>
-          <a:noFill/>
-          <a:ln/>
-        </p:spPr>
-        <p:txBody>
-          <a:bodyPr wrap="square" lIns="0" tIns="0" rIns="0" bIns="0" rtlCol="0" anchor="ctr"/>
-          <a:lstStyle/>
-          <a:p>
-            <a:pPr algn="l" indent="0" marL="0">
-              <a:buNone/>
-            </a:pPr>
-            <a:r>
-              <a:rPr lang="en-US" sz="600" spc="100" kern="0" dirty="0">
-                <a:solidFill>
-                  <a:srgbClr val="000000"/>
-                </a:solidFill>
-                <a:latin typeface="Arial" pitchFamily="34" charset="0"/>
-                <a:ea typeface="Arial" pitchFamily="34" charset="-122"/>
-                <a:cs typeface="Arial" pitchFamily="34" charset="-120"/>
-              </a:rPr>
-              <a:t>STRUCTURE</a:t>
-            </a:r>
-            <a:endParaRPr lang="en-US" sz="600" dirty="0"/>
-          </a:p>
-        </p:txBody>
-      </p:sp>
-      <p:sp>
-        <p:nvSpPr>
-          <p:cNvPr id="48" name="Text 43"/>
-          <p:cNvSpPr/>
-          <p:nvPr/>
-        </p:nvSpPr>
-        <p:spPr>
-          <a:xfrm>
-            <a:off x="3973068" y="4919472"/>
+            <a:off x="3973068" y="5102352"/>
             <a:ext cx="1255014" cy="548640"/>
           </a:xfrm>
           <a:prstGeom prst="rect">
@@ -13628,13 +13589,13 @@
       </p:sp>
       <p:sp>
         <p:nvSpPr>
-          <p:cNvPr id="49" name="Shape 44"/>
-          <p:cNvSpPr/>
-          <p:nvPr/>
-        </p:nvSpPr>
-        <p:spPr>
-          <a:xfrm>
-            <a:off x="5484114" y="4315968"/>
+          <p:cNvPr id="48" name="Shape 43"/>
+          <p:cNvSpPr/>
+          <p:nvPr/>
+        </p:nvSpPr>
+        <p:spPr>
+          <a:xfrm>
+            <a:off x="5484114" y="4498848"/>
             <a:ext cx="1511046" cy="1207008"/>
           </a:xfrm>
           <a:prstGeom prst="rect">
@@ -13653,7 +13614,7 @@
       </p:sp>
       <p:pic>
         <p:nvPicPr>
-          <p:cNvPr id="50" name="Image 3" descr="preencoded.png">    </p:cNvPr>
+          <p:cNvPr id="49" name="Image 3" descr="preencoded.png">    </p:cNvPr>
           <p:cNvPicPr>
             <a:picLocks noChangeAspect="1"/>
           </p:cNvPicPr>
@@ -13667,7 +13628,7 @@
         </p:blipFill>
         <p:spPr>
           <a:xfrm>
-            <a:off x="5612130" y="4443984"/>
+            <a:off x="5612130" y="4626864"/>
             <a:ext cx="402336" cy="402336"/>
           </a:xfrm>
           <a:prstGeom prst="rect">
@@ -13677,40 +13638,79 @@
       </p:pic>
       <p:sp>
         <p:nvSpPr>
+          <p:cNvPr id="50" name="Text 44"/>
+          <p:cNvSpPr/>
+          <p:nvPr/>
+        </p:nvSpPr>
+        <p:spPr>
+          <a:xfrm>
+            <a:off x="6087618" y="4645152"/>
+            <a:ext cx="816102" cy="182880"/>
+          </a:xfrm>
+          <a:prstGeom prst="rect">
+            <a:avLst/>
+          </a:prstGeom>
+          <a:noFill/>
+          <a:ln/>
+        </p:spPr>
+        <p:txBody>
+          <a:bodyPr wrap="square" lIns="0" tIns="0" rIns="0" bIns="0" rtlCol="0" anchor="ctr"/>
+          <a:lstStyle/>
+          <a:p>
+            <a:pPr algn="l" indent="0" marL="0">
+              <a:buNone/>
+            </a:pPr>
+            <a:r>
+              <a:rPr lang="en-US" sz="800" b="1" spc="60" kern="0" dirty="0">
+                <a:solidFill>
+                  <a:srgbClr val="1A1A1A"/>
+                </a:solidFill>
+                <a:latin typeface="Arial" pitchFamily="34" charset="0"/>
+                <a:ea typeface="Arial" pitchFamily="34" charset="-122"/>
+                <a:cs typeface="Arial" pitchFamily="34" charset="-120"/>
+              </a:rPr>
+              <a:t>GOVERNANCE</a:t>
+            </a:r>
+            <a:endParaRPr lang="en-US" sz="800" dirty="0"/>
+          </a:p>
+        </p:txBody>
+      </p:sp>
+      <p:sp>
+        <p:nvSpPr>
           <p:cNvPr id="51" name="Text 45"/>
           <p:cNvSpPr/>
           <p:nvPr/>
         </p:nvSpPr>
         <p:spPr>
           <a:xfrm>
-            <a:off x="6087618" y="4462272"/>
-            <a:ext cx="816102" cy="182880"/>
-          </a:xfrm>
-          <a:prstGeom prst="rect">
-            <a:avLst/>
-          </a:prstGeom>
-          <a:noFill/>
-          <a:ln/>
-        </p:spPr>
-        <p:txBody>
-          <a:bodyPr wrap="square" lIns="0" tIns="0" rIns="0" bIns="0" rtlCol="0" anchor="ctr"/>
-          <a:lstStyle/>
-          <a:p>
-            <a:pPr algn="l" indent="0" marL="0">
-              <a:buNone/>
-            </a:pPr>
-            <a:r>
-              <a:rPr lang="en-US" sz="800" b="1" spc="60" kern="0" dirty="0">
-                <a:solidFill>
-                  <a:srgbClr val="1A1A1A"/>
-                </a:solidFill>
-                <a:latin typeface="Arial" pitchFamily="34" charset="0"/>
-                <a:ea typeface="Arial" pitchFamily="34" charset="-122"/>
-                <a:cs typeface="Arial" pitchFamily="34" charset="-120"/>
-              </a:rPr>
-              <a:t>GOVERNANCE</a:t>
-            </a:r>
-            <a:endParaRPr lang="en-US" sz="800" dirty="0"/>
+            <a:off x="6446520" y="4572000"/>
+            <a:ext cx="475488" cy="128016"/>
+          </a:xfrm>
+          <a:prstGeom prst="rect">
+            <a:avLst/>
+          </a:prstGeom>
+          <a:noFill/>
+          <a:ln/>
+        </p:spPr>
+        <p:txBody>
+          <a:bodyPr wrap="square" lIns="0" tIns="0" rIns="0" bIns="0" rtlCol="0" anchor="ctr"/>
+          <a:lstStyle/>
+          <a:p>
+            <a:pPr algn="r" indent="0" marL="0">
+              <a:buNone/>
+            </a:pPr>
+            <a:r>
+              <a:rPr lang="en-US" sz="560" b="1" spc="100" kern="0" dirty="0">
+                <a:solidFill>
+                  <a:srgbClr val="6E6E6E"/>
+                </a:solidFill>
+                <a:latin typeface="Arial" pitchFamily="34" charset="0"/>
+                <a:ea typeface="Arial" pitchFamily="34" charset="-122"/>
+                <a:cs typeface="Arial" pitchFamily="34" charset="-120"/>
+              </a:rPr>
+              <a:t>PILOT</a:t>
+            </a:r>
+            <a:endParaRPr lang="en-US" sz="560" dirty="0"/>
           </a:p>
         </p:txBody>
       </p:sp>
@@ -13722,7 +13722,7 @@
         </p:nvSpPr>
         <p:spPr>
           <a:xfrm>
-            <a:off x="6087618" y="4636008"/>
+            <a:off x="6087618" y="4818888"/>
             <a:ext cx="816102" cy="146304"/>
           </a:xfrm>
           <a:prstGeom prst="rect">
@@ -13761,7 +13761,7 @@
         </p:nvSpPr>
         <p:spPr>
           <a:xfrm>
-            <a:off x="5612130" y="4919472"/>
+            <a:off x="5612130" y="5102352"/>
             <a:ext cx="1255014" cy="548640"/>
           </a:xfrm>
           <a:prstGeom prst="rect">
@@ -13803,7 +13803,7 @@
         </p:nvSpPr>
         <p:spPr>
           <a:xfrm>
-            <a:off x="566928" y="5650992"/>
+            <a:off x="566928" y="5833872"/>
             <a:ext cx="1511046" cy="1207008"/>
           </a:xfrm>
           <a:prstGeom prst="rect">
@@ -13836,7 +13836,7 @@
         </p:blipFill>
         <p:spPr>
           <a:xfrm>
-            <a:off x="694944" y="5779008"/>
+            <a:off x="694944" y="5961888"/>
             <a:ext cx="402336" cy="402336"/>
           </a:xfrm>
           <a:prstGeom prst="rect">
@@ -13852,7 +13852,7 @@
         </p:nvSpPr>
         <p:spPr>
           <a:xfrm>
-            <a:off x="1170432" y="5797296"/>
+            <a:off x="1170432" y="5980176"/>
             <a:ext cx="816102" cy="182880"/>
           </a:xfrm>
           <a:prstGeom prst="rect">
@@ -13891,7 +13891,7 @@
         </p:nvSpPr>
         <p:spPr>
           <a:xfrm>
-            <a:off x="1529334" y="5724144"/>
+            <a:off x="1529334" y="5907024"/>
             <a:ext cx="475488" cy="128016"/>
           </a:xfrm>
           <a:prstGeom prst="rect">
@@ -13930,7 +13930,7 @@
         </p:nvSpPr>
         <p:spPr>
           <a:xfrm>
-            <a:off x="1170432" y="5971032"/>
+            <a:off x="1170432" y="6153912"/>
             <a:ext cx="816102" cy="146304"/>
           </a:xfrm>
           <a:prstGeom prst="rect">
@@ -13969,7 +13969,7 @@
         </p:nvSpPr>
         <p:spPr>
           <a:xfrm>
-            <a:off x="694944" y="6254496"/>
+            <a:off x="694944" y="6437376"/>
             <a:ext cx="1255014" cy="548640"/>
           </a:xfrm>
           <a:prstGeom prst="rect">
@@ -14011,7 +14011,7 @@
         </p:nvSpPr>
         <p:spPr>
           <a:xfrm>
-            <a:off x="2205990" y="5650992"/>
+            <a:off x="2205990" y="5833872"/>
             <a:ext cx="1511046" cy="1207008"/>
           </a:xfrm>
           <a:prstGeom prst="rect">
@@ -14044,7 +14044,7 @@
         </p:blipFill>
         <p:spPr>
           <a:xfrm>
-            <a:off x="2334006" y="5779008"/>
+            <a:off x="2334006" y="5961888"/>
             <a:ext cx="402336" cy="402336"/>
           </a:xfrm>
           <a:prstGeom prst="rect">
@@ -14060,7 +14060,7 @@
         </p:nvSpPr>
         <p:spPr>
           <a:xfrm>
-            <a:off x="2809494" y="5797296"/>
+            <a:off x="2809494" y="5980176"/>
             <a:ext cx="816102" cy="182880"/>
           </a:xfrm>
           <a:prstGeom prst="rect">
@@ -14099,7 +14099,7 @@
         </p:nvSpPr>
         <p:spPr>
           <a:xfrm>
-            <a:off x="2809494" y="5971032"/>
+            <a:off x="2809494" y="6153912"/>
             <a:ext cx="816102" cy="146304"/>
           </a:xfrm>
           <a:prstGeom prst="rect">
@@ -14138,7 +14138,7 @@
         </p:nvSpPr>
         <p:spPr>
           <a:xfrm>
-            <a:off x="2334006" y="6254496"/>
+            <a:off x="2334006" y="6437376"/>
             <a:ext cx="1255014" cy="548640"/>
           </a:xfrm>
           <a:prstGeom prst="rect">
@@ -14180,7 +14180,7 @@
         </p:nvSpPr>
         <p:spPr>
           <a:xfrm>
-            <a:off x="3845052" y="5650992"/>
+            <a:off x="3845052" y="5833872"/>
             <a:ext cx="1511046" cy="1207008"/>
           </a:xfrm>
           <a:prstGeom prst="rect">
@@ -14213,7 +14213,7 @@
         </p:blipFill>
         <p:spPr>
           <a:xfrm>
-            <a:off x="3973068" y="5779008"/>
+            <a:off x="3973068" y="5961888"/>
             <a:ext cx="402336" cy="402336"/>
           </a:xfrm>
           <a:prstGeom prst="rect">
@@ -14229,7 +14229,7 @@
         </p:nvSpPr>
         <p:spPr>
           <a:xfrm>
-            <a:off x="4448556" y="5797296"/>
+            <a:off x="4448556" y="5980176"/>
             <a:ext cx="816102" cy="182880"/>
           </a:xfrm>
           <a:prstGeom prst="rect">
@@ -14268,7 +14268,7 @@
         </p:nvSpPr>
         <p:spPr>
           <a:xfrm>
-            <a:off x="4807458" y="5724144"/>
+            <a:off x="4807458" y="5907024"/>
             <a:ext cx="475488" cy="128016"/>
           </a:xfrm>
           <a:prstGeom prst="rect">
@@ -14307,7 +14307,7 @@
         </p:nvSpPr>
         <p:spPr>
           <a:xfrm>
-            <a:off x="4448556" y="5971032"/>
+            <a:off x="4448556" y="6153912"/>
             <a:ext cx="816102" cy="146304"/>
           </a:xfrm>
           <a:prstGeom prst="rect">
@@ -14346,7 +14346,7 @@
         </p:nvSpPr>
         <p:spPr>
           <a:xfrm>
-            <a:off x="3973068" y="6254496"/>
+            <a:off x="3973068" y="6437376"/>
             <a:ext cx="1255014" cy="548640"/>
           </a:xfrm>
           <a:prstGeom prst="rect">
@@ -14388,7 +14388,7 @@
         </p:nvSpPr>
         <p:spPr>
           <a:xfrm>
-            <a:off x="5484114" y="5650992"/>
+            <a:off x="5484114" y="5833872"/>
             <a:ext cx="1511046" cy="1207008"/>
           </a:xfrm>
           <a:prstGeom prst="rect">
@@ -14421,7 +14421,7 @@
         </p:blipFill>
         <p:spPr>
           <a:xfrm>
-            <a:off x="5612130" y="5779008"/>
+            <a:off x="5612130" y="5961888"/>
             <a:ext cx="402336" cy="402336"/>
           </a:xfrm>
           <a:prstGeom prst="rect">
@@ -14437,7 +14437,7 @@
         </p:nvSpPr>
         <p:spPr>
           <a:xfrm>
-            <a:off x="6087618" y="5797296"/>
+            <a:off x="6087618" y="5980176"/>
             <a:ext cx="816102" cy="182880"/>
           </a:xfrm>
           <a:prstGeom prst="rect">
@@ -14476,7 +14476,7 @@
         </p:nvSpPr>
         <p:spPr>
           <a:xfrm>
-            <a:off x="6087618" y="5971032"/>
+            <a:off x="6087618" y="6153912"/>
             <a:ext cx="816102" cy="146304"/>
           </a:xfrm>
           <a:prstGeom prst="rect">
@@ -14515,7 +14515,7 @@
         </p:nvSpPr>
         <p:spPr>
           <a:xfrm>
-            <a:off x="5612130" y="6254496"/>
+            <a:off x="5612130" y="6437376"/>
             <a:ext cx="1255014" cy="548640"/>
           </a:xfrm>
           <a:prstGeom prst="rect">
@@ -14557,7 +14557,7 @@
         </p:nvSpPr>
         <p:spPr>
           <a:xfrm>
-            <a:off x="566928" y="6986016"/>
+            <a:off x="566928" y="7168896"/>
             <a:ext cx="1511046" cy="1207008"/>
           </a:xfrm>
           <a:prstGeom prst="rect">
@@ -14590,7 +14590,7 @@
         </p:blipFill>
         <p:spPr>
           <a:xfrm>
-            <a:off x="694944" y="7114032"/>
+            <a:off x="694944" y="7296912"/>
             <a:ext cx="402336" cy="402336"/>
           </a:xfrm>
           <a:prstGeom prst="rect">
@@ -14606,7 +14606,7 @@
         </p:nvSpPr>
         <p:spPr>
           <a:xfrm>
-            <a:off x="1170432" y="7132320"/>
+            <a:off x="1170432" y="7315200"/>
             <a:ext cx="816102" cy="182880"/>
           </a:xfrm>
           <a:prstGeom prst="rect">
@@ -14645,7 +14645,7 @@
         </p:nvSpPr>
         <p:spPr>
           <a:xfrm>
-            <a:off x="1529334" y="7059168"/>
+            <a:off x="1529334" y="7242048"/>
             <a:ext cx="475488" cy="128016"/>
           </a:xfrm>
           <a:prstGeom prst="rect">
@@ -14684,7 +14684,7 @@
         </p:nvSpPr>
         <p:spPr>
           <a:xfrm>
-            <a:off x="1170432" y="7306056"/>
+            <a:off x="1170432" y="7488936"/>
             <a:ext cx="816102" cy="146304"/>
           </a:xfrm>
           <a:prstGeom prst="rect">
@@ -14723,7 +14723,7 @@
         </p:nvSpPr>
         <p:spPr>
           <a:xfrm>
-            <a:off x="694944" y="7589520"/>
+            <a:off x="694944" y="7772400"/>
             <a:ext cx="1255014" cy="548640"/>
           </a:xfrm>
           <a:prstGeom prst="rect">
@@ -14765,7 +14765,7 @@
         </p:nvSpPr>
         <p:spPr>
           <a:xfrm>
-            <a:off x="2205990" y="6986016"/>
+            <a:off x="2205990" y="7168896"/>
             <a:ext cx="1511046" cy="1207008"/>
           </a:xfrm>
           <a:prstGeom prst="rect">
@@ -14798,7 +14798,7 @@
         </p:blipFill>
         <p:spPr>
           <a:xfrm>
-            <a:off x="2334006" y="7114032"/>
+            <a:off x="2334006" y="7296912"/>
             <a:ext cx="402336" cy="402336"/>
           </a:xfrm>
           <a:prstGeom prst="rect">
@@ -14814,7 +14814,7 @@
         </p:nvSpPr>
         <p:spPr>
           <a:xfrm>
-            <a:off x="2809494" y="7132320"/>
+            <a:off x="2809494" y="7315200"/>
             <a:ext cx="816102" cy="182880"/>
           </a:xfrm>
           <a:prstGeom prst="rect">
@@ -14853,7 +14853,7 @@
         </p:nvSpPr>
         <p:spPr>
           <a:xfrm>
-            <a:off x="2809494" y="7306056"/>
+            <a:off x="2809494" y="7488936"/>
             <a:ext cx="816102" cy="146304"/>
           </a:xfrm>
           <a:prstGeom prst="rect">
@@ -14892,7 +14892,7 @@
         </p:nvSpPr>
         <p:spPr>
           <a:xfrm>
-            <a:off x="2334006" y="7589520"/>
+            <a:off x="2334006" y="7772400"/>
             <a:ext cx="1255014" cy="548640"/>
           </a:xfrm>
           <a:prstGeom prst="rect">
@@ -14934,7 +14934,7 @@
         </p:nvSpPr>
         <p:spPr>
           <a:xfrm>
-            <a:off x="3845052" y="6986016"/>
+            <a:off x="3845052" y="7168896"/>
             <a:ext cx="1511046" cy="1207008"/>
           </a:xfrm>
           <a:prstGeom prst="rect">
@@ -14967,7 +14967,7 @@
         </p:blipFill>
         <p:spPr>
           <a:xfrm>
-            <a:off x="3973068" y="7114032"/>
+            <a:off x="3973068" y="7296912"/>
             <a:ext cx="402336" cy="402336"/>
           </a:xfrm>
           <a:prstGeom prst="rect">
@@ -14983,7 +14983,7 @@
         </p:nvSpPr>
         <p:spPr>
           <a:xfrm>
-            <a:off x="4448556" y="7132320"/>
+            <a:off x="4448556" y="7315200"/>
             <a:ext cx="816102" cy="182880"/>
           </a:xfrm>
           <a:prstGeom prst="rect">
@@ -15022,7 +15022,7 @@
         </p:nvSpPr>
         <p:spPr>
           <a:xfrm>
-            <a:off x="4807458" y="7059168"/>
+            <a:off x="4807458" y="7242048"/>
             <a:ext cx="475488" cy="128016"/>
           </a:xfrm>
           <a:prstGeom prst="rect">
@@ -15061,7 +15061,7 @@
         </p:nvSpPr>
         <p:spPr>
           <a:xfrm>
-            <a:off x="4448556" y="7306056"/>
+            <a:off x="4448556" y="7488936"/>
             <a:ext cx="816102" cy="146304"/>
           </a:xfrm>
           <a:prstGeom prst="rect">
@@ -15100,7 +15100,7 @@
         </p:nvSpPr>
         <p:spPr>
           <a:xfrm>
-            <a:off x="3973068" y="7589520"/>
+            <a:off x="3973068" y="7772400"/>
             <a:ext cx="1255014" cy="548640"/>
           </a:xfrm>
           <a:prstGeom prst="rect">
@@ -15142,7 +15142,7 @@
         </p:nvSpPr>
         <p:spPr>
           <a:xfrm>
-            <a:off x="5484114" y="6986016"/>
+            <a:off x="5484114" y="7168896"/>
             <a:ext cx="1511046" cy="1207008"/>
           </a:xfrm>
           <a:prstGeom prst="rect">
@@ -15175,7 +15175,7 @@
         </p:blipFill>
         <p:spPr>
           <a:xfrm>
-            <a:off x="5612130" y="7114032"/>
+            <a:off x="5612130" y="7296912"/>
             <a:ext cx="402336" cy="402336"/>
           </a:xfrm>
           <a:prstGeom prst="rect">
@@ -15191,7 +15191,7 @@
         </p:nvSpPr>
         <p:spPr>
           <a:xfrm>
-            <a:off x="6087618" y="7132320"/>
+            <a:off x="6087618" y="7315200"/>
             <a:ext cx="816102" cy="182880"/>
           </a:xfrm>
           <a:prstGeom prst="rect">
@@ -15230,7 +15230,7 @@
         </p:nvSpPr>
         <p:spPr>
           <a:xfrm>
-            <a:off x="6087618" y="7306056"/>
+            <a:off x="6087618" y="7488936"/>
             <a:ext cx="816102" cy="146304"/>
           </a:xfrm>
           <a:prstGeom prst="rect">
@@ -15269,7 +15269,7 @@
         </p:nvSpPr>
         <p:spPr>
           <a:xfrm>
-            <a:off x="5612130" y="7589520"/>
+            <a:off x="5612130" y="7772400"/>
             <a:ext cx="1255014" cy="548640"/>
           </a:xfrm>
           <a:prstGeom prst="rect">
@@ -15311,7 +15311,7 @@
         </p:nvSpPr>
         <p:spPr>
           <a:xfrm>
-            <a:off x="566928" y="8467344"/>
+            <a:off x="566928" y="8650224"/>
             <a:ext cx="6428232" cy="182880"/>
           </a:xfrm>
           <a:prstGeom prst="rect">
@@ -15350,7 +15350,7 @@
         </p:nvSpPr>
         <p:spPr>
           <a:xfrm>
-            <a:off x="566928" y="8650224"/>
+            <a:off x="566928" y="8833104"/>
             <a:ext cx="6428232" cy="7315"/>
           </a:xfrm>
           <a:prstGeom prst="rect">
@@ -15370,7 +15370,7 @@
         </p:nvSpPr>
         <p:spPr>
           <a:xfrm>
-            <a:off x="566928" y="8759952"/>
+            <a:off x="566928" y="8942832"/>
             <a:ext cx="6428232" cy="859536"/>
           </a:xfrm>
           <a:prstGeom prst="rect">
@@ -15403,7 +15403,7 @@
         </p:blipFill>
         <p:spPr>
           <a:xfrm>
-            <a:off x="786384" y="8979408"/>
+            <a:off x="786384" y="9162288"/>
             <a:ext cx="420624" cy="420624"/>
           </a:xfrm>
           <a:prstGeom prst="rect">
@@ -15427,7 +15427,7 @@
         </p:blipFill>
         <p:spPr>
           <a:xfrm>
-            <a:off x="1389888" y="9034272"/>
+            <a:off x="1389888" y="9217152"/>
             <a:ext cx="310896" cy="310896"/>
           </a:xfrm>
           <a:prstGeom prst="rect">
@@ -15451,7 +15451,7 @@
         </p:blipFill>
         <p:spPr>
           <a:xfrm>
-            <a:off x="1883664" y="9070848"/>
+            <a:off x="1883664" y="9253728"/>
             <a:ext cx="237744" cy="237744"/>
           </a:xfrm>
           <a:prstGeom prst="rect">
@@ -15475,7 +15475,7 @@
         </p:blipFill>
         <p:spPr>
           <a:xfrm>
-            <a:off x="2304288" y="9102852"/>
+            <a:off x="2304288" y="9285732"/>
             <a:ext cx="173736" cy="173736"/>
           </a:xfrm>
           <a:prstGeom prst="rect">
@@ -15491,7 +15491,7 @@
         </p:nvSpPr>
         <p:spPr>
           <a:xfrm>
-            <a:off x="786384" y="9436608"/>
+            <a:off x="786384" y="9619488"/>
             <a:ext cx="1828800" cy="146304"/>
           </a:xfrm>
           <a:prstGeom prst="rect">
@@ -15530,7 +15530,7 @@
         </p:nvSpPr>
         <p:spPr>
           <a:xfrm>
-            <a:off x="2852928" y="8869680"/>
+            <a:off x="2852928" y="9052560"/>
             <a:ext cx="12802" cy="640080"/>
           </a:xfrm>
           <a:prstGeom prst="rect">
@@ -15558,7 +15558,7 @@
         </p:blipFill>
         <p:spPr>
           <a:xfrm>
-            <a:off x="3090672" y="8979408"/>
+            <a:off x="3090672" y="9162288"/>
             <a:ext cx="310896" cy="310896"/>
           </a:xfrm>
           <a:prstGeom prst="rect">
@@ -15582,7 +15582,7 @@
         </p:blipFill>
         <p:spPr>
           <a:xfrm>
-            <a:off x="3547872" y="8979408"/>
+            <a:off x="3547872" y="9162288"/>
             <a:ext cx="310896" cy="310896"/>
           </a:xfrm>
           <a:prstGeom prst="rect">
@@ -15606,7 +15606,7 @@
         </p:blipFill>
         <p:spPr>
           <a:xfrm>
-            <a:off x="4005072" y="8979408"/>
+            <a:off x="4005072" y="9162288"/>
             <a:ext cx="310896" cy="310896"/>
           </a:xfrm>
           <a:prstGeom prst="rect">
@@ -15630,7 +15630,7 @@
         </p:blipFill>
         <p:spPr>
           <a:xfrm>
-            <a:off x="4462272" y="8979408"/>
+            <a:off x="4462272" y="9162288"/>
             <a:ext cx="310896" cy="310896"/>
           </a:xfrm>
           <a:prstGeom prst="rect">
@@ -15646,7 +15646,7 @@
         </p:nvSpPr>
         <p:spPr>
           <a:xfrm>
-            <a:off x="3090672" y="9363456"/>
+            <a:off x="3090672" y="9546336"/>
             <a:ext cx="1828800" cy="146304"/>
           </a:xfrm>
           <a:prstGeom prst="rect">
@@ -15685,7 +15685,7 @@
         </p:nvSpPr>
         <p:spPr>
           <a:xfrm>
-            <a:off x="5047488" y="8869680"/>
+            <a:off x="5047488" y="9052560"/>
             <a:ext cx="12802" cy="640080"/>
           </a:xfrm>
           <a:prstGeom prst="rect">
@@ -15713,7 +15713,7 @@
         </p:blipFill>
         <p:spPr>
           <a:xfrm>
-            <a:off x="5285232" y="8979408"/>
+            <a:off x="5285232" y="9162288"/>
             <a:ext cx="310896" cy="310896"/>
           </a:xfrm>
           <a:prstGeom prst="rect">
@@ -15737,7 +15737,7 @@
         </p:blipFill>
         <p:spPr>
           <a:xfrm>
-            <a:off x="5742432" y="8979408"/>
+            <a:off x="5742432" y="9162288"/>
             <a:ext cx="310896" cy="310896"/>
           </a:xfrm>
           <a:prstGeom prst="rect">
@@ -15761,7 +15761,7 @@
         </p:blipFill>
         <p:spPr>
           <a:xfrm>
-            <a:off x="6199632" y="8979408"/>
+            <a:off x="6199632" y="9162288"/>
             <a:ext cx="310896" cy="310896"/>
           </a:xfrm>
           <a:prstGeom prst="rect">
@@ -15785,7 +15785,7 @@
         </p:blipFill>
         <p:spPr>
           <a:xfrm>
-            <a:off x="6656832" y="8979408"/>
+            <a:off x="6656832" y="9162288"/>
             <a:ext cx="310896" cy="310896"/>
           </a:xfrm>
           <a:prstGeom prst="rect">
@@ -15801,7 +15801,7 @@
         </p:nvSpPr>
         <p:spPr>
           <a:xfrm>
-            <a:off x="5285232" y="9363456"/>
+            <a:off x="5285232" y="9546336"/>
             <a:ext cx="1828800" cy="146304"/>
           </a:xfrm>
           <a:prstGeom prst="rect">
@@ -16076,7 +16076,7 @@
                 <a:ea typeface="Arial" pitchFamily="34" charset="-122"/>
                 <a:cs typeface="Arial" pitchFamily="34" charset="-120"/>
               </a:rPr>
-              <a:t>NZ ARMY   COMBAT MINDSET   VISUAL IDENTITY SYSTEM</a:t>
+              <a:t>COMBAT MINDSET   VISUAL IDENTITY</a:t>
             </a:r>
             <a:endParaRPr lang="en-US" sz="600" dirty="0"/>
           </a:p>
@@ -16115,7 +16115,7 @@
                 <a:ea typeface="Arial" pitchFamily="34" charset="-122"/>
                 <a:cs typeface="Arial" pitchFamily="34" charset="-120"/>
               </a:rPr>
-              <a:t>DRAFT FOR REVIEW   |   V0.2   |   AUGUST 2026</a:t>
+              <a:t>DRAFT V0.3   |   AUGUST 2026</a:t>
             </a:r>
             <a:endParaRPr lang="en-US" sz="600" dirty="0"/>
           </a:p>
@@ -16728,7 +16728,7 @@
                 <a:ea typeface="Arial" pitchFamily="34" charset="-122"/>
                 <a:cs typeface="Arial" pitchFamily="34" charset="-120"/>
               </a:rPr>
-              <a:t>Decision and risk only. Never a surface, never a heading, never a fill.</a:t>
+              <a:t>Decision nodes, the action notation, and defined threshold states. Otherwise risk is carried by the broken datum.</a:t>
             </a:r>
             <a:endParaRPr lang="en-US" sz="780" dirty="0"/>
           </a:p>
@@ -17899,7 +17899,7 @@
                 <a:ea typeface="Arial" pitchFamily="34" charset="-122"/>
                 <a:cs typeface="Arial" pitchFamily="34" charset="-120"/>
               </a:rPr>
-              <a:t>NZ ARMY   COMBAT MINDSET   VISUAL IDENTITY SYSTEM</a:t>
+              <a:t>COMBAT MINDSET   VISUAL IDENTITY</a:t>
             </a:r>
             <a:endParaRPr lang="en-US" sz="600" dirty="0"/>
           </a:p>
@@ -17938,7 +17938,7 @@
                 <a:ea typeface="Arial" pitchFamily="34" charset="-122"/>
                 <a:cs typeface="Arial" pitchFamily="34" charset="-120"/>
               </a:rPr>
-              <a:t>DRAFT FOR REVIEW   |   V0.2   |   AUGUST 2026</a:t>
+              <a:t>DRAFT V0.3   |   AUGUST 2026</a:t>
             </a:r>
             <a:endParaRPr lang="en-US" sz="600" dirty="0"/>
           </a:p>
@@ -18012,7 +18012,7 @@
         <p:spPr>
           <a:xfrm>
             <a:off x="566928" y="2066544"/>
-            <a:ext cx="6428232" cy="749808"/>
+            <a:ext cx="6428232" cy="914400"/>
           </a:xfrm>
           <a:prstGeom prst="rect">
             <a:avLst/>
@@ -18039,7 +18039,7 @@
                 <a:ea typeface="Arial" pitchFamily="34" charset="-122"/>
                 <a:cs typeface="Arial" pitchFamily="34" charset="-120"/>
               </a:rPr>
-              <a:t>Every piece of Combat Mindset content is presented in the same component: a notation mark, a type label, an identifier, a title, and a status line. The component is identical in print, in a slide, in a repository and on a phone; only its scale changes. Identifiers separate content type, item and version, because a number that means two things eventually means nothing. The scheme shown is illustrative: allocation authority, and its relationship to existing Army and NZDF reference series, is resolved at step 03 before any identifier is issued.</a:t>
+              <a:t>Every piece of Combat Mindset content is presented in the same component: a notation mark, a type label, an identifier, a title, and a status line. The component is identical in print, in a slide, in a repository and on a phone; only its scale changes. Identifiers separate content type, item and version, because a number that means two things eventually means nothing. The scheme shown is illustrative: allocation authority, and its relationship to existing Army and NZDF reference series, is resolved at step 03 before any identifier is issued. The pilot also tests whether some types are better held as status or relationship metadata than as primary types.</a:t>
             </a:r>
             <a:endParaRPr lang="en-US" sz="900" dirty="0"/>
           </a:p>
@@ -18053,7 +18053,7 @@
         </p:nvSpPr>
         <p:spPr>
           <a:xfrm>
-            <a:off x="566928" y="2926080"/>
+            <a:off x="566928" y="3072384"/>
             <a:ext cx="6428232" cy="914400"/>
           </a:xfrm>
           <a:prstGeom prst="rect">
@@ -18078,7 +18078,7 @@
         </p:nvSpPr>
         <p:spPr>
           <a:xfrm>
-            <a:off x="566928" y="2926080"/>
+            <a:off x="566928" y="3072384"/>
             <a:ext cx="45720" cy="914400"/>
           </a:xfrm>
           <a:prstGeom prst="rect">
@@ -18106,7 +18106,7 @@
         </p:blipFill>
         <p:spPr>
           <a:xfrm>
-            <a:off x="786384" y="3127248"/>
+            <a:off x="786384" y="3273552"/>
             <a:ext cx="457200" cy="457200"/>
           </a:xfrm>
           <a:prstGeom prst="rect">
@@ -18122,7 +18122,7 @@
         </p:nvSpPr>
         <p:spPr>
           <a:xfrm>
-            <a:off x="1371600" y="3108960"/>
+            <a:off x="1371600" y="3255264"/>
             <a:ext cx="1828800" cy="182880"/>
           </a:xfrm>
           <a:prstGeom prst="rect">
@@ -18161,7 +18161,7 @@
         </p:nvSpPr>
         <p:spPr>
           <a:xfrm>
-            <a:off x="1371600" y="3273552"/>
+            <a:off x="1371600" y="3419856"/>
             <a:ext cx="1828800" cy="182880"/>
           </a:xfrm>
           <a:prstGeom prst="rect">
@@ -18200,7 +18200,7 @@
         </p:nvSpPr>
         <p:spPr>
           <a:xfrm>
-            <a:off x="3310128" y="3108960"/>
+            <a:off x="3310128" y="3255264"/>
             <a:ext cx="3319272" cy="237744"/>
           </a:xfrm>
           <a:prstGeom prst="rect">
@@ -18239,7 +18239,7 @@
         </p:nvSpPr>
         <p:spPr>
           <a:xfrm>
-            <a:off x="3310128" y="3364992"/>
+            <a:off x="3310128" y="3511296"/>
             <a:ext cx="3319272" cy="182880"/>
           </a:xfrm>
           <a:prstGeom prst="rect">
@@ -18278,8 +18278,8 @@
         </p:nvSpPr>
         <p:spPr>
           <a:xfrm>
-            <a:off x="786384" y="3858768"/>
-            <a:ext cx="1828800" cy="164592"/>
+            <a:off x="786384" y="4005072"/>
+            <a:ext cx="1828800" cy="146304"/>
           </a:xfrm>
           <a:prstGeom prst="rect">
             <a:avLst/>
@@ -18317,8 +18317,8 @@
         </p:nvSpPr>
         <p:spPr>
           <a:xfrm>
-            <a:off x="1371600" y="3858768"/>
-            <a:ext cx="1828800" cy="164592"/>
+            <a:off x="1371600" y="4005072"/>
+            <a:ext cx="1828800" cy="146304"/>
           </a:xfrm>
           <a:prstGeom prst="rect">
             <a:avLst/>
@@ -18356,8 +18356,8 @@
         </p:nvSpPr>
         <p:spPr>
           <a:xfrm>
-            <a:off x="3310128" y="3858768"/>
-            <a:ext cx="1828800" cy="164592"/>
+            <a:off x="3310128" y="4005072"/>
+            <a:ext cx="1828800" cy="146304"/>
           </a:xfrm>
           <a:prstGeom prst="rect">
             <a:avLst/>
@@ -18395,7 +18395,7 @@
         </p:nvSpPr>
         <p:spPr>
           <a:xfrm>
-            <a:off x="566928" y="4206240"/>
+            <a:off x="566928" y="4224528"/>
             <a:ext cx="6428232" cy="182880"/>
           </a:xfrm>
           <a:prstGeom prst="rect">
@@ -18434,7 +18434,7 @@
         </p:nvSpPr>
         <p:spPr>
           <a:xfrm>
-            <a:off x="566928" y="4389120"/>
+            <a:off x="566928" y="4407408"/>
             <a:ext cx="6428232" cy="7315"/>
           </a:xfrm>
           <a:prstGeom prst="rect">
@@ -18454,7 +18454,7 @@
         </p:nvSpPr>
         <p:spPr>
           <a:xfrm>
-            <a:off x="566928" y="4498848"/>
+            <a:off x="566928" y="4517136"/>
             <a:ext cx="6428232" cy="420624"/>
           </a:xfrm>
           <a:prstGeom prst="rect">
@@ -18474,7 +18474,7 @@
         </p:nvSpPr>
         <p:spPr>
           <a:xfrm>
-            <a:off x="566928" y="4498848"/>
+            <a:off x="566928" y="4517136"/>
             <a:ext cx="36576" cy="420624"/>
           </a:xfrm>
           <a:prstGeom prst="rect">
@@ -18502,7 +18502,7 @@
         </p:blipFill>
         <p:spPr>
           <a:xfrm>
-            <a:off x="731520" y="4599432"/>
+            <a:off x="731520" y="4617720"/>
             <a:ext cx="256032" cy="256032"/>
           </a:xfrm>
           <a:prstGeom prst="rect">
@@ -18518,7 +18518,7 @@
         </p:nvSpPr>
         <p:spPr>
           <a:xfrm>
-            <a:off x="1097280" y="4498848"/>
+            <a:off x="1097280" y="4517136"/>
             <a:ext cx="1371600" cy="420624"/>
           </a:xfrm>
           <a:prstGeom prst="rect">
@@ -18557,7 +18557,7 @@
         </p:nvSpPr>
         <p:spPr>
           <a:xfrm>
-            <a:off x="2450592" y="4498848"/>
+            <a:off x="2450592" y="4517136"/>
             <a:ext cx="914400" cy="420624"/>
           </a:xfrm>
           <a:prstGeom prst="rect">
@@ -18596,7 +18596,7 @@
         </p:nvSpPr>
         <p:spPr>
           <a:xfrm>
-            <a:off x="3310128" y="4498848"/>
+            <a:off x="3310128" y="4517136"/>
             <a:ext cx="969264" cy="420624"/>
           </a:xfrm>
           <a:prstGeom prst="rect">
@@ -18635,7 +18635,7 @@
         </p:nvSpPr>
         <p:spPr>
           <a:xfrm>
-            <a:off x="4352544" y="4498848"/>
+            <a:off x="4352544" y="4517136"/>
             <a:ext cx="2551176" cy="420624"/>
           </a:xfrm>
           <a:prstGeom prst="rect">
@@ -18674,7 +18674,7 @@
         </p:nvSpPr>
         <p:spPr>
           <a:xfrm>
-            <a:off x="566928" y="4956048"/>
+            <a:off x="566928" y="4974336"/>
             <a:ext cx="6428232" cy="420624"/>
           </a:xfrm>
           <a:prstGeom prst="rect">
@@ -18694,7 +18694,7 @@
         </p:nvSpPr>
         <p:spPr>
           <a:xfrm>
-            <a:off x="566928" y="4956048"/>
+            <a:off x="566928" y="4974336"/>
             <a:ext cx="36576" cy="420624"/>
           </a:xfrm>
           <a:prstGeom prst="rect">
@@ -18722,7 +18722,7 @@
         </p:blipFill>
         <p:spPr>
           <a:xfrm>
-            <a:off x="731520" y="5056632"/>
+            <a:off x="731520" y="5074920"/>
             <a:ext cx="256032" cy="256032"/>
           </a:xfrm>
           <a:prstGeom prst="rect">
@@ -18738,7 +18738,7 @@
         </p:nvSpPr>
         <p:spPr>
           <a:xfrm>
-            <a:off x="1097280" y="4956048"/>
+            <a:off x="1097280" y="4974336"/>
             <a:ext cx="1371600" cy="420624"/>
           </a:xfrm>
           <a:prstGeom prst="rect">
@@ -18777,7 +18777,7 @@
         </p:nvSpPr>
         <p:spPr>
           <a:xfrm>
-            <a:off x="2450592" y="4956048"/>
+            <a:off x="2450592" y="4974336"/>
             <a:ext cx="914400" cy="420624"/>
           </a:xfrm>
           <a:prstGeom prst="rect">
@@ -18816,7 +18816,7 @@
         </p:nvSpPr>
         <p:spPr>
           <a:xfrm>
-            <a:off x="3310128" y="4956048"/>
+            <a:off x="3310128" y="4974336"/>
             <a:ext cx="969264" cy="420624"/>
           </a:xfrm>
           <a:prstGeom prst="rect">
@@ -18855,7 +18855,7 @@
         </p:nvSpPr>
         <p:spPr>
           <a:xfrm>
-            <a:off x="4352544" y="4956048"/>
+            <a:off x="4352544" y="4974336"/>
             <a:ext cx="2551176" cy="420624"/>
           </a:xfrm>
           <a:prstGeom prst="rect">
@@ -18894,7 +18894,7 @@
         </p:nvSpPr>
         <p:spPr>
           <a:xfrm>
-            <a:off x="566928" y="5413248"/>
+            <a:off x="566928" y="5431536"/>
             <a:ext cx="6428232" cy="420624"/>
           </a:xfrm>
           <a:prstGeom prst="rect">
@@ -18914,7 +18914,7 @@
         </p:nvSpPr>
         <p:spPr>
           <a:xfrm>
-            <a:off x="566928" y="5413248"/>
+            <a:off x="566928" y="5431536"/>
             <a:ext cx="36576" cy="420624"/>
           </a:xfrm>
           <a:prstGeom prst="rect">
@@ -18942,7 +18942,7 @@
         </p:blipFill>
         <p:spPr>
           <a:xfrm>
-            <a:off x="731520" y="5513832"/>
+            <a:off x="731520" y="5532120"/>
             <a:ext cx="256032" cy="256032"/>
           </a:xfrm>
           <a:prstGeom prst="rect">
@@ -18958,7 +18958,7 @@
         </p:nvSpPr>
         <p:spPr>
           <a:xfrm>
-            <a:off x="1097280" y="5413248"/>
+            <a:off x="1097280" y="5431536"/>
             <a:ext cx="1371600" cy="420624"/>
           </a:xfrm>
           <a:prstGeom prst="rect">
@@ -18997,7 +18997,7 @@
         </p:nvSpPr>
         <p:spPr>
           <a:xfrm>
-            <a:off x="2450592" y="5413248"/>
+            <a:off x="2450592" y="5431536"/>
             <a:ext cx="914400" cy="420624"/>
           </a:xfrm>
           <a:prstGeom prst="rect">
@@ -19036,7 +19036,7 @@
         </p:nvSpPr>
         <p:spPr>
           <a:xfrm>
-            <a:off x="3310128" y="5413248"/>
+            <a:off x="3310128" y="5431536"/>
             <a:ext cx="969264" cy="420624"/>
           </a:xfrm>
           <a:prstGeom prst="rect">
@@ -19075,7 +19075,7 @@
         </p:nvSpPr>
         <p:spPr>
           <a:xfrm>
-            <a:off x="4352544" y="5413248"/>
+            <a:off x="4352544" y="5431536"/>
             <a:ext cx="2551176" cy="420624"/>
           </a:xfrm>
           <a:prstGeom prst="rect">
@@ -19114,7 +19114,7 @@
         </p:nvSpPr>
         <p:spPr>
           <a:xfrm>
-            <a:off x="566928" y="5870448"/>
+            <a:off x="566928" y="5888736"/>
             <a:ext cx="6428232" cy="420624"/>
           </a:xfrm>
           <a:prstGeom prst="rect">
@@ -19134,7 +19134,7 @@
         </p:nvSpPr>
         <p:spPr>
           <a:xfrm>
-            <a:off x="566928" y="5870448"/>
+            <a:off x="566928" y="5888736"/>
             <a:ext cx="36576" cy="420624"/>
           </a:xfrm>
           <a:prstGeom prst="rect">
@@ -19162,7 +19162,7 @@
         </p:blipFill>
         <p:spPr>
           <a:xfrm>
-            <a:off x="731520" y="5971032"/>
+            <a:off x="731520" y="5989320"/>
             <a:ext cx="256032" cy="256032"/>
           </a:xfrm>
           <a:prstGeom prst="rect">
@@ -19178,7 +19178,7 @@
         </p:nvSpPr>
         <p:spPr>
           <a:xfrm>
-            <a:off x="1097280" y="5870448"/>
+            <a:off x="1097280" y="5888736"/>
             <a:ext cx="1371600" cy="420624"/>
           </a:xfrm>
           <a:prstGeom prst="rect">
@@ -19217,7 +19217,7 @@
         </p:nvSpPr>
         <p:spPr>
           <a:xfrm>
-            <a:off x="2450592" y="5870448"/>
+            <a:off x="2450592" y="5888736"/>
             <a:ext cx="914400" cy="420624"/>
           </a:xfrm>
           <a:prstGeom prst="rect">
@@ -19256,7 +19256,7 @@
         </p:nvSpPr>
         <p:spPr>
           <a:xfrm>
-            <a:off x="3310128" y="5870448"/>
+            <a:off x="3310128" y="5888736"/>
             <a:ext cx="969264" cy="420624"/>
           </a:xfrm>
           <a:prstGeom prst="rect">
@@ -19295,7 +19295,7 @@
         </p:nvSpPr>
         <p:spPr>
           <a:xfrm>
-            <a:off x="4352544" y="5870448"/>
+            <a:off x="4352544" y="5888736"/>
             <a:ext cx="2551176" cy="420624"/>
           </a:xfrm>
           <a:prstGeom prst="rect">
@@ -19334,7 +19334,7 @@
         </p:nvSpPr>
         <p:spPr>
           <a:xfrm>
-            <a:off x="566928" y="6327648"/>
+            <a:off x="566928" y="6345936"/>
             <a:ext cx="6428232" cy="420624"/>
           </a:xfrm>
           <a:prstGeom prst="rect">
@@ -19354,7 +19354,7 @@
         </p:nvSpPr>
         <p:spPr>
           <a:xfrm>
-            <a:off x="566928" y="6327648"/>
+            <a:off x="566928" y="6345936"/>
             <a:ext cx="36576" cy="420624"/>
           </a:xfrm>
           <a:prstGeom prst="rect">
@@ -19382,7 +19382,7 @@
         </p:blipFill>
         <p:spPr>
           <a:xfrm>
-            <a:off x="731520" y="6428232"/>
+            <a:off x="731520" y="6446520"/>
             <a:ext cx="256032" cy="256032"/>
           </a:xfrm>
           <a:prstGeom prst="rect">
@@ -19398,7 +19398,7 @@
         </p:nvSpPr>
         <p:spPr>
           <a:xfrm>
-            <a:off x="1097280" y="6327648"/>
+            <a:off x="1097280" y="6345936"/>
             <a:ext cx="1371600" cy="420624"/>
           </a:xfrm>
           <a:prstGeom prst="rect">
@@ -19437,7 +19437,7 @@
         </p:nvSpPr>
         <p:spPr>
           <a:xfrm>
-            <a:off x="2450592" y="6327648"/>
+            <a:off x="2450592" y="6345936"/>
             <a:ext cx="914400" cy="420624"/>
           </a:xfrm>
           <a:prstGeom prst="rect">
@@ -19476,7 +19476,7 @@
         </p:nvSpPr>
         <p:spPr>
           <a:xfrm>
-            <a:off x="3310128" y="6327648"/>
+            <a:off x="3310128" y="6345936"/>
             <a:ext cx="969264" cy="420624"/>
           </a:xfrm>
           <a:prstGeom prst="rect">
@@ -19515,7 +19515,7 @@
         </p:nvSpPr>
         <p:spPr>
           <a:xfrm>
-            <a:off x="4352544" y="6327648"/>
+            <a:off x="4352544" y="6345936"/>
             <a:ext cx="2551176" cy="420624"/>
           </a:xfrm>
           <a:prstGeom prst="rect">
@@ -19554,7 +19554,7 @@
         </p:nvSpPr>
         <p:spPr>
           <a:xfrm>
-            <a:off x="566928" y="6784848"/>
+            <a:off x="566928" y="6803136"/>
             <a:ext cx="6428232" cy="420624"/>
           </a:xfrm>
           <a:prstGeom prst="rect">
@@ -19574,7 +19574,7 @@
         </p:nvSpPr>
         <p:spPr>
           <a:xfrm>
-            <a:off x="566928" y="6784848"/>
+            <a:off x="566928" y="6803136"/>
             <a:ext cx="36576" cy="420624"/>
           </a:xfrm>
           <a:prstGeom prst="rect">
@@ -19602,7 +19602,7 @@
         </p:blipFill>
         <p:spPr>
           <a:xfrm>
-            <a:off x="731520" y="6885432"/>
+            <a:off x="731520" y="6903720"/>
             <a:ext cx="256032" cy="256032"/>
           </a:xfrm>
           <a:prstGeom prst="rect">
@@ -19618,7 +19618,7 @@
         </p:nvSpPr>
         <p:spPr>
           <a:xfrm>
-            <a:off x="1097280" y="6784848"/>
+            <a:off x="1097280" y="6803136"/>
             <a:ext cx="1371600" cy="420624"/>
           </a:xfrm>
           <a:prstGeom prst="rect">
@@ -19657,7 +19657,7 @@
         </p:nvSpPr>
         <p:spPr>
           <a:xfrm>
-            <a:off x="2450592" y="6784848"/>
+            <a:off x="2450592" y="6803136"/>
             <a:ext cx="914400" cy="420624"/>
           </a:xfrm>
           <a:prstGeom prst="rect">
@@ -19696,7 +19696,7 @@
         </p:nvSpPr>
         <p:spPr>
           <a:xfrm>
-            <a:off x="3310128" y="6784848"/>
+            <a:off x="3310128" y="6803136"/>
             <a:ext cx="969264" cy="420624"/>
           </a:xfrm>
           <a:prstGeom prst="rect">
@@ -19735,7 +19735,7 @@
         </p:nvSpPr>
         <p:spPr>
           <a:xfrm>
-            <a:off x="4352544" y="6784848"/>
+            <a:off x="4352544" y="6803136"/>
             <a:ext cx="2551176" cy="420624"/>
           </a:xfrm>
           <a:prstGeom prst="rect">
@@ -19774,7 +19774,7 @@
         </p:nvSpPr>
         <p:spPr>
           <a:xfrm>
-            <a:off x="566928" y="7242048"/>
+            <a:off x="566928" y="7260336"/>
             <a:ext cx="6428232" cy="420624"/>
           </a:xfrm>
           <a:prstGeom prst="rect">
@@ -19794,7 +19794,7 @@
         </p:nvSpPr>
         <p:spPr>
           <a:xfrm>
-            <a:off x="566928" y="7242048"/>
+            <a:off x="566928" y="7260336"/>
             <a:ext cx="36576" cy="420624"/>
           </a:xfrm>
           <a:prstGeom prst="rect">
@@ -19822,7 +19822,7 @@
         </p:blipFill>
         <p:spPr>
           <a:xfrm>
-            <a:off x="731520" y="7342632"/>
+            <a:off x="731520" y="7360920"/>
             <a:ext cx="256032" cy="256032"/>
           </a:xfrm>
           <a:prstGeom prst="rect">
@@ -19838,7 +19838,7 @@
         </p:nvSpPr>
         <p:spPr>
           <a:xfrm>
-            <a:off x="1097280" y="7242048"/>
+            <a:off x="1097280" y="7260336"/>
             <a:ext cx="1371600" cy="420624"/>
           </a:xfrm>
           <a:prstGeom prst="rect">
@@ -19877,7 +19877,7 @@
         </p:nvSpPr>
         <p:spPr>
           <a:xfrm>
-            <a:off x="2450592" y="7242048"/>
+            <a:off x="2450592" y="7260336"/>
             <a:ext cx="914400" cy="420624"/>
           </a:xfrm>
           <a:prstGeom prst="rect">
@@ -19916,7 +19916,7 @@
         </p:nvSpPr>
         <p:spPr>
           <a:xfrm>
-            <a:off x="3310128" y="7242048"/>
+            <a:off x="3310128" y="7260336"/>
             <a:ext cx="969264" cy="420624"/>
           </a:xfrm>
           <a:prstGeom prst="rect">
@@ -19955,7 +19955,7 @@
         </p:nvSpPr>
         <p:spPr>
           <a:xfrm>
-            <a:off x="4352544" y="7242048"/>
+            <a:off x="4352544" y="7260336"/>
             <a:ext cx="2551176" cy="420624"/>
           </a:xfrm>
           <a:prstGeom prst="rect">
@@ -19994,7 +19994,7 @@
         </p:nvSpPr>
         <p:spPr>
           <a:xfrm>
-            <a:off x="566928" y="7699248"/>
+            <a:off x="566928" y="7717536"/>
             <a:ext cx="6428232" cy="420624"/>
           </a:xfrm>
           <a:prstGeom prst="rect">
@@ -20014,7 +20014,7 @@
         </p:nvSpPr>
         <p:spPr>
           <a:xfrm>
-            <a:off x="566928" y="7699248"/>
+            <a:off x="566928" y="7717536"/>
             <a:ext cx="36576" cy="420624"/>
           </a:xfrm>
           <a:prstGeom prst="rect">
@@ -20042,7 +20042,7 @@
         </p:blipFill>
         <p:spPr>
           <a:xfrm>
-            <a:off x="731520" y="7799832"/>
+            <a:off x="731520" y="7818120"/>
             <a:ext cx="256032" cy="256032"/>
           </a:xfrm>
           <a:prstGeom prst="rect">
@@ -20058,7 +20058,7 @@
         </p:nvSpPr>
         <p:spPr>
           <a:xfrm>
-            <a:off x="1097280" y="7699248"/>
+            <a:off x="1097280" y="7717536"/>
             <a:ext cx="1371600" cy="420624"/>
           </a:xfrm>
           <a:prstGeom prst="rect">
@@ -20097,7 +20097,7 @@
         </p:nvSpPr>
         <p:spPr>
           <a:xfrm>
-            <a:off x="2450592" y="7699248"/>
+            <a:off x="2450592" y="7717536"/>
             <a:ext cx="914400" cy="420624"/>
           </a:xfrm>
           <a:prstGeom prst="rect">
@@ -20136,7 +20136,7 @@
         </p:nvSpPr>
         <p:spPr>
           <a:xfrm>
-            <a:off x="3310128" y="7699248"/>
+            <a:off x="3310128" y="7717536"/>
             <a:ext cx="969264" cy="420624"/>
           </a:xfrm>
           <a:prstGeom prst="rect">
@@ -20175,7 +20175,7 @@
         </p:nvSpPr>
         <p:spPr>
           <a:xfrm>
-            <a:off x="4352544" y="7699248"/>
+            <a:off x="4352544" y="7717536"/>
             <a:ext cx="2551176" cy="420624"/>
           </a:xfrm>
           <a:prstGeom prst="rect">
@@ -20214,7 +20214,7 @@
         </p:nvSpPr>
         <p:spPr>
           <a:xfrm>
-            <a:off x="566928" y="8156448"/>
+            <a:off x="566928" y="8174736"/>
             <a:ext cx="6428232" cy="420624"/>
           </a:xfrm>
           <a:prstGeom prst="rect">
@@ -20234,7 +20234,7 @@
         </p:nvSpPr>
         <p:spPr>
           <a:xfrm>
-            <a:off x="566928" y="8156448"/>
+            <a:off x="566928" y="8174736"/>
             <a:ext cx="36576" cy="420624"/>
           </a:xfrm>
           <a:prstGeom prst="rect">
@@ -20262,7 +20262,7 @@
         </p:blipFill>
         <p:spPr>
           <a:xfrm>
-            <a:off x="731520" y="8257032"/>
+            <a:off x="731520" y="8275320"/>
             <a:ext cx="256032" cy="256032"/>
           </a:xfrm>
           <a:prstGeom prst="rect">
@@ -20278,7 +20278,7 @@
         </p:nvSpPr>
         <p:spPr>
           <a:xfrm>
-            <a:off x="1097280" y="8156448"/>
+            <a:off x="1097280" y="8174736"/>
             <a:ext cx="1371600" cy="420624"/>
           </a:xfrm>
           <a:prstGeom prst="rect">
@@ -20317,7 +20317,7 @@
         </p:nvSpPr>
         <p:spPr>
           <a:xfrm>
-            <a:off x="2450592" y="8156448"/>
+            <a:off x="2450592" y="8174736"/>
             <a:ext cx="914400" cy="420624"/>
           </a:xfrm>
           <a:prstGeom prst="rect">
@@ -20356,7 +20356,7 @@
         </p:nvSpPr>
         <p:spPr>
           <a:xfrm>
-            <a:off x="3310128" y="8156448"/>
+            <a:off x="3310128" y="8174736"/>
             <a:ext cx="969264" cy="420624"/>
           </a:xfrm>
           <a:prstGeom prst="rect">
@@ -20395,7 +20395,7 @@
         </p:nvSpPr>
         <p:spPr>
           <a:xfrm>
-            <a:off x="4352544" y="8156448"/>
+            <a:off x="4352544" y="8174736"/>
             <a:ext cx="2551176" cy="420624"/>
           </a:xfrm>
           <a:prstGeom prst="rect">
@@ -20434,7 +20434,7 @@
         </p:nvSpPr>
         <p:spPr>
           <a:xfrm>
-            <a:off x="566928" y="8613648"/>
+            <a:off x="566928" y="8631936"/>
             <a:ext cx="6428232" cy="420624"/>
           </a:xfrm>
           <a:prstGeom prst="rect">
@@ -20454,7 +20454,7 @@
         </p:nvSpPr>
         <p:spPr>
           <a:xfrm>
-            <a:off x="566928" y="8613648"/>
+            <a:off x="566928" y="8631936"/>
             <a:ext cx="36576" cy="420624"/>
           </a:xfrm>
           <a:prstGeom prst="rect">
@@ -20482,7 +20482,7 @@
         </p:blipFill>
         <p:spPr>
           <a:xfrm>
-            <a:off x="731520" y="8714232"/>
+            <a:off x="731520" y="8732520"/>
             <a:ext cx="256032" cy="256032"/>
           </a:xfrm>
           <a:prstGeom prst="rect">
@@ -20498,7 +20498,7 @@
         </p:nvSpPr>
         <p:spPr>
           <a:xfrm>
-            <a:off x="1097280" y="8613648"/>
+            <a:off x="1097280" y="8631936"/>
             <a:ext cx="1371600" cy="420624"/>
           </a:xfrm>
           <a:prstGeom prst="rect">
@@ -20537,7 +20537,7 @@
         </p:nvSpPr>
         <p:spPr>
           <a:xfrm>
-            <a:off x="2450592" y="8613648"/>
+            <a:off x="2450592" y="8631936"/>
             <a:ext cx="914400" cy="420624"/>
           </a:xfrm>
           <a:prstGeom prst="rect">
@@ -20576,7 +20576,7 @@
         </p:nvSpPr>
         <p:spPr>
           <a:xfrm>
-            <a:off x="3310128" y="8613648"/>
+            <a:off x="3310128" y="8631936"/>
             <a:ext cx="969264" cy="420624"/>
           </a:xfrm>
           <a:prstGeom prst="rect">
@@ -20615,7 +20615,7 @@
         </p:nvSpPr>
         <p:spPr>
           <a:xfrm>
-            <a:off x="4352544" y="8613648"/>
+            <a:off x="4352544" y="8631936"/>
             <a:ext cx="2551176" cy="420624"/>
           </a:xfrm>
           <a:prstGeom prst="rect">
@@ -20654,7 +20654,7 @@
         </p:nvSpPr>
         <p:spPr>
           <a:xfrm>
-            <a:off x="566928" y="9070848"/>
+            <a:off x="566928" y="9089136"/>
             <a:ext cx="6428232" cy="420624"/>
           </a:xfrm>
           <a:prstGeom prst="rect">
@@ -20674,7 +20674,7 @@
         </p:nvSpPr>
         <p:spPr>
           <a:xfrm>
-            <a:off x="566928" y="9070848"/>
+            <a:off x="566928" y="9089136"/>
             <a:ext cx="36576" cy="420624"/>
           </a:xfrm>
           <a:prstGeom prst="rect">
@@ -20702,7 +20702,7 @@
         </p:blipFill>
         <p:spPr>
           <a:xfrm>
-            <a:off x="731520" y="9171432"/>
+            <a:off x="731520" y="9189720"/>
             <a:ext cx="256032" cy="256032"/>
           </a:xfrm>
           <a:prstGeom prst="rect">
@@ -20718,7 +20718,7 @@
         </p:nvSpPr>
         <p:spPr>
           <a:xfrm>
-            <a:off x="1097280" y="9070848"/>
+            <a:off x="1097280" y="9089136"/>
             <a:ext cx="1371600" cy="420624"/>
           </a:xfrm>
           <a:prstGeom prst="rect">
@@ -20757,7 +20757,7 @@
         </p:nvSpPr>
         <p:spPr>
           <a:xfrm>
-            <a:off x="2450592" y="9070848"/>
+            <a:off x="2450592" y="9089136"/>
             <a:ext cx="914400" cy="420624"/>
           </a:xfrm>
           <a:prstGeom prst="rect">
@@ -20796,7 +20796,7 @@
         </p:nvSpPr>
         <p:spPr>
           <a:xfrm>
-            <a:off x="3310128" y="9070848"/>
+            <a:off x="3310128" y="9089136"/>
             <a:ext cx="969264" cy="420624"/>
           </a:xfrm>
           <a:prstGeom prst="rect">
@@ -20835,7 +20835,7 @@
         </p:nvSpPr>
         <p:spPr>
           <a:xfrm>
-            <a:off x="4352544" y="9070848"/>
+            <a:off x="4352544" y="9089136"/>
             <a:ext cx="2551176" cy="420624"/>
           </a:xfrm>
           <a:prstGeom prst="rect">
@@ -20874,7 +20874,7 @@
         </p:nvSpPr>
         <p:spPr>
           <a:xfrm>
-            <a:off x="566928" y="9528048"/>
+            <a:off x="566928" y="9546336"/>
             <a:ext cx="6428232" cy="420624"/>
           </a:xfrm>
           <a:prstGeom prst="rect">
@@ -20894,7 +20894,7 @@
         </p:nvSpPr>
         <p:spPr>
           <a:xfrm>
-            <a:off x="566928" y="9528048"/>
+            <a:off x="566928" y="9546336"/>
             <a:ext cx="36576" cy="420624"/>
           </a:xfrm>
           <a:prstGeom prst="rect">
@@ -20922,7 +20922,7 @@
         </p:blipFill>
         <p:spPr>
           <a:xfrm>
-            <a:off x="731520" y="9628632"/>
+            <a:off x="731520" y="9646920"/>
             <a:ext cx="256032" cy="256032"/>
           </a:xfrm>
           <a:prstGeom prst="rect">
@@ -20938,7 +20938,7 @@
         </p:nvSpPr>
         <p:spPr>
           <a:xfrm>
-            <a:off x="1097280" y="9528048"/>
+            <a:off x="1097280" y="9546336"/>
             <a:ext cx="1371600" cy="420624"/>
           </a:xfrm>
           <a:prstGeom prst="rect">
@@ -20977,7 +20977,7 @@
         </p:nvSpPr>
         <p:spPr>
           <a:xfrm>
-            <a:off x="2450592" y="9528048"/>
+            <a:off x="2450592" y="9546336"/>
             <a:ext cx="914400" cy="420624"/>
           </a:xfrm>
           <a:prstGeom prst="rect">
@@ -21016,7 +21016,7 @@
         </p:nvSpPr>
         <p:spPr>
           <a:xfrm>
-            <a:off x="3310128" y="9528048"/>
+            <a:off x="3310128" y="9546336"/>
             <a:ext cx="969264" cy="420624"/>
           </a:xfrm>
           <a:prstGeom prst="rect">
@@ -21055,7 +21055,7 @@
         </p:nvSpPr>
         <p:spPr>
           <a:xfrm>
-            <a:off x="4352544" y="9528048"/>
+            <a:off x="4352544" y="9546336"/>
             <a:ext cx="2551176" cy="420624"/>
           </a:xfrm>
           <a:prstGeom prst="rect">
@@ -21330,7 +21330,7 @@
                 <a:ea typeface="Arial" pitchFamily="34" charset="-122"/>
                 <a:cs typeface="Arial" pitchFamily="34" charset="-120"/>
               </a:rPr>
-              <a:t>NZ ARMY   COMBAT MINDSET   VISUAL IDENTITY SYSTEM</a:t>
+              <a:t>COMBAT MINDSET   VISUAL IDENTITY</a:t>
             </a:r>
             <a:endParaRPr lang="en-US" sz="600" dirty="0"/>
           </a:p>
@@ -21369,7 +21369,7 @@
                 <a:ea typeface="Arial" pitchFamily="34" charset="-122"/>
                 <a:cs typeface="Arial" pitchFamily="34" charset="-120"/>
               </a:rPr>
-              <a:t>DRAFT FOR REVIEW   |   V0.2   |   AUGUST 2026</a:t>
+              <a:t>DRAFT V0.3   |   AUGUST 2026</a:t>
             </a:r>
             <a:endParaRPr lang="en-US" sz="600" dirty="0"/>
           </a:p>
@@ -23337,7 +23337,7 @@
                 <a:ea typeface="Arial" pitchFamily="34" charset="-122"/>
                 <a:cs typeface="Arial" pitchFamily="34" charset="-120"/>
               </a:rPr>
-              <a:t>NZ ARMY   COMBAT MINDSET   VISUAL IDENTITY SYSTEM</a:t>
+              <a:t>COMBAT MINDSET   VISUAL IDENTITY</a:t>
             </a:r>
             <a:endParaRPr lang="en-US" sz="600" dirty="0"/>
           </a:p>
@@ -23376,7 +23376,7 @@
                 <a:ea typeface="Arial" pitchFamily="34" charset="-122"/>
                 <a:cs typeface="Arial" pitchFamily="34" charset="-120"/>
               </a:rPr>
-              <a:t>DRAFT FOR REVIEW   |   V0.2   |   AUGUST 2026</a:t>
+              <a:t>DRAFT V0.3   |   AUGUST 2026</a:t>
             </a:r>
             <a:endParaRPr lang="en-US" sz="600" dirty="0"/>
           </a:p>
@@ -24451,7 +24451,7 @@
                 <a:ea typeface="Arial" pitchFamily="34" charset="-122"/>
                 <a:cs typeface="Arial" pitchFamily="34" charset="-120"/>
               </a:rPr>
-              <a:t>NZ ARMY   COMBAT MINDSET   VISUAL IDENTITY SYSTEM</a:t>
+              <a:t>COMBAT MINDSET   VISUAL IDENTITY</a:t>
             </a:r>
             <a:endParaRPr lang="en-US" sz="600" dirty="0"/>
           </a:p>
@@ -24490,7 +24490,7 @@
                 <a:ea typeface="Arial" pitchFamily="34" charset="-122"/>
                 <a:cs typeface="Arial" pitchFamily="34" charset="-120"/>
               </a:rPr>
-              <a:t>DRAFT FOR REVIEW   |   V0.2   |   AUGUST 2026</a:t>
+              <a:t>DRAFT V0.3   |   AUGUST 2026</a:t>
             </a:r>
             <a:endParaRPr lang="en-US" sz="600" dirty="0"/>
           </a:p>
@@ -25880,7 +25880,7 @@
                 <a:ea typeface="Arial" pitchFamily="34" charset="-122"/>
                 <a:cs typeface="Arial" pitchFamily="34" charset="-120"/>
               </a:rPr>
-              <a:t>NZ ARMY   COMBAT MINDSET   VISUAL IDENTITY SYSTEM</a:t>
+              <a:t>COMBAT MINDSET   VISUAL IDENTITY</a:t>
             </a:r>
             <a:endParaRPr lang="en-US" sz="600" dirty="0"/>
           </a:p>
@@ -25919,7 +25919,7 @@
                 <a:ea typeface="Arial" pitchFamily="34" charset="-122"/>
                 <a:cs typeface="Arial" pitchFamily="34" charset="-120"/>
               </a:rPr>
-              <a:t>DRAFT FOR REVIEW   |   V0.2   |   AUGUST 2026</a:t>
+              <a:t>DRAFT V0.3   |   AUGUST 2026</a:t>
             </a:r>
             <a:endParaRPr lang="en-US" sz="600" dirty="0"/>
           </a:p>
@@ -27547,7 +27547,7 @@
                 <a:ea typeface="Arial" pitchFamily="34" charset="-122"/>
                 <a:cs typeface="Arial" pitchFamily="34" charset="-120"/>
               </a:rPr>
-              <a:t>NZ ARMY   COMBAT MINDSET   VISUAL IDENTITY SYSTEM</a:t>
+              <a:t>COMBAT MINDSET   VISUAL IDENTITY</a:t>
             </a:r>
             <a:endParaRPr lang="en-US" sz="600" dirty="0"/>
           </a:p>
@@ -27586,7 +27586,7 @@
                 <a:ea typeface="Arial" pitchFamily="34" charset="-122"/>
                 <a:cs typeface="Arial" pitchFamily="34" charset="-120"/>
               </a:rPr>
-              <a:t>DRAFT FOR REVIEW   |   V0.2   |   AUGUST 2026</a:t>
+              <a:t>DRAFT V0.3   |   AUGUST 2026</a:t>
             </a:r>
             <a:endParaRPr lang="en-US" sz="600" dirty="0"/>
           </a:p>
@@ -29435,7 +29435,7 @@
                 <a:ea typeface="Arial" pitchFamily="34" charset="-122"/>
                 <a:cs typeface="Arial" pitchFamily="34" charset="-120"/>
               </a:rPr>
-              <a:t>NZ ARMY   COMBAT MINDSET   VISUAL IDENTITY SYSTEM</a:t>
+              <a:t>COMBAT MINDSET   VISUAL IDENTITY</a:t>
             </a:r>
             <a:endParaRPr lang="en-US" sz="600" dirty="0"/>
           </a:p>
@@ -29474,7 +29474,7 @@
                 <a:ea typeface="Arial" pitchFamily="34" charset="-122"/>
                 <a:cs typeface="Arial" pitchFamily="34" charset="-120"/>
               </a:rPr>
-              <a:t>DRAFT FOR REVIEW   |   V0.2   |   AUGUST 2026</a:t>
+              <a:t>DRAFT V0.3   |   AUGUST 2026</a:t>
             </a:r>
             <a:endParaRPr lang="en-US" sz="600" dirty="0"/>
           </a:p>
@@ -30383,7 +30383,7 @@
                 <a:ea typeface="Arial" pitchFamily="34" charset="-122"/>
                 <a:cs typeface="Arial" pitchFamily="34" charset="-120"/>
               </a:rPr>
-              <a:t>NZ ARMY   COMBAT MINDSET   VISUAL IDENTITY SYSTEM</a:t>
+              <a:t>COMBAT MINDSET   VISUAL IDENTITY</a:t>
             </a:r>
             <a:endParaRPr lang="en-US" sz="600" dirty="0"/>
           </a:p>
@@ -30422,7 +30422,7 @@
                 <a:ea typeface="Arial" pitchFamily="34" charset="-122"/>
                 <a:cs typeface="Arial" pitchFamily="34" charset="-120"/>
               </a:rPr>
-              <a:t>DRAFT FOR REVIEW   |   V0.2   |   AUGUST 2026</a:t>
+              <a:t>DRAFT V0.3   |   AUGUST 2026</a:t>
             </a:r>
             <a:endParaRPr lang="en-US" sz="600" dirty="0"/>
           </a:p>
@@ -30999,7 +30999,7 @@
                 <a:ea typeface="Arial" pitchFamily="34" charset="-122"/>
                 <a:cs typeface="Arial" pitchFamily="34" charset="-120"/>
               </a:rPr>
-              <a:t>Put the position and the specification to DPA. Expect challenge on the wordmark and on the notation family. Obtain the vector Army logo at the same time.</a:t>
+              <a:t>Put the position and the specification to DPA. Expect challenge on the title treatment, the notation family, and the derivation of the field from the Army chevron pattern. Obtain the vector Army logo at the same time.</a:t>
             </a:r>
             <a:endParaRPr lang="en-US" sz="860" dirty="0"/>
           </a:p>
@@ -31967,7 +31967,7 @@
                 <a:ea typeface="Arial" pitchFamily="34" charset="-122"/>
                 <a:cs typeface="Arial" pitchFamily="34" charset="-120"/>
               </a:rPr>
-              <a:t>NZ ARMY   COMBAT MINDSET   VISUAL IDENTITY SYSTEM</a:t>
+              <a:t>COMBAT MINDSET   VISUAL IDENTITY</a:t>
             </a:r>
             <a:endParaRPr lang="en-US" sz="600" dirty="0"/>
           </a:p>
@@ -32006,7 +32006,7 @@
                 <a:ea typeface="Arial" pitchFamily="34" charset="-122"/>
                 <a:cs typeface="Arial" pitchFamily="34" charset="-120"/>
               </a:rPr>
-              <a:t>DRAFT FOR REVIEW   |   V0.2   |   AUGUST 2026</a:t>
+              <a:t>DRAFT V0.3   |   AUGUST 2026</a:t>
             </a:r>
             <a:endParaRPr lang="en-US" sz="600" dirty="0"/>
           </a:p>
@@ -33689,7 +33689,7 @@
                 <a:ea typeface="Arial" pitchFamily="34" charset="-122"/>
                 <a:cs typeface="Arial" pitchFamily="34" charset="-120"/>
               </a:rPr>
-              <a:t>NZ ARMY   COMBAT MINDSET   VISUAL IDENTITY SYSTEM</a:t>
+              <a:t>COMBAT MINDSET   VISUAL IDENTITY</a:t>
             </a:r>
             <a:endParaRPr lang="en-US" sz="600" dirty="0"/>
           </a:p>
@@ -33728,7 +33728,7 @@
                 <a:ea typeface="Arial" pitchFamily="34" charset="-122"/>
                 <a:cs typeface="Arial" pitchFamily="34" charset="-120"/>
               </a:rPr>
-              <a:t>DRAFT FOR REVIEW   |   V0.2   |   AUGUST 2026</a:t>
+              <a:t>DRAFT V0.3   |   AUGUST 2026</a:t>
             </a:r>
             <a:endParaRPr lang="en-US" sz="600" dirty="0"/>
           </a:p>
@@ -33868,7 +33868,7 @@
                 <a:ea typeface="Arial" pitchFamily="34" charset="-122"/>
                 <a:cs typeface="Arial" pitchFamily="34" charset="-120"/>
               </a:rPr>
-              <a:t>Not launched. Not campaigned. A soldier meeting a Combat Mindset product for the first time should assume it has existed for years and that they simply had not needed it until now. Newness is a liability in an enduring capability framework.</a:t>
+              <a:t>Not launched. Not campaigned. A soldier meeting a Combat Mindset product for the first time should assume it has existed for years and that they simply had not needed it until now. Visible novelty is a liability in an enduring capability framework.</a:t>
             </a:r>
             <a:endParaRPr lang="en-US" sz="900" dirty="0"/>
           </a:p>
@@ -34372,7 +34372,7 @@
                 <a:ea typeface="Arial" pitchFamily="34" charset="-122"/>
                 <a:cs typeface="Arial" pitchFamily="34" charset="-120"/>
               </a:rPr>
-              <a:t>Motivation decays. Doctrine does not.</a:t>
+              <a:t>Motivation fades. Institutional systems endure.</a:t>
             </a:r>
             <a:endParaRPr lang="en-US" sz="800" dirty="0"/>
           </a:p>
@@ -34985,7 +34985,7 @@
                 <a:ea typeface="Arial" pitchFamily="34" charset="-122"/>
                 <a:cs typeface="Arial" pitchFamily="34" charset="-120"/>
               </a:rPr>
-              <a:t>NZ ARMY   COMBAT MINDSET   VISUAL IDENTITY SYSTEM</a:t>
+              <a:t>COMBAT MINDSET   VISUAL IDENTITY</a:t>
             </a:r>
             <a:endParaRPr lang="en-US" sz="600" dirty="0"/>
           </a:p>
@@ -35024,7 +35024,7 @@
                 <a:ea typeface="Arial" pitchFamily="34" charset="-122"/>
                 <a:cs typeface="Arial" pitchFamily="34" charset="-120"/>
               </a:rPr>
-              <a:t>DRAFT FOR REVIEW   |   V0.2   |   AUGUST 2026</a:t>
+              <a:t>DRAFT V0.3   |   AUGUST 2026</a:t>
             </a:r>
             <a:endParaRPr lang="en-US" sz="600" dirty="0"/>
           </a:p>
@@ -37135,7 +37135,7 @@
                 <a:ea typeface="Arial" pitchFamily="34" charset="-122"/>
                 <a:cs typeface="Arial" pitchFamily="34" charset="-120"/>
               </a:rPr>
-              <a:t>NZ ARMY   COMBAT MINDSET   VISUAL IDENTITY SYSTEM</a:t>
+              <a:t>COMBAT MINDSET   VISUAL IDENTITY</a:t>
             </a:r>
             <a:endParaRPr lang="en-US" sz="600" dirty="0"/>
           </a:p>
@@ -37174,7 +37174,7 @@
                 <a:ea typeface="Arial" pitchFamily="34" charset="-122"/>
                 <a:cs typeface="Arial" pitchFamily="34" charset="-120"/>
               </a:rPr>
-              <a:t>DRAFT FOR REVIEW   |   V0.2   |   AUGUST 2026</a:t>
+              <a:t>DRAFT V0.3   |   AUGUST 2026</a:t>
             </a:r>
             <a:endParaRPr lang="en-US" sz="600" dirty="0"/>
           </a:p>
@@ -38662,7 +38662,7 @@
                 <a:ea typeface="Arial" pitchFamily="34" charset="-122"/>
                 <a:cs typeface="Arial" pitchFamily="34" charset="-120"/>
               </a:rPr>
-              <a:t>NZ ARMY   COMBAT MINDSET   VISUAL IDENTITY SYSTEM</a:t>
+              <a:t>COMBAT MINDSET   VISUAL IDENTITY</a:t>
             </a:r>
             <a:endParaRPr lang="en-US" sz="600" dirty="0"/>
           </a:p>
@@ -38701,7 +38701,7 @@
                 <a:ea typeface="Arial" pitchFamily="34" charset="-122"/>
                 <a:cs typeface="Arial" pitchFamily="34" charset="-120"/>
               </a:rPr>
-              <a:t>DRAFT FOR REVIEW   |   V0.2   |   AUGUST 2026</a:t>
+              <a:t>DRAFT V0.3   |   AUGUST 2026</a:t>
             </a:r>
             <a:endParaRPr lang="en-US" sz="600" dirty="0"/>
           </a:p>
@@ -39868,7 +39868,7 @@
                 <a:ea typeface="Arial" pitchFamily="34" charset="-122"/>
                 <a:cs typeface="Arial" pitchFamily="34" charset="-120"/>
               </a:rPr>
-              <a:t>NZ ARMY   COMBAT MINDSET   VISUAL IDENTITY SYSTEM</a:t>
+              <a:t>COMBAT MINDSET   VISUAL IDENTITY</a:t>
             </a:r>
             <a:endParaRPr lang="en-US" sz="600" dirty="0"/>
           </a:p>
@@ -39907,7 +39907,7 @@
                 <a:ea typeface="Arial" pitchFamily="34" charset="-122"/>
                 <a:cs typeface="Arial" pitchFamily="34" charset="-120"/>
               </a:rPr>
-              <a:t>DRAFT FOR REVIEW   |   V0.2   |   AUGUST 2026</a:t>
+              <a:t>DRAFT V0.3   |   AUGUST 2026</a:t>
             </a:r>
             <a:endParaRPr lang="en-US" sz="600" dirty="0"/>
           </a:p>
@@ -41074,7 +41074,7 @@
                 <a:ea typeface="Arial" pitchFamily="34" charset="-122"/>
                 <a:cs typeface="Arial" pitchFamily="34" charset="-120"/>
               </a:rPr>
-              <a:t>NZ ARMY   COMBAT MINDSET   VISUAL IDENTITY SYSTEM</a:t>
+              <a:t>COMBAT MINDSET   VISUAL IDENTITY</a:t>
             </a:r>
             <a:endParaRPr lang="en-US" sz="600" dirty="0"/>
           </a:p>
@@ -41113,7 +41113,7 @@
                 <a:ea typeface="Arial" pitchFamily="34" charset="-122"/>
                 <a:cs typeface="Arial" pitchFamily="34" charset="-120"/>
               </a:rPr>
-              <a:t>DRAFT FOR REVIEW   |   V0.2   |   AUGUST 2026</a:t>
+              <a:t>DRAFT V0.3   |   AUGUST 2026</a:t>
             </a:r>
             <a:endParaRPr lang="en-US" sz="600" dirty="0"/>
           </a:p>

</xml_diff>

<commit_message>
Identity system V0.4: final consistency pass
Broaden the precedent claim to doctrine and controlled information
systems. Align page 3 with the artefact level logo rule and replace the
reference number absolute with a governed identifier. Correct the element
count to six. Restate the Concept A capability claim defensibly. Reword
the Doctrine and Product notation explanations. Narrow the gym imagery
rejection to generic shorthand. Framework browser filters now follow the
pilot set, and Interactive Doctrine becomes Controlled Content Reader.

Co-Authored-By: Claude Fable 5 <noreply@anthropic.com>
Claude-Session: https://claude.ai/code/session_01YLo1WfwUDkbwfJEF3ZNVbB
</commit_message>
<xml_diff>
--- a/output/combat-mindset-identity-system.pptx
+++ b/output/combat-mindset-identity-system.pptx
@@ -3349,7 +3349,7 @@
                 <a:ea typeface="Arial" pitchFamily="34" charset="-122"/>
                 <a:cs typeface="Arial" pitchFamily="34" charset="-120"/>
               </a:rPr>
-              <a:t>V0.3, August 2026</a:t>
+              <a:t>V0.4, August 2026</a:t>
             </a:r>
             <a:endParaRPr lang="en-US" sz="800" dirty="0"/>
           </a:p>
@@ -3638,7 +3638,7 @@
                 <a:ea typeface="Arial" pitchFamily="34" charset="-122"/>
                 <a:cs typeface="Arial" pitchFamily="34" charset="-120"/>
               </a:rPr>
-              <a:t>DRAFT V0.3   |   AUGUST 2026</a:t>
+              <a:t>DRAFT V0.4   |   AUGUST 2026</a:t>
             </a:r>
             <a:endParaRPr lang="en-US" sz="600" dirty="0"/>
           </a:p>
@@ -6671,7 +6671,7 @@
                 <a:ea typeface="Arial" pitchFamily="34" charset="-122"/>
                 <a:cs typeface="Arial" pitchFamily="34" charset="-120"/>
               </a:rPr>
-              <a:t>DRAFT V0.3   |   AUGUST 2026</a:t>
+              <a:t>DRAFT V0.4   |   AUGUST 2026</a:t>
             </a:r>
             <a:endParaRPr lang="en-US" sz="600" dirty="0"/>
           </a:p>
@@ -8707,7 +8707,7 @@
                 <a:ea typeface="Arial" pitchFamily="34" charset="-122"/>
                 <a:cs typeface="Arial" pitchFamily="34" charset="-120"/>
               </a:rPr>
-              <a:t>DRAFT V0.3   |   AUGUST 2026</a:t>
+              <a:t>DRAFT V0.4   |   AUGUST 2026</a:t>
             </a:r>
             <a:endParaRPr lang="en-US" sz="600" dirty="0"/>
           </a:p>
@@ -10304,7 +10304,7 @@
                 <a:ea typeface="Arial" pitchFamily="34" charset="-122"/>
                 <a:cs typeface="Arial" pitchFamily="34" charset="-120"/>
               </a:rPr>
-              <a:t>Five elements. Nothing else is permitted, and each carries a fixed meaning so the language cannot drift into decoration.</a:t>
+              <a:t>Six elements. Nothing else is permitted, and each carries a fixed meaning so the language cannot drift into decoration.</a:t>
             </a:r>
             <a:endParaRPr lang="en-US" sz="960" dirty="0"/>
           </a:p>
@@ -10382,7 +10382,7 @@
                 <a:ea typeface="Arial" pitchFamily="34" charset="-122"/>
                 <a:cs typeface="Arial" pitchFamily="34" charset="-120"/>
               </a:rPr>
-              <a:t>DRAFT V0.3   |   AUGUST 2026</a:t>
+              <a:t>DRAFT V0.4   |   AUGUST 2026</a:t>
             </a:r>
             <a:endParaRPr lang="en-US" sz="600" dirty="0"/>
           </a:p>
@@ -12312,7 +12312,7 @@
                 <a:ea typeface="Arial" pitchFamily="34" charset="-122"/>
                 <a:cs typeface="Arial" pitchFamily="34" charset="-120"/>
               </a:rPr>
-              <a:t>DRAFT V0.3   |   AUGUST 2026</a:t>
+              <a:t>DRAFT V0.4   |   AUGUST 2026</a:t>
             </a:r>
             <a:endParaRPr lang="en-US" sz="600" dirty="0"/>
           </a:p>
@@ -13412,7 +13412,7 @@
                 <a:ea typeface="Arial" pitchFamily="34" charset="-122"/>
                 <a:cs typeface="Arial" pitchFamily="34" charset="-120"/>
               </a:rPr>
-              <a:t>Endorsed and enduring. The bar is solid because doctrine does not qualify itself.</a:t>
+              <a:t>The solid bar: endorsed institutional guidance rather than open inquiry.</a:t>
             </a:r>
             <a:endParaRPr lang="en-US" sz="690" dirty="0"/>
           </a:p>
@@ -14751,7 +14751,7 @@
                 <a:ea typeface="Arial" pitchFamily="34" charset="-122"/>
                 <a:cs typeface="Arial" pitchFamily="34" charset="-120"/>
               </a:rPr>
-              <a:t>A discrete block on the datum. Products are countable and can be held.</a:t>
+              <a:t>A block on the datum. Products are discrete, identifiable and issued for use.</a:t>
             </a:r>
             <a:endParaRPr lang="en-US" sz="690" dirty="0"/>
           </a:p>
@@ -16115,7 +16115,7 @@
                 <a:ea typeface="Arial" pitchFamily="34" charset="-122"/>
                 <a:cs typeface="Arial" pitchFamily="34" charset="-120"/>
               </a:rPr>
-              <a:t>DRAFT V0.3   |   AUGUST 2026</a:t>
+              <a:t>DRAFT V0.4   |   AUGUST 2026</a:t>
             </a:r>
             <a:endParaRPr lang="en-US" sz="600" dirty="0"/>
           </a:p>
@@ -17938,7 +17938,7 @@
                 <a:ea typeface="Arial" pitchFamily="34" charset="-122"/>
                 <a:cs typeface="Arial" pitchFamily="34" charset="-120"/>
               </a:rPr>
-              <a:t>DRAFT V0.3   |   AUGUST 2026</a:t>
+              <a:t>DRAFT V0.4   |   AUGUST 2026</a:t>
             </a:r>
             <a:endParaRPr lang="en-US" sz="600" dirty="0"/>
           </a:p>
@@ -21369,7 +21369,7 @@
                 <a:ea typeface="Arial" pitchFamily="34" charset="-122"/>
                 <a:cs typeface="Arial" pitchFamily="34" charset="-120"/>
               </a:rPr>
-              <a:t>DRAFT V0.3   |   AUGUST 2026</a:t>
+              <a:t>DRAFT V0.4   |   AUGUST 2026</a:t>
             </a:r>
             <a:endParaRPr lang="en-US" sz="600" dirty="0"/>
           </a:p>
@@ -22613,7 +22613,7 @@
                 <a:ea typeface="Arial" pitchFamily="34" charset="-122"/>
                 <a:cs typeface="Arial" pitchFamily="34" charset="-120"/>
               </a:rPr>
-              <a:t>Gym and physical training as a stand-in for performance</a:t>
+              <a:t>Generic gym imagery as shorthand for performance</a:t>
             </a:r>
             <a:endParaRPr lang="en-US" sz="700" dirty="0"/>
           </a:p>
@@ -23376,7 +23376,7 @@
                 <a:ea typeface="Arial" pitchFamily="34" charset="-122"/>
                 <a:cs typeface="Arial" pitchFamily="34" charset="-120"/>
               </a:rPr>
-              <a:t>DRAFT V0.3   |   AUGUST 2026</a:t>
+              <a:t>DRAFT V0.4   |   AUGUST 2026</a:t>
             </a:r>
             <a:endParaRPr lang="en-US" sz="600" dirty="0"/>
           </a:p>
@@ -24490,7 +24490,7 @@
                 <a:ea typeface="Arial" pitchFamily="34" charset="-122"/>
                 <a:cs typeface="Arial" pitchFamily="34" charset="-120"/>
               </a:rPr>
-              <a:t>DRAFT V0.3   |   AUGUST 2026</a:t>
+              <a:t>DRAFT V0.4   |   AUGUST 2026</a:t>
             </a:r>
             <a:endParaRPr lang="en-US" sz="600" dirty="0"/>
           </a:p>
@@ -24789,7 +24789,7 @@
                 <a:ea typeface="Arial" pitchFamily="34" charset="-122"/>
                 <a:cs typeface="Arial" pitchFamily="34" charset="-120"/>
               </a:rPr>
-              <a:t>The twelve content types become the primary filter, not a search box. A user arrives asking what kind of thing they need before they know its title. Left rail carries the notation; content pane carries the component.</a:t>
+              <a:t>The pilot content types form the initial primary filter, not a search box. A user arrives asking what kind of thing they need before they know its title. Left rail carries the notation; content pane carries the component.</a:t>
             </a:r>
             <a:endParaRPr lang="en-US" sz="840" dirty="0"/>
           </a:p>
@@ -24867,7 +24867,7 @@
                 <a:ea typeface="Arial" pitchFamily="34" charset="-122"/>
                 <a:cs typeface="Arial" pitchFamily="34" charset="-120"/>
               </a:rPr>
-              <a:t>INTERACTIVE DOCTRINE</a:t>
+              <a:t>CONTROLLED CONTENT READER</a:t>
             </a:r>
             <a:endParaRPr lang="en-US" sz="860" dirty="0"/>
           </a:p>
@@ -24909,7 +24909,7 @@
                 <a:ea typeface="Arial" pitchFamily="34" charset="-122"/>
                 <a:cs typeface="Arial" pitchFamily="34" charset="-120"/>
               </a:rPr>
-              <a:t>Doctrine text at full measure, with evidence and assessment content collapsed beneath it and marked with their own notation. The reader can see that evidence exists without being made to read it, which is the behaviour the framework wants to encourage.</a:t>
+              <a:t>Endorsed text at full measure, with evidence and assessment collapsed beneath it and marked with their own notation. Doctrine is one content class this reader eventually carries. The reader can see that evidence exists without being made to read it, which is the behaviour the framework wants to encourage.</a:t>
             </a:r>
             <a:endParaRPr lang="en-US" sz="840" dirty="0"/>
           </a:p>
@@ -25919,7 +25919,7 @@
                 <a:ea typeface="Arial" pitchFamily="34" charset="-122"/>
                 <a:cs typeface="Arial" pitchFamily="34" charset="-120"/>
               </a:rPr>
-              <a:t>DRAFT V0.3   |   AUGUST 2026</a:t>
+              <a:t>DRAFT V0.4   |   AUGUST 2026</a:t>
             </a:r>
             <a:endParaRPr lang="en-US" sz="600" dirty="0"/>
           </a:p>
@@ -26098,7 +26098,7 @@
                 <a:ea typeface="Arial" pitchFamily="34" charset="-122"/>
                 <a:cs typeface="Arial" pitchFamily="34" charset="-120"/>
               </a:rPr>
-              <a:t>The guidelines forbid programmes creating logos. Correct, but the more useful observation is that a capability framework is closer to doctrine than to a project. Doctrine has a visual system: format, hierarchy, notation, numbering. That is the precedent to follow.</a:t>
+              <a:t>The guidelines forbid programmes creating logos. Correct, but the more useful observation is that a capability framework is closer to doctrine and controlled military information systems than to a branded project. Doctrine has a visual system: format, hierarchy, notation, numbering. That is the precedent to follow.</a:t>
             </a:r>
             <a:endParaRPr lang="en-US" sz="880" dirty="0"/>
           </a:p>
@@ -27586,7 +27586,7 @@
                 <a:ea typeface="Arial" pitchFamily="34" charset="-122"/>
                 <a:cs typeface="Arial" pitchFamily="34" charset="-120"/>
               </a:rPr>
-              <a:t>DRAFT V0.3   |   AUGUST 2026</a:t>
+              <a:t>DRAFT V0.4   |   AUGUST 2026</a:t>
             </a:r>
             <a:endParaRPr lang="en-US" sz="600" dirty="0"/>
           </a:p>
@@ -29474,7 +29474,7 @@
                 <a:ea typeface="Arial" pitchFamily="34" charset="-122"/>
                 <a:cs typeface="Arial" pitchFamily="34" charset="-120"/>
               </a:rPr>
-              <a:t>DRAFT V0.3   |   AUGUST 2026</a:t>
+              <a:t>DRAFT V0.4   |   AUGUST 2026</a:t>
             </a:r>
             <a:endParaRPr lang="en-US" sz="600" dirty="0"/>
           </a:p>
@@ -30422,7 +30422,7 @@
                 <a:ea typeface="Arial" pitchFamily="34" charset="-122"/>
                 <a:cs typeface="Arial" pitchFamily="34" charset="-120"/>
               </a:rPr>
-              <a:t>DRAFT V0.3   |   AUGUST 2026</a:t>
+              <a:t>DRAFT V0.4   |   AUGUST 2026</a:t>
             </a:r>
             <a:endParaRPr lang="en-US" sz="600" dirty="0"/>
           </a:p>
@@ -32006,7 +32006,7 @@
                 <a:ea typeface="Arial" pitchFamily="34" charset="-122"/>
                 <a:cs typeface="Arial" pitchFamily="34" charset="-120"/>
               </a:rPr>
-              <a:t>DRAFT V0.3   |   AUGUST 2026</a:t>
+              <a:t>DRAFT V0.4   |   AUGUST 2026</a:t>
             </a:r>
             <a:endParaRPr lang="en-US" sz="600" dirty="0"/>
           </a:p>
@@ -32740,7 +32740,7 @@
                 <a:ea typeface="Arial" pitchFamily="34" charset="-122"/>
                 <a:cs typeface="Arial" pitchFamily="34" charset="-120"/>
               </a:rPr>
-              <a:t>The Army logo appears unaltered on every artefact. Combat Mindset never competes with it.</a:t>
+              <a:t>The Army logo appears unaltered on every complete formal artefact. Combat Mindset never competes with it.</a:t>
             </a:r>
             <a:endParaRPr lang="en-US" sz="900" dirty="0"/>
           </a:p>
@@ -32764,7 +32764,7 @@
                 <a:ea typeface="Arial" pitchFamily="34" charset="-122"/>
                 <a:cs typeface="Arial" pitchFamily="34" charset="-120"/>
               </a:rPr>
-              <a:t>Authority is signalled the way doctrine signals it: consistent format, visible hierarchy, explicit classification of content, and a reference number on everything.</a:t>
+              <a:t>Authority is signalled the way doctrine signals it: consistent format, visible hierarchy, explicit classification of content, and a controlled identifier on every governed content item.</a:t>
             </a:r>
             <a:endParaRPr lang="en-US" sz="900" dirty="0"/>
           </a:p>
@@ -33728,7 +33728,7 @@
                 <a:ea typeface="Arial" pitchFamily="34" charset="-122"/>
                 <a:cs typeface="Arial" pitchFamily="34" charset="-120"/>
               </a:rPr>
-              <a:t>DRAFT V0.3   |   AUGUST 2026</a:t>
+              <a:t>DRAFT V0.4   |   AUGUST 2026</a:t>
             </a:r>
             <a:endParaRPr lang="en-US" sz="600" dirty="0"/>
           </a:p>
@@ -35024,7 +35024,7 @@
                 <a:ea typeface="Arial" pitchFamily="34" charset="-122"/>
                 <a:cs typeface="Arial" pitchFamily="34" charset="-120"/>
               </a:rPr>
-              <a:t>DRAFT V0.3   |   AUGUST 2026</a:t>
+              <a:t>DRAFT V0.4   |   AUGUST 2026</a:t>
             </a:r>
             <a:endParaRPr lang="en-US" sz="600" dirty="0"/>
           </a:p>
@@ -37174,7 +37174,7 @@
                 <a:ea typeface="Arial" pitchFamily="34" charset="-122"/>
                 <a:cs typeface="Arial" pitchFamily="34" charset="-120"/>
               </a:rPr>
-              <a:t>DRAFT V0.3   |   AUGUST 2026</a:t>
+              <a:t>DRAFT V0.4   |   AUGUST 2026</a:t>
             </a:r>
             <a:endParaRPr lang="en-US" sz="600" dirty="0"/>
           </a:p>
@@ -38701,7 +38701,7 @@
                 <a:ea typeface="Arial" pitchFamily="34" charset="-122"/>
                 <a:cs typeface="Arial" pitchFamily="34" charset="-120"/>
               </a:rPr>
-              <a:t>DRAFT V0.3   |   AUGUST 2026</a:t>
+              <a:t>DRAFT V0.4   |   AUGUST 2026</a:t>
             </a:r>
             <a:endParaRPr lang="en-US" sz="600" dirty="0"/>
           </a:p>
@@ -38967,7 +38967,7 @@
                 <a:ea typeface="Arial" pitchFamily="34" charset="-122"/>
                 <a:cs typeface="Arial" pitchFamily="34" charset="-120"/>
               </a:rPr>
-              <a:t>This is what the framework is for. Capability is not lost under pressure; access to it is temporarily displaced, and the system exists to shorten the return.</a:t>
+              <a:t>This is what the framework is for. Under pressure, access to trained capability can be displaced or degraded, and the system exists to preserve effectiveness and shorten the return to true.</a:t>
             </a:r>
             <a:endParaRPr lang="en-US" sz="1020" dirty="0"/>
           </a:p>
@@ -39907,7 +39907,7 @@
                 <a:ea typeface="Arial" pitchFamily="34" charset="-122"/>
                 <a:cs typeface="Arial" pitchFamily="34" charset="-120"/>
               </a:rPr>
-              <a:t>DRAFT V0.3   |   AUGUST 2026</a:t>
+              <a:t>DRAFT V0.4   |   AUGUST 2026</a:t>
             </a:r>
             <a:endParaRPr lang="en-US" sz="600" dirty="0"/>
           </a:p>
@@ -41113,7 +41113,7 @@
                 <a:ea typeface="Arial" pitchFamily="34" charset="-122"/>
                 <a:cs typeface="Arial" pitchFamily="34" charset="-120"/>
               </a:rPr>
-              <a:t>DRAFT V0.3   |   AUGUST 2026</a:t>
+              <a:t>DRAFT V0.4   |   AUGUST 2026</a:t>
             </a:r>
             <a:endParaRPr lang="en-US" sz="600" dirty="0"/>
           </a:p>

</xml_diff>

<commit_message>
Identity system V0.5: circulation draft
Four final amendments from review: no freestanding brand mark replaces
the no mark absolute, the formal title treatment draws on doctrine
publication conventions rather than borrowing authority, the governance
constraint narrows to production assets and enduring templates, and the
information architecture table now visually separates the six pilot
types from the six greyed candidate extensions with a legend.

Co-Authored-By: Claude Fable 5 <noreply@anthropic.com>
Claude-Session: https://claude.ai/code/session_01YLo1WfwUDkbwfJEF3ZNVbB
</commit_message>
<xml_diff>
--- a/output/combat-mindset-identity-system.pptx
+++ b/output/combat-mindset-identity-system.pptx
@@ -3349,7 +3349,7 @@
                 <a:ea typeface="Arial" pitchFamily="34" charset="-122"/>
                 <a:cs typeface="Arial" pitchFamily="34" charset="-120"/>
               </a:rPr>
-              <a:t>V0.4, August 2026</a:t>
+              <a:t>V0.5, August 2026</a:t>
             </a:r>
             <a:endParaRPr lang="en-US" sz="800" dirty="0"/>
           </a:p>
@@ -3638,7 +3638,7 @@
                 <a:ea typeface="Arial" pitchFamily="34" charset="-122"/>
                 <a:cs typeface="Arial" pitchFamily="34" charset="-120"/>
               </a:rPr>
-              <a:t>DRAFT V0.4   |   AUGUST 2026</a:t>
+              <a:t>DRAFT V0.5   |   AUGUST 2026</a:t>
             </a:r>
             <a:endParaRPr lang="en-US" sz="600" dirty="0"/>
           </a:p>
@@ -6671,7 +6671,7 @@
                 <a:ea typeface="Arial" pitchFamily="34" charset="-122"/>
                 <a:cs typeface="Arial" pitchFamily="34" charset="-120"/>
               </a:rPr>
-              <a:t>DRAFT V0.4   |   AUGUST 2026</a:t>
+              <a:t>DRAFT V0.5   |   AUGUST 2026</a:t>
             </a:r>
             <a:endParaRPr lang="en-US" sz="600" dirty="0"/>
           </a:p>
@@ -7642,7 +7642,7 @@
                 <a:ea typeface="Arial" pitchFamily="34" charset="-122"/>
                 <a:cs typeface="Arial" pitchFamily="34" charset="-120"/>
               </a:rPr>
-              <a:t>Borrows the authority of the doctrine series directly. Recommended as the formal variant on covers and title pages.</a:t>
+              <a:t>Draws on doctrine-publication conventions of numbering and hierarchy. Recommended as the formal variant on covers and title pages.</a:t>
             </a:r>
             <a:endParaRPr lang="en-US" sz="760" dirty="0"/>
           </a:p>
@@ -8707,7 +8707,7 @@
                 <a:ea typeface="Arial" pitchFamily="34" charset="-122"/>
                 <a:cs typeface="Arial" pitchFamily="34" charset="-120"/>
               </a:rPr>
-              <a:t>DRAFT V0.4   |   AUGUST 2026</a:t>
+              <a:t>DRAFT V0.5   |   AUGUST 2026</a:t>
             </a:r>
             <a:endParaRPr lang="en-US" sz="600" dirty="0"/>
           </a:p>
@@ -10382,7 +10382,7 @@
                 <a:ea typeface="Arial" pitchFamily="34" charset="-122"/>
                 <a:cs typeface="Arial" pitchFamily="34" charset="-120"/>
               </a:rPr>
-              <a:t>DRAFT V0.4   |   AUGUST 2026</a:t>
+              <a:t>DRAFT V0.5   |   AUGUST 2026</a:t>
             </a:r>
             <a:endParaRPr lang="en-US" sz="600" dirty="0"/>
           </a:p>
@@ -12312,7 +12312,7 @@
                 <a:ea typeface="Arial" pitchFamily="34" charset="-122"/>
                 <a:cs typeface="Arial" pitchFamily="34" charset="-120"/>
               </a:rPr>
-              <a:t>DRAFT V0.4   |   AUGUST 2026</a:t>
+              <a:t>DRAFT V0.5   |   AUGUST 2026</a:t>
             </a:r>
             <a:endParaRPr lang="en-US" sz="600" dirty="0"/>
           </a:p>
@@ -16115,7 +16115,7 @@
                 <a:ea typeface="Arial" pitchFamily="34" charset="-122"/>
                 <a:cs typeface="Arial" pitchFamily="34" charset="-120"/>
               </a:rPr>
-              <a:t>DRAFT V0.4   |   AUGUST 2026</a:t>
+              <a:t>DRAFT V0.5   |   AUGUST 2026</a:t>
             </a:r>
             <a:endParaRPr lang="en-US" sz="600" dirty="0"/>
           </a:p>
@@ -17938,7 +17938,7 @@
                 <a:ea typeface="Arial" pitchFamily="34" charset="-122"/>
                 <a:cs typeface="Arial" pitchFamily="34" charset="-120"/>
               </a:rPr>
-              <a:t>DRAFT V0.4   |   AUGUST 2026</a:t>
+              <a:t>DRAFT V0.5   |   AUGUST 2026</a:t>
             </a:r>
             <a:endParaRPr lang="en-US" sz="600" dirty="0"/>
           </a:p>
@@ -18455,7 +18455,7 @@
         <p:spPr>
           <a:xfrm>
             <a:off x="566928" y="4517136"/>
-            <a:ext cx="6428232" cy="420624"/>
+            <a:ext cx="6428232" cy="402336"/>
           </a:xfrm>
           <a:prstGeom prst="rect">
             <a:avLst/>
@@ -18475,7 +18475,7 @@
         <p:spPr>
           <a:xfrm>
             <a:off x="566928" y="4517136"/>
-            <a:ext cx="36576" cy="420624"/>
+            <a:ext cx="36576" cy="402336"/>
           </a:xfrm>
           <a:prstGeom prst="rect">
             <a:avLst/>
@@ -18519,7 +18519,7 @@
         <p:spPr>
           <a:xfrm>
             <a:off x="1097280" y="4517136"/>
-            <a:ext cx="1371600" cy="420624"/>
+            <a:ext cx="1371600" cy="402336"/>
           </a:xfrm>
           <a:prstGeom prst="rect">
             <a:avLst/>
@@ -18558,7 +18558,7 @@
         <p:spPr>
           <a:xfrm>
             <a:off x="2450592" y="4517136"/>
-            <a:ext cx="914400" cy="420624"/>
+            <a:ext cx="914400" cy="402336"/>
           </a:xfrm>
           <a:prstGeom prst="rect">
             <a:avLst/>
@@ -18597,7 +18597,7 @@
         <p:spPr>
           <a:xfrm>
             <a:off x="3310128" y="4517136"/>
-            <a:ext cx="969264" cy="420624"/>
+            <a:ext cx="969264" cy="402336"/>
           </a:xfrm>
           <a:prstGeom prst="rect">
             <a:avLst/>
@@ -18636,7 +18636,7 @@
         <p:spPr>
           <a:xfrm>
             <a:off x="4352544" y="4517136"/>
-            <a:ext cx="2551176" cy="420624"/>
+            <a:ext cx="2551176" cy="402336"/>
           </a:xfrm>
           <a:prstGeom prst="rect">
             <a:avLst/>
@@ -18674,8 +18674,8 @@
         </p:nvSpPr>
         <p:spPr>
           <a:xfrm>
-            <a:off x="566928" y="4974336"/>
-            <a:ext cx="6428232" cy="420624"/>
+            <a:off x="566928" y="4956048"/>
+            <a:ext cx="6428232" cy="402336"/>
           </a:xfrm>
           <a:prstGeom prst="rect">
             <a:avLst/>
@@ -18694,8 +18694,8 @@
         </p:nvSpPr>
         <p:spPr>
           <a:xfrm>
-            <a:off x="566928" y="4974336"/>
-            <a:ext cx="36576" cy="420624"/>
+            <a:off x="566928" y="4956048"/>
+            <a:ext cx="36576" cy="402336"/>
           </a:xfrm>
           <a:prstGeom prst="rect">
             <a:avLst/>
@@ -18722,7 +18722,7 @@
         </p:blipFill>
         <p:spPr>
           <a:xfrm>
-            <a:off x="731520" y="5074920"/>
+            <a:off x="731520" y="5056632"/>
             <a:ext cx="256032" cy="256032"/>
           </a:xfrm>
           <a:prstGeom prst="rect">
@@ -18738,8 +18738,8 @@
         </p:nvSpPr>
         <p:spPr>
           <a:xfrm>
-            <a:off x="1097280" y="4974336"/>
-            <a:ext cx="1371600" cy="420624"/>
+            <a:off x="1097280" y="4956048"/>
+            <a:ext cx="1371600" cy="402336"/>
           </a:xfrm>
           <a:prstGeom prst="rect">
             <a:avLst/>
@@ -18757,7 +18757,7 @@
             <a:r>
               <a:rPr lang="en-US" sz="820" b="1" spc="60" kern="0" dirty="0">
                 <a:solidFill>
-                  <a:srgbClr val="1A1A1A"/>
+                  <a:srgbClr val="6E6E6E"/>
                 </a:solidFill>
                 <a:latin typeface="Arial" pitchFamily="34" charset="0"/>
                 <a:ea typeface="Arial" pitchFamily="34" charset="-122"/>
@@ -18777,8 +18777,8 @@
         </p:nvSpPr>
         <p:spPr>
           <a:xfrm>
-            <a:off x="2450592" y="4974336"/>
-            <a:ext cx="914400" cy="420624"/>
+            <a:off x="2450592" y="4956048"/>
+            <a:ext cx="914400" cy="402336"/>
           </a:xfrm>
           <a:prstGeom prst="rect">
             <a:avLst/>
@@ -18816,8 +18816,8 @@
         </p:nvSpPr>
         <p:spPr>
           <a:xfrm>
-            <a:off x="3310128" y="4974336"/>
-            <a:ext cx="969264" cy="420624"/>
+            <a:off x="3310128" y="4956048"/>
+            <a:ext cx="969264" cy="402336"/>
           </a:xfrm>
           <a:prstGeom prst="rect">
             <a:avLst/>
@@ -18855,8 +18855,8 @@
         </p:nvSpPr>
         <p:spPr>
           <a:xfrm>
-            <a:off x="4352544" y="4974336"/>
-            <a:ext cx="2551176" cy="420624"/>
+            <a:off x="4352544" y="4956048"/>
+            <a:ext cx="2551176" cy="402336"/>
           </a:xfrm>
           <a:prstGeom prst="rect">
             <a:avLst/>
@@ -18874,7 +18874,7 @@
             <a:r>
               <a:rPr lang="en-US" sz="780" dirty="0">
                 <a:solidFill>
-                  <a:srgbClr val="3E3E3E"/>
+                  <a:srgbClr val="9C9C9C"/>
                 </a:solidFill>
                 <a:latin typeface="Arial" pitchFamily="34" charset="0"/>
                 <a:ea typeface="Arial" pitchFamily="34" charset="-122"/>
@@ -18894,8 +18894,8 @@
         </p:nvSpPr>
         <p:spPr>
           <a:xfrm>
-            <a:off x="566928" y="5431536"/>
-            <a:ext cx="6428232" cy="420624"/>
+            <a:off x="566928" y="5394960"/>
+            <a:ext cx="6428232" cy="402336"/>
           </a:xfrm>
           <a:prstGeom prst="rect">
             <a:avLst/>
@@ -18914,8 +18914,8 @@
         </p:nvSpPr>
         <p:spPr>
           <a:xfrm>
-            <a:off x="566928" y="5431536"/>
-            <a:ext cx="36576" cy="420624"/>
+            <a:off x="566928" y="5394960"/>
+            <a:ext cx="36576" cy="402336"/>
           </a:xfrm>
           <a:prstGeom prst="rect">
             <a:avLst/>
@@ -18942,7 +18942,7 @@
         </p:blipFill>
         <p:spPr>
           <a:xfrm>
-            <a:off x="731520" y="5532120"/>
+            <a:off x="731520" y="5495544"/>
             <a:ext cx="256032" cy="256032"/>
           </a:xfrm>
           <a:prstGeom prst="rect">
@@ -18958,8 +18958,8 @@
         </p:nvSpPr>
         <p:spPr>
           <a:xfrm>
-            <a:off x="1097280" y="5431536"/>
-            <a:ext cx="1371600" cy="420624"/>
+            <a:off x="1097280" y="5394960"/>
+            <a:ext cx="1371600" cy="402336"/>
           </a:xfrm>
           <a:prstGeom prst="rect">
             <a:avLst/>
@@ -18977,7 +18977,7 @@
             <a:r>
               <a:rPr lang="en-US" sz="820" b="1" spc="60" kern="0" dirty="0">
                 <a:solidFill>
-                  <a:srgbClr val="1A1A1A"/>
+                  <a:srgbClr val="6E6E6E"/>
                 </a:solidFill>
                 <a:latin typeface="Arial" pitchFamily="34" charset="0"/>
                 <a:ea typeface="Arial" pitchFamily="34" charset="-122"/>
@@ -18997,8 +18997,8 @@
         </p:nvSpPr>
         <p:spPr>
           <a:xfrm>
-            <a:off x="2450592" y="5431536"/>
-            <a:ext cx="914400" cy="420624"/>
+            <a:off x="2450592" y="5394960"/>
+            <a:ext cx="914400" cy="402336"/>
           </a:xfrm>
           <a:prstGeom prst="rect">
             <a:avLst/>
@@ -19036,8 +19036,8 @@
         </p:nvSpPr>
         <p:spPr>
           <a:xfrm>
-            <a:off x="3310128" y="5431536"/>
-            <a:ext cx="969264" cy="420624"/>
+            <a:off x="3310128" y="5394960"/>
+            <a:ext cx="969264" cy="402336"/>
           </a:xfrm>
           <a:prstGeom prst="rect">
             <a:avLst/>
@@ -19075,8 +19075,8 @@
         </p:nvSpPr>
         <p:spPr>
           <a:xfrm>
-            <a:off x="4352544" y="5431536"/>
-            <a:ext cx="2551176" cy="420624"/>
+            <a:off x="4352544" y="5394960"/>
+            <a:ext cx="2551176" cy="402336"/>
           </a:xfrm>
           <a:prstGeom prst="rect">
             <a:avLst/>
@@ -19094,7 +19094,7 @@
             <a:r>
               <a:rPr lang="en-US" sz="780" dirty="0">
                 <a:solidFill>
-                  <a:srgbClr val="3E3E3E"/>
+                  <a:srgbClr val="9C9C9C"/>
                 </a:solidFill>
                 <a:latin typeface="Arial" pitchFamily="34" charset="0"/>
                 <a:ea typeface="Arial" pitchFamily="34" charset="-122"/>
@@ -19114,8 +19114,8 @@
         </p:nvSpPr>
         <p:spPr>
           <a:xfrm>
-            <a:off x="566928" y="5888736"/>
-            <a:ext cx="6428232" cy="420624"/>
+            <a:off x="566928" y="5833872"/>
+            <a:ext cx="6428232" cy="402336"/>
           </a:xfrm>
           <a:prstGeom prst="rect">
             <a:avLst/>
@@ -19134,8 +19134,8 @@
         </p:nvSpPr>
         <p:spPr>
           <a:xfrm>
-            <a:off x="566928" y="5888736"/>
-            <a:ext cx="36576" cy="420624"/>
+            <a:off x="566928" y="5833872"/>
+            <a:ext cx="36576" cy="402336"/>
           </a:xfrm>
           <a:prstGeom prst="rect">
             <a:avLst/>
@@ -19162,7 +19162,7 @@
         </p:blipFill>
         <p:spPr>
           <a:xfrm>
-            <a:off x="731520" y="5989320"/>
+            <a:off x="731520" y="5934456"/>
             <a:ext cx="256032" cy="256032"/>
           </a:xfrm>
           <a:prstGeom prst="rect">
@@ -19178,8 +19178,8 @@
         </p:nvSpPr>
         <p:spPr>
           <a:xfrm>
-            <a:off x="1097280" y="5888736"/>
-            <a:ext cx="1371600" cy="420624"/>
+            <a:off x="1097280" y="5833872"/>
+            <a:ext cx="1371600" cy="402336"/>
           </a:xfrm>
           <a:prstGeom prst="rect">
             <a:avLst/>
@@ -19217,8 +19217,8 @@
         </p:nvSpPr>
         <p:spPr>
           <a:xfrm>
-            <a:off x="2450592" y="5888736"/>
-            <a:ext cx="914400" cy="420624"/>
+            <a:off x="2450592" y="5833872"/>
+            <a:ext cx="914400" cy="402336"/>
           </a:xfrm>
           <a:prstGeom prst="rect">
             <a:avLst/>
@@ -19256,8 +19256,8 @@
         </p:nvSpPr>
         <p:spPr>
           <a:xfrm>
-            <a:off x="3310128" y="5888736"/>
-            <a:ext cx="969264" cy="420624"/>
+            <a:off x="3310128" y="5833872"/>
+            <a:ext cx="969264" cy="402336"/>
           </a:xfrm>
           <a:prstGeom prst="rect">
             <a:avLst/>
@@ -19295,8 +19295,8 @@
         </p:nvSpPr>
         <p:spPr>
           <a:xfrm>
-            <a:off x="4352544" y="5888736"/>
-            <a:ext cx="2551176" cy="420624"/>
+            <a:off x="4352544" y="5833872"/>
+            <a:ext cx="2551176" cy="402336"/>
           </a:xfrm>
           <a:prstGeom prst="rect">
             <a:avLst/>
@@ -19334,8 +19334,8 @@
         </p:nvSpPr>
         <p:spPr>
           <a:xfrm>
-            <a:off x="566928" y="6345936"/>
-            <a:ext cx="6428232" cy="420624"/>
+            <a:off x="566928" y="6272784"/>
+            <a:ext cx="6428232" cy="402336"/>
           </a:xfrm>
           <a:prstGeom prst="rect">
             <a:avLst/>
@@ -19354,8 +19354,8 @@
         </p:nvSpPr>
         <p:spPr>
           <a:xfrm>
-            <a:off x="566928" y="6345936"/>
-            <a:ext cx="36576" cy="420624"/>
+            <a:off x="566928" y="6272784"/>
+            <a:ext cx="36576" cy="402336"/>
           </a:xfrm>
           <a:prstGeom prst="rect">
             <a:avLst/>
@@ -19382,7 +19382,7 @@
         </p:blipFill>
         <p:spPr>
           <a:xfrm>
-            <a:off x="731520" y="6446520"/>
+            <a:off x="731520" y="6373368"/>
             <a:ext cx="256032" cy="256032"/>
           </a:xfrm>
           <a:prstGeom prst="rect">
@@ -19398,8 +19398,8 @@
         </p:nvSpPr>
         <p:spPr>
           <a:xfrm>
-            <a:off x="1097280" y="6345936"/>
-            <a:ext cx="1371600" cy="420624"/>
+            <a:off x="1097280" y="6272784"/>
+            <a:ext cx="1371600" cy="402336"/>
           </a:xfrm>
           <a:prstGeom prst="rect">
             <a:avLst/>
@@ -19437,8 +19437,8 @@
         </p:nvSpPr>
         <p:spPr>
           <a:xfrm>
-            <a:off x="2450592" y="6345936"/>
-            <a:ext cx="914400" cy="420624"/>
+            <a:off x="2450592" y="6272784"/>
+            <a:ext cx="914400" cy="402336"/>
           </a:xfrm>
           <a:prstGeom prst="rect">
             <a:avLst/>
@@ -19476,8 +19476,8 @@
         </p:nvSpPr>
         <p:spPr>
           <a:xfrm>
-            <a:off x="3310128" y="6345936"/>
-            <a:ext cx="969264" cy="420624"/>
+            <a:off x="3310128" y="6272784"/>
+            <a:ext cx="969264" cy="402336"/>
           </a:xfrm>
           <a:prstGeom prst="rect">
             <a:avLst/>
@@ -19515,8 +19515,8 @@
         </p:nvSpPr>
         <p:spPr>
           <a:xfrm>
-            <a:off x="4352544" y="6345936"/>
-            <a:ext cx="2551176" cy="420624"/>
+            <a:off x="4352544" y="6272784"/>
+            <a:ext cx="2551176" cy="402336"/>
           </a:xfrm>
           <a:prstGeom prst="rect">
             <a:avLst/>
@@ -19554,8 +19554,8 @@
         </p:nvSpPr>
         <p:spPr>
           <a:xfrm>
-            <a:off x="566928" y="6803136"/>
-            <a:ext cx="6428232" cy="420624"/>
+            <a:off x="566928" y="6711696"/>
+            <a:ext cx="6428232" cy="402336"/>
           </a:xfrm>
           <a:prstGeom prst="rect">
             <a:avLst/>
@@ -19574,8 +19574,8 @@
         </p:nvSpPr>
         <p:spPr>
           <a:xfrm>
-            <a:off x="566928" y="6803136"/>
-            <a:ext cx="36576" cy="420624"/>
+            <a:off x="566928" y="6711696"/>
+            <a:ext cx="36576" cy="402336"/>
           </a:xfrm>
           <a:prstGeom prst="rect">
             <a:avLst/>
@@ -19602,7 +19602,7 @@
         </p:blipFill>
         <p:spPr>
           <a:xfrm>
-            <a:off x="731520" y="6903720"/>
+            <a:off x="731520" y="6812280"/>
             <a:ext cx="256032" cy="256032"/>
           </a:xfrm>
           <a:prstGeom prst="rect">
@@ -19618,8 +19618,8 @@
         </p:nvSpPr>
         <p:spPr>
           <a:xfrm>
-            <a:off x="1097280" y="6803136"/>
-            <a:ext cx="1371600" cy="420624"/>
+            <a:off x="1097280" y="6711696"/>
+            <a:ext cx="1371600" cy="402336"/>
           </a:xfrm>
           <a:prstGeom prst="rect">
             <a:avLst/>
@@ -19637,7 +19637,7 @@
             <a:r>
               <a:rPr lang="en-US" sz="820" b="1" spc="60" kern="0" dirty="0">
                 <a:solidFill>
-                  <a:srgbClr val="1A1A1A"/>
+                  <a:srgbClr val="6E6E6E"/>
                 </a:solidFill>
                 <a:latin typeface="Arial" pitchFamily="34" charset="0"/>
                 <a:ea typeface="Arial" pitchFamily="34" charset="-122"/>
@@ -19657,8 +19657,8 @@
         </p:nvSpPr>
         <p:spPr>
           <a:xfrm>
-            <a:off x="2450592" y="6803136"/>
-            <a:ext cx="914400" cy="420624"/>
+            <a:off x="2450592" y="6711696"/>
+            <a:ext cx="914400" cy="402336"/>
           </a:xfrm>
           <a:prstGeom prst="rect">
             <a:avLst/>
@@ -19696,8 +19696,8 @@
         </p:nvSpPr>
         <p:spPr>
           <a:xfrm>
-            <a:off x="3310128" y="6803136"/>
-            <a:ext cx="969264" cy="420624"/>
+            <a:off x="3310128" y="6711696"/>
+            <a:ext cx="969264" cy="402336"/>
           </a:xfrm>
           <a:prstGeom prst="rect">
             <a:avLst/>
@@ -19735,8 +19735,8 @@
         </p:nvSpPr>
         <p:spPr>
           <a:xfrm>
-            <a:off x="4352544" y="6803136"/>
-            <a:ext cx="2551176" cy="420624"/>
+            <a:off x="4352544" y="6711696"/>
+            <a:ext cx="2551176" cy="402336"/>
           </a:xfrm>
           <a:prstGeom prst="rect">
             <a:avLst/>
@@ -19754,7 +19754,7 @@
             <a:r>
               <a:rPr lang="en-US" sz="780" dirty="0">
                 <a:solidFill>
-                  <a:srgbClr val="3E3E3E"/>
+                  <a:srgbClr val="9C9C9C"/>
                 </a:solidFill>
                 <a:latin typeface="Arial" pitchFamily="34" charset="0"/>
                 <a:ea typeface="Arial" pitchFamily="34" charset="-122"/>
@@ -19774,8 +19774,8 @@
         </p:nvSpPr>
         <p:spPr>
           <a:xfrm>
-            <a:off x="566928" y="7260336"/>
-            <a:ext cx="6428232" cy="420624"/>
+            <a:off x="566928" y="7150608"/>
+            <a:ext cx="6428232" cy="402336"/>
           </a:xfrm>
           <a:prstGeom prst="rect">
             <a:avLst/>
@@ -19794,8 +19794,8 @@
         </p:nvSpPr>
         <p:spPr>
           <a:xfrm>
-            <a:off x="566928" y="7260336"/>
-            <a:ext cx="36576" cy="420624"/>
+            <a:off x="566928" y="7150608"/>
+            <a:ext cx="36576" cy="402336"/>
           </a:xfrm>
           <a:prstGeom prst="rect">
             <a:avLst/>
@@ -19822,7 +19822,7 @@
         </p:blipFill>
         <p:spPr>
           <a:xfrm>
-            <a:off x="731520" y="7360920"/>
+            <a:off x="731520" y="7251192"/>
             <a:ext cx="256032" cy="256032"/>
           </a:xfrm>
           <a:prstGeom prst="rect">
@@ -19838,8 +19838,8 @@
         </p:nvSpPr>
         <p:spPr>
           <a:xfrm>
-            <a:off x="1097280" y="7260336"/>
-            <a:ext cx="1371600" cy="420624"/>
+            <a:off x="1097280" y="7150608"/>
+            <a:ext cx="1371600" cy="402336"/>
           </a:xfrm>
           <a:prstGeom prst="rect">
             <a:avLst/>
@@ -19877,8 +19877,8 @@
         </p:nvSpPr>
         <p:spPr>
           <a:xfrm>
-            <a:off x="2450592" y="7260336"/>
-            <a:ext cx="914400" cy="420624"/>
+            <a:off x="2450592" y="7150608"/>
+            <a:ext cx="914400" cy="402336"/>
           </a:xfrm>
           <a:prstGeom prst="rect">
             <a:avLst/>
@@ -19916,8 +19916,8 @@
         </p:nvSpPr>
         <p:spPr>
           <a:xfrm>
-            <a:off x="3310128" y="7260336"/>
-            <a:ext cx="969264" cy="420624"/>
+            <a:off x="3310128" y="7150608"/>
+            <a:ext cx="969264" cy="402336"/>
           </a:xfrm>
           <a:prstGeom prst="rect">
             <a:avLst/>
@@ -19955,8 +19955,8 @@
         </p:nvSpPr>
         <p:spPr>
           <a:xfrm>
-            <a:off x="4352544" y="7260336"/>
-            <a:ext cx="2551176" cy="420624"/>
+            <a:off x="4352544" y="7150608"/>
+            <a:ext cx="2551176" cy="402336"/>
           </a:xfrm>
           <a:prstGeom prst="rect">
             <a:avLst/>
@@ -19994,8 +19994,8 @@
         </p:nvSpPr>
         <p:spPr>
           <a:xfrm>
-            <a:off x="566928" y="7717536"/>
-            <a:ext cx="6428232" cy="420624"/>
+            <a:off x="566928" y="7589520"/>
+            <a:ext cx="6428232" cy="402336"/>
           </a:xfrm>
           <a:prstGeom prst="rect">
             <a:avLst/>
@@ -20014,8 +20014,8 @@
         </p:nvSpPr>
         <p:spPr>
           <a:xfrm>
-            <a:off x="566928" y="7717536"/>
-            <a:ext cx="36576" cy="420624"/>
+            <a:off x="566928" y="7589520"/>
+            <a:ext cx="36576" cy="402336"/>
           </a:xfrm>
           <a:prstGeom prst="rect">
             <a:avLst/>
@@ -20042,7 +20042,7 @@
         </p:blipFill>
         <p:spPr>
           <a:xfrm>
-            <a:off x="731520" y="7818120"/>
+            <a:off x="731520" y="7690104"/>
             <a:ext cx="256032" cy="256032"/>
           </a:xfrm>
           <a:prstGeom prst="rect">
@@ -20058,8 +20058,8 @@
         </p:nvSpPr>
         <p:spPr>
           <a:xfrm>
-            <a:off x="1097280" y="7717536"/>
-            <a:ext cx="1371600" cy="420624"/>
+            <a:off x="1097280" y="7589520"/>
+            <a:ext cx="1371600" cy="402336"/>
           </a:xfrm>
           <a:prstGeom prst="rect">
             <a:avLst/>
@@ -20077,7 +20077,7 @@
             <a:r>
               <a:rPr lang="en-US" sz="820" b="1" spc="60" kern="0" dirty="0">
                 <a:solidFill>
-                  <a:srgbClr val="1A1A1A"/>
+                  <a:srgbClr val="6E6E6E"/>
                 </a:solidFill>
                 <a:latin typeface="Arial" pitchFamily="34" charset="0"/>
                 <a:ea typeface="Arial" pitchFamily="34" charset="-122"/>
@@ -20097,8 +20097,8 @@
         </p:nvSpPr>
         <p:spPr>
           <a:xfrm>
-            <a:off x="2450592" y="7717536"/>
-            <a:ext cx="914400" cy="420624"/>
+            <a:off x="2450592" y="7589520"/>
+            <a:ext cx="914400" cy="402336"/>
           </a:xfrm>
           <a:prstGeom prst="rect">
             <a:avLst/>
@@ -20136,8 +20136,8 @@
         </p:nvSpPr>
         <p:spPr>
           <a:xfrm>
-            <a:off x="3310128" y="7717536"/>
-            <a:ext cx="969264" cy="420624"/>
+            <a:off x="3310128" y="7589520"/>
+            <a:ext cx="969264" cy="402336"/>
           </a:xfrm>
           <a:prstGeom prst="rect">
             <a:avLst/>
@@ -20175,8 +20175,8 @@
         </p:nvSpPr>
         <p:spPr>
           <a:xfrm>
-            <a:off x="4352544" y="7717536"/>
-            <a:ext cx="2551176" cy="420624"/>
+            <a:off x="4352544" y="7589520"/>
+            <a:ext cx="2551176" cy="402336"/>
           </a:xfrm>
           <a:prstGeom prst="rect">
             <a:avLst/>
@@ -20194,7 +20194,7 @@
             <a:r>
               <a:rPr lang="en-US" sz="780" dirty="0">
                 <a:solidFill>
-                  <a:srgbClr val="3E3E3E"/>
+                  <a:srgbClr val="9C9C9C"/>
                 </a:solidFill>
                 <a:latin typeface="Arial" pitchFamily="34" charset="0"/>
                 <a:ea typeface="Arial" pitchFamily="34" charset="-122"/>
@@ -20214,8 +20214,8 @@
         </p:nvSpPr>
         <p:spPr>
           <a:xfrm>
-            <a:off x="566928" y="8174736"/>
-            <a:ext cx="6428232" cy="420624"/>
+            <a:off x="566928" y="8028432"/>
+            <a:ext cx="6428232" cy="402336"/>
           </a:xfrm>
           <a:prstGeom prst="rect">
             <a:avLst/>
@@ -20234,8 +20234,8 @@
         </p:nvSpPr>
         <p:spPr>
           <a:xfrm>
-            <a:off x="566928" y="8174736"/>
-            <a:ext cx="36576" cy="420624"/>
+            <a:off x="566928" y="8028432"/>
+            <a:ext cx="36576" cy="402336"/>
           </a:xfrm>
           <a:prstGeom prst="rect">
             <a:avLst/>
@@ -20262,7 +20262,7 @@
         </p:blipFill>
         <p:spPr>
           <a:xfrm>
-            <a:off x="731520" y="8275320"/>
+            <a:off x="731520" y="8129016"/>
             <a:ext cx="256032" cy="256032"/>
           </a:xfrm>
           <a:prstGeom prst="rect">
@@ -20278,8 +20278,8 @@
         </p:nvSpPr>
         <p:spPr>
           <a:xfrm>
-            <a:off x="1097280" y="8174736"/>
-            <a:ext cx="1371600" cy="420624"/>
+            <a:off x="1097280" y="8028432"/>
+            <a:ext cx="1371600" cy="402336"/>
           </a:xfrm>
           <a:prstGeom prst="rect">
             <a:avLst/>
@@ -20317,8 +20317,8 @@
         </p:nvSpPr>
         <p:spPr>
           <a:xfrm>
-            <a:off x="2450592" y="8174736"/>
-            <a:ext cx="914400" cy="420624"/>
+            <a:off x="2450592" y="8028432"/>
+            <a:ext cx="914400" cy="402336"/>
           </a:xfrm>
           <a:prstGeom prst="rect">
             <a:avLst/>
@@ -20356,8 +20356,8 @@
         </p:nvSpPr>
         <p:spPr>
           <a:xfrm>
-            <a:off x="3310128" y="8174736"/>
-            <a:ext cx="969264" cy="420624"/>
+            <a:off x="3310128" y="8028432"/>
+            <a:ext cx="969264" cy="402336"/>
           </a:xfrm>
           <a:prstGeom prst="rect">
             <a:avLst/>
@@ -20395,8 +20395,8 @@
         </p:nvSpPr>
         <p:spPr>
           <a:xfrm>
-            <a:off x="4352544" y="8174736"/>
-            <a:ext cx="2551176" cy="420624"/>
+            <a:off x="4352544" y="8028432"/>
+            <a:ext cx="2551176" cy="402336"/>
           </a:xfrm>
           <a:prstGeom prst="rect">
             <a:avLst/>
@@ -20434,8 +20434,8 @@
         </p:nvSpPr>
         <p:spPr>
           <a:xfrm>
-            <a:off x="566928" y="8631936"/>
-            <a:ext cx="6428232" cy="420624"/>
+            <a:off x="566928" y="8467344"/>
+            <a:ext cx="6428232" cy="402336"/>
           </a:xfrm>
           <a:prstGeom prst="rect">
             <a:avLst/>
@@ -20454,8 +20454,8 @@
         </p:nvSpPr>
         <p:spPr>
           <a:xfrm>
-            <a:off x="566928" y="8631936"/>
-            <a:ext cx="36576" cy="420624"/>
+            <a:off x="566928" y="8467344"/>
+            <a:ext cx="36576" cy="402336"/>
           </a:xfrm>
           <a:prstGeom prst="rect">
             <a:avLst/>
@@ -20482,7 +20482,7 @@
         </p:blipFill>
         <p:spPr>
           <a:xfrm>
-            <a:off x="731520" y="8732520"/>
+            <a:off x="731520" y="8567928"/>
             <a:ext cx="256032" cy="256032"/>
           </a:xfrm>
           <a:prstGeom prst="rect">
@@ -20498,8 +20498,8 @@
         </p:nvSpPr>
         <p:spPr>
           <a:xfrm>
-            <a:off x="1097280" y="8631936"/>
-            <a:ext cx="1371600" cy="420624"/>
+            <a:off x="1097280" y="8467344"/>
+            <a:ext cx="1371600" cy="402336"/>
           </a:xfrm>
           <a:prstGeom prst="rect">
             <a:avLst/>
@@ -20517,7 +20517,7 @@
             <a:r>
               <a:rPr lang="en-US" sz="820" b="1" spc="60" kern="0" dirty="0">
                 <a:solidFill>
-                  <a:srgbClr val="1A1A1A"/>
+                  <a:srgbClr val="6E6E6E"/>
                 </a:solidFill>
                 <a:latin typeface="Arial" pitchFamily="34" charset="0"/>
                 <a:ea typeface="Arial" pitchFamily="34" charset="-122"/>
@@ -20537,8 +20537,8 @@
         </p:nvSpPr>
         <p:spPr>
           <a:xfrm>
-            <a:off x="2450592" y="8631936"/>
-            <a:ext cx="914400" cy="420624"/>
+            <a:off x="2450592" y="8467344"/>
+            <a:ext cx="914400" cy="402336"/>
           </a:xfrm>
           <a:prstGeom prst="rect">
             <a:avLst/>
@@ -20576,8 +20576,8 @@
         </p:nvSpPr>
         <p:spPr>
           <a:xfrm>
-            <a:off x="3310128" y="8631936"/>
-            <a:ext cx="969264" cy="420624"/>
+            <a:off x="3310128" y="8467344"/>
+            <a:ext cx="969264" cy="402336"/>
           </a:xfrm>
           <a:prstGeom prst="rect">
             <a:avLst/>
@@ -20615,8 +20615,8 @@
         </p:nvSpPr>
         <p:spPr>
           <a:xfrm>
-            <a:off x="4352544" y="8631936"/>
-            <a:ext cx="2551176" cy="420624"/>
+            <a:off x="4352544" y="8467344"/>
+            <a:ext cx="2551176" cy="402336"/>
           </a:xfrm>
           <a:prstGeom prst="rect">
             <a:avLst/>
@@ -20634,7 +20634,7 @@
             <a:r>
               <a:rPr lang="en-US" sz="780" dirty="0">
                 <a:solidFill>
-                  <a:srgbClr val="3E3E3E"/>
+                  <a:srgbClr val="9C9C9C"/>
                 </a:solidFill>
                 <a:latin typeface="Arial" pitchFamily="34" charset="0"/>
                 <a:ea typeface="Arial" pitchFamily="34" charset="-122"/>
@@ -20654,8 +20654,8 @@
         </p:nvSpPr>
         <p:spPr>
           <a:xfrm>
-            <a:off x="566928" y="9089136"/>
-            <a:ext cx="6428232" cy="420624"/>
+            <a:off x="566928" y="8906256"/>
+            <a:ext cx="6428232" cy="402336"/>
           </a:xfrm>
           <a:prstGeom prst="rect">
             <a:avLst/>
@@ -20674,8 +20674,8 @@
         </p:nvSpPr>
         <p:spPr>
           <a:xfrm>
-            <a:off x="566928" y="9089136"/>
-            <a:ext cx="36576" cy="420624"/>
+            <a:off x="566928" y="8906256"/>
+            <a:ext cx="36576" cy="402336"/>
           </a:xfrm>
           <a:prstGeom prst="rect">
             <a:avLst/>
@@ -20702,7 +20702,7 @@
         </p:blipFill>
         <p:spPr>
           <a:xfrm>
-            <a:off x="731520" y="9189720"/>
+            <a:off x="731520" y="9006840"/>
             <a:ext cx="256032" cy="256032"/>
           </a:xfrm>
           <a:prstGeom prst="rect">
@@ -20718,8 +20718,8 @@
         </p:nvSpPr>
         <p:spPr>
           <a:xfrm>
-            <a:off x="1097280" y="9089136"/>
-            <a:ext cx="1371600" cy="420624"/>
+            <a:off x="1097280" y="8906256"/>
+            <a:ext cx="1371600" cy="402336"/>
           </a:xfrm>
           <a:prstGeom prst="rect">
             <a:avLst/>
@@ -20757,8 +20757,8 @@
         </p:nvSpPr>
         <p:spPr>
           <a:xfrm>
-            <a:off x="2450592" y="9089136"/>
-            <a:ext cx="914400" cy="420624"/>
+            <a:off x="2450592" y="8906256"/>
+            <a:ext cx="914400" cy="402336"/>
           </a:xfrm>
           <a:prstGeom prst="rect">
             <a:avLst/>
@@ -20796,8 +20796,8 @@
         </p:nvSpPr>
         <p:spPr>
           <a:xfrm>
-            <a:off x="3310128" y="9089136"/>
-            <a:ext cx="969264" cy="420624"/>
+            <a:off x="3310128" y="8906256"/>
+            <a:ext cx="969264" cy="402336"/>
           </a:xfrm>
           <a:prstGeom prst="rect">
             <a:avLst/>
@@ -20835,8 +20835,8 @@
         </p:nvSpPr>
         <p:spPr>
           <a:xfrm>
-            <a:off x="4352544" y="9089136"/>
-            <a:ext cx="2551176" cy="420624"/>
+            <a:off x="4352544" y="8906256"/>
+            <a:ext cx="2551176" cy="402336"/>
           </a:xfrm>
           <a:prstGeom prst="rect">
             <a:avLst/>
@@ -20874,8 +20874,8 @@
         </p:nvSpPr>
         <p:spPr>
           <a:xfrm>
-            <a:off x="566928" y="9546336"/>
-            <a:ext cx="6428232" cy="420624"/>
+            <a:off x="566928" y="9345168"/>
+            <a:ext cx="6428232" cy="402336"/>
           </a:xfrm>
           <a:prstGeom prst="rect">
             <a:avLst/>
@@ -20894,8 +20894,8 @@
         </p:nvSpPr>
         <p:spPr>
           <a:xfrm>
-            <a:off x="566928" y="9546336"/>
-            <a:ext cx="36576" cy="420624"/>
+            <a:off x="566928" y="9345168"/>
+            <a:ext cx="36576" cy="402336"/>
           </a:xfrm>
           <a:prstGeom prst="rect">
             <a:avLst/>
@@ -20922,7 +20922,7 @@
         </p:blipFill>
         <p:spPr>
           <a:xfrm>
-            <a:off x="731520" y="9646920"/>
+            <a:off x="731520" y="9445752"/>
             <a:ext cx="256032" cy="256032"/>
           </a:xfrm>
           <a:prstGeom prst="rect">
@@ -20938,8 +20938,8 @@
         </p:nvSpPr>
         <p:spPr>
           <a:xfrm>
-            <a:off x="1097280" y="9546336"/>
-            <a:ext cx="1371600" cy="420624"/>
+            <a:off x="1097280" y="9345168"/>
+            <a:ext cx="1371600" cy="402336"/>
           </a:xfrm>
           <a:prstGeom prst="rect">
             <a:avLst/>
@@ -20957,7 +20957,7 @@
             <a:r>
               <a:rPr lang="en-US" sz="820" b="1" spc="60" kern="0" dirty="0">
                 <a:solidFill>
-                  <a:srgbClr val="1A1A1A"/>
+                  <a:srgbClr val="6E6E6E"/>
                 </a:solidFill>
                 <a:latin typeface="Arial" pitchFamily="34" charset="0"/>
                 <a:ea typeface="Arial" pitchFamily="34" charset="-122"/>
@@ -20977,8 +20977,8 @@
         </p:nvSpPr>
         <p:spPr>
           <a:xfrm>
-            <a:off x="2450592" y="9546336"/>
-            <a:ext cx="914400" cy="420624"/>
+            <a:off x="2450592" y="9345168"/>
+            <a:ext cx="914400" cy="402336"/>
           </a:xfrm>
           <a:prstGeom prst="rect">
             <a:avLst/>
@@ -21016,8 +21016,8 @@
         </p:nvSpPr>
         <p:spPr>
           <a:xfrm>
-            <a:off x="3310128" y="9546336"/>
-            <a:ext cx="969264" cy="420624"/>
+            <a:off x="3310128" y="9345168"/>
+            <a:ext cx="969264" cy="402336"/>
           </a:xfrm>
           <a:prstGeom prst="rect">
             <a:avLst/>
@@ -21055,8 +21055,8 @@
         </p:nvSpPr>
         <p:spPr>
           <a:xfrm>
-            <a:off x="4352544" y="9546336"/>
-            <a:ext cx="2551176" cy="420624"/>
+            <a:off x="4352544" y="9345168"/>
+            <a:ext cx="2551176" cy="402336"/>
           </a:xfrm>
           <a:prstGeom prst="rect">
             <a:avLst/>
@@ -21074,7 +21074,7 @@
             <a:r>
               <a:rPr lang="en-US" sz="780" dirty="0">
                 <a:solidFill>
-                  <a:srgbClr val="3E3E3E"/>
+                  <a:srgbClr val="9C9C9C"/>
                 </a:solidFill>
                 <a:latin typeface="Arial" pitchFamily="34" charset="0"/>
                 <a:ea typeface="Arial" pitchFamily="34" charset="-122"/>
@@ -21083,6 +21083,45 @@
               <a:t>A discontinuity to be managed</a:t>
             </a:r>
             <a:endParaRPr lang="en-US" sz="780" dirty="0"/>
+          </a:p>
+        </p:txBody>
+      </p:sp>
+      <p:sp>
+        <p:nvSpPr>
+          <p:cNvPr id="108" name="Text 93"/>
+          <p:cNvSpPr/>
+          <p:nvPr/>
+        </p:nvSpPr>
+        <p:spPr>
+          <a:xfrm>
+            <a:off x="566928" y="9857232"/>
+            <a:ext cx="6428232" cy="164592"/>
+          </a:xfrm>
+          <a:prstGeom prst="rect">
+            <a:avLst/>
+          </a:prstGeom>
+          <a:noFill/>
+          <a:ln/>
+        </p:spPr>
+        <p:txBody>
+          <a:bodyPr wrap="square" lIns="0" tIns="0" rIns="0" bIns="0" rtlCol="0" anchor="ctr"/>
+          <a:lstStyle/>
+          <a:p>
+            <a:pPr algn="l" indent="0" marL="0">
+              <a:buNone/>
+            </a:pPr>
+            <a:r>
+              <a:rPr lang="en-US" sz="740" i="1" dirty="0">
+                <a:solidFill>
+                  <a:srgbClr val="6E6E6E"/>
+                </a:solidFill>
+                <a:latin typeface="Arial" pitchFamily="34" charset="0"/>
+                <a:ea typeface="Arial" pitchFamily="34" charset="-122"/>
+                <a:cs typeface="Arial" pitchFamily="34" charset="-120"/>
+              </a:rPr>
+              <a:t>Greyed rows are candidate extensions: drafted to prove the grammar extends, and introduced only when the pilot shows the distinction is needed.</a:t>
+            </a:r>
+            <a:endParaRPr lang="en-US" sz="740" dirty="0"/>
           </a:p>
         </p:txBody>
       </p:sp>
@@ -21369,7 +21408,7 @@
                 <a:ea typeface="Arial" pitchFamily="34" charset="-122"/>
                 <a:cs typeface="Arial" pitchFamily="34" charset="-120"/>
               </a:rPr>
-              <a:t>DRAFT V0.4   |   AUGUST 2026</a:t>
+              <a:t>DRAFT V0.5   |   AUGUST 2026</a:t>
             </a:r>
             <a:endParaRPr lang="en-US" sz="600" dirty="0"/>
           </a:p>
@@ -23376,7 +23415,7 @@
                 <a:ea typeface="Arial" pitchFamily="34" charset="-122"/>
                 <a:cs typeface="Arial" pitchFamily="34" charset="-120"/>
               </a:rPr>
-              <a:t>DRAFT V0.4   |   AUGUST 2026</a:t>
+              <a:t>DRAFT V0.5   |   AUGUST 2026</a:t>
             </a:r>
             <a:endParaRPr lang="en-US" sz="600" dirty="0"/>
           </a:p>
@@ -24490,7 +24529,7 @@
                 <a:ea typeface="Arial" pitchFamily="34" charset="-122"/>
                 <a:cs typeface="Arial" pitchFamily="34" charset="-120"/>
               </a:rPr>
-              <a:t>DRAFT V0.4   |   AUGUST 2026</a:t>
+              <a:t>DRAFT V0.5   |   AUGUST 2026</a:t>
             </a:r>
             <a:endParaRPr lang="en-US" sz="600" dirty="0"/>
           </a:p>
@@ -25919,7 +25958,7 @@
                 <a:ea typeface="Arial" pitchFamily="34" charset="-122"/>
                 <a:cs typeface="Arial" pitchFamily="34" charset="-120"/>
               </a:rPr>
-              <a:t>DRAFT V0.4   |   AUGUST 2026</a:t>
+              <a:t>DRAFT V0.5   |   AUGUST 2026</a:t>
             </a:r>
             <a:endParaRPr lang="en-US" sz="600" dirty="0"/>
           </a:p>
@@ -27586,7 +27625,7 @@
                 <a:ea typeface="Arial" pitchFamily="34" charset="-122"/>
                 <a:cs typeface="Arial" pitchFamily="34" charset="-120"/>
               </a:rPr>
-              <a:t>DRAFT V0.4   |   AUGUST 2026</a:t>
+              <a:t>DRAFT V0.5   |   AUGUST 2026</a:t>
             </a:r>
             <a:endParaRPr lang="en-US" sz="600" dirty="0"/>
           </a:p>
@@ -29474,7 +29513,7 @@
                 <a:ea typeface="Arial" pitchFamily="34" charset="-122"/>
                 <a:cs typeface="Arial" pitchFamily="34" charset="-120"/>
               </a:rPr>
-              <a:t>DRAFT V0.4   |   AUGUST 2026</a:t>
+              <a:t>DRAFT V0.5   |   AUGUST 2026</a:t>
             </a:r>
             <a:endParaRPr lang="en-US" sz="600" dirty="0"/>
           </a:p>
@@ -30422,7 +30461,7 @@
                 <a:ea typeface="Arial" pitchFamily="34" charset="-122"/>
                 <a:cs typeface="Arial" pitchFamily="34" charset="-120"/>
               </a:rPr>
-              <a:t>DRAFT V0.4   |   AUGUST 2026</a:t>
+              <a:t>DRAFT V0.5   |   AUGUST 2026</a:t>
             </a:r>
             <a:endParaRPr lang="en-US" sz="600" dirty="0"/>
           </a:p>
@@ -30820,7 +30859,7 @@
                 <a:ea typeface="Arial" pitchFamily="34" charset="-122"/>
                 <a:cs typeface="Arial" pitchFamily="34" charset="-120"/>
               </a:rPr>
-              <a:t>Agree that doctrine and controlled information systems are the visual precedent, without claiming doctrinal status for the framework itself. Everything else follows from this position and nothing should be built before it is settled.</a:t>
+              <a:t>Agree that doctrine and controlled information systems are the visual precedent, without claiming doctrinal status for the framework itself. Everything else follows from this position, and no production assets or enduring templates should be issued before it is settled.</a:t>
             </a:r>
             <a:endParaRPr lang="en-US" sz="860" dirty="0"/>
           </a:p>
@@ -32006,7 +32045,7 @@
                 <a:ea typeface="Arial" pitchFamily="34" charset="-122"/>
                 <a:cs typeface="Arial" pitchFamily="34" charset="-120"/>
               </a:rPr>
-              <a:t>DRAFT V0.4   |   AUGUST 2026</a:t>
+              <a:t>DRAFT V0.5   |   AUGUST 2026</a:t>
             </a:r>
             <a:endParaRPr lang="en-US" sz="600" dirty="0"/>
           </a:p>
@@ -32716,7 +32755,7 @@
                 <a:ea typeface="Arial" pitchFamily="34" charset="-122"/>
                 <a:cs typeface="Arial" pitchFamily="34" charset="-120"/>
               </a:rPr>
-              <a:t>No mark, no badge, no patch, no symbol. The identity is carried by typography and structure.</a:t>
+              <a:t>No freestanding brand mark, badge, patch or symbol. The identity is carried by typography, structure and functional notation.</a:t>
             </a:r>
             <a:endParaRPr lang="en-US" sz="900" dirty="0"/>
           </a:p>
@@ -33728,7 +33767,7 @@
                 <a:ea typeface="Arial" pitchFamily="34" charset="-122"/>
                 <a:cs typeface="Arial" pitchFamily="34" charset="-120"/>
               </a:rPr>
-              <a:t>DRAFT V0.4   |   AUGUST 2026</a:t>
+              <a:t>DRAFT V0.5   |   AUGUST 2026</a:t>
             </a:r>
             <a:endParaRPr lang="en-US" sz="600" dirty="0"/>
           </a:p>
@@ -35024,7 +35063,7 @@
                 <a:ea typeface="Arial" pitchFamily="34" charset="-122"/>
                 <a:cs typeface="Arial" pitchFamily="34" charset="-120"/>
               </a:rPr>
-              <a:t>DRAFT V0.4   |   AUGUST 2026</a:t>
+              <a:t>DRAFT V0.5   |   AUGUST 2026</a:t>
             </a:r>
             <a:endParaRPr lang="en-US" sz="600" dirty="0"/>
           </a:p>
@@ -37174,7 +37213,7 @@
                 <a:ea typeface="Arial" pitchFamily="34" charset="-122"/>
                 <a:cs typeface="Arial" pitchFamily="34" charset="-120"/>
               </a:rPr>
-              <a:t>DRAFT V0.4   |   AUGUST 2026</a:t>
+              <a:t>DRAFT V0.5   |   AUGUST 2026</a:t>
             </a:r>
             <a:endParaRPr lang="en-US" sz="600" dirty="0"/>
           </a:p>
@@ -38701,7 +38740,7 @@
                 <a:ea typeface="Arial" pitchFamily="34" charset="-122"/>
                 <a:cs typeface="Arial" pitchFamily="34" charset="-120"/>
               </a:rPr>
-              <a:t>DRAFT V0.4   |   AUGUST 2026</a:t>
+              <a:t>DRAFT V0.5   |   AUGUST 2026</a:t>
             </a:r>
             <a:endParaRPr lang="en-US" sz="600" dirty="0"/>
           </a:p>
@@ -39907,7 +39946,7 @@
                 <a:ea typeface="Arial" pitchFamily="34" charset="-122"/>
                 <a:cs typeface="Arial" pitchFamily="34" charset="-120"/>
               </a:rPr>
-              <a:t>DRAFT V0.4   |   AUGUST 2026</a:t>
+              <a:t>DRAFT V0.5   |   AUGUST 2026</a:t>
             </a:r>
             <a:endParaRPr lang="en-US" sz="600" dirty="0"/>
           </a:p>
@@ -41113,7 +41152,7 @@
                 <a:ea typeface="Arial" pitchFamily="34" charset="-122"/>
                 <a:cs typeface="Arial" pitchFamily="34" charset="-120"/>
               </a:rPr>
-              <a:t>DRAFT V0.4   |   AUGUST 2026</a:t>
+              <a:t>DRAFT V0.5   |   AUGUST 2026</a:t>
             </a:r>
             <a:endParaRPr lang="en-US" sz="600" dirty="0"/>
           </a:p>

</xml_diff>

<commit_message>
Identity system V0.6: lock in Datum as the selected concept
Datum is adopted rather than recommended. Concept pages now carry a
status band, selected or not adopted, with the red marker reserved for
the selected one. Page 10 becomes Evaluation and decision, and the panel
records a decision taken rather than an option offered. Contents,
governance and the cover status follow. The datum joins the must not
change list as the governing device. Threshold and Trace are retained in
full so the reasons for not adopting them survive.

Co-Authored-By: Claude Fable 5 <noreply@anthropic.com>
Claude-Session: https://claude.ai/code/session_01YLo1WfwUDkbwfJEF3ZNVbB
</commit_message>
<xml_diff>
--- a/output/combat-mindset-identity-system.pptx
+++ b/output/combat-mindset-identity-system.pptx
@@ -3268,7 +3268,7 @@
                 <a:ea typeface="Arial" pitchFamily="34" charset="-122"/>
                 <a:cs typeface="Arial" pitchFamily="34" charset="-120"/>
               </a:rPr>
-              <a:t>Draft for review. Not an approved standard.</a:t>
+              <a:t>Governing concept selected. Draft for review; not an approved standard.</a:t>
             </a:r>
             <a:endParaRPr lang="en-US" sz="800" dirty="0"/>
           </a:p>
@@ -3349,7 +3349,7 @@
                 <a:ea typeface="Arial" pitchFamily="34" charset="-122"/>
                 <a:cs typeface="Arial" pitchFamily="34" charset="-120"/>
               </a:rPr>
-              <a:t>V0.5, August 2026</a:t>
+              <a:t>V0.6, August 2026</a:t>
             </a:r>
             <a:endParaRPr lang="en-US" sz="800" dirty="0"/>
           </a:p>
@@ -3420,7 +3420,7 @@
                 <a:ea typeface="Arial" pitchFamily="34" charset="-122"/>
                 <a:cs typeface="Arial" pitchFamily="34" charset="-120"/>
               </a:rPr>
-              <a:t>RECOMMENDATION</a:t>
+              <a:t>DECISION</a:t>
             </a:r>
             <a:endParaRPr lang="en-US" sz="700" dirty="0"/>
           </a:p>
@@ -3518,7 +3518,7 @@
                 <a:ea typeface="Arial" pitchFamily="34" charset="-122"/>
                 <a:cs typeface="Arial" pitchFamily="34" charset="-120"/>
               </a:rPr>
-              <a:t>Evaluation and recommendation</a:t>
+              <a:t>Evaluation and decision</a:t>
             </a:r>
             <a:endParaRPr lang="en-US" sz="1900" dirty="0"/>
           </a:p>
@@ -3560,7 +3560,7 @@
                 <a:ea typeface="Arial" pitchFamily="34" charset="-122"/>
                 <a:cs typeface="Arial" pitchFamily="34" charset="-120"/>
               </a:rPr>
-              <a:t>Scored against the criteria that matter for a system intended to last twenty years, not against which concept looks best on a cover.</a:t>
+              <a:t>Scored against the criteria that matter for a system intended to last twenty years, not against which concept looks best on a cover. The decision below is taken; it is the constraint the specification is built on, not an option left open for review.</a:t>
             </a:r>
             <a:endParaRPr lang="en-US" sz="960" dirty="0"/>
           </a:p>
@@ -3638,7 +3638,7 @@
                 <a:ea typeface="Arial" pitchFamily="34" charset="-122"/>
                 <a:cs typeface="Arial" pitchFamily="34" charset="-120"/>
               </a:rPr>
-              <a:t>DRAFT V0.5   |   AUGUST 2026</a:t>
+              <a:t>DRAFT V0.6   |   AUGUST 2026</a:t>
             </a:r>
             <a:endParaRPr lang="en-US" sz="600" dirty="0"/>
           </a:p>
@@ -6055,7 +6055,7 @@
                 <a:ea typeface="Arial" pitchFamily="34" charset="-122"/>
                 <a:cs typeface="Arial" pitchFamily="34" charset="-120"/>
               </a:rPr>
-              <a:t>RECOMMENDATION</a:t>
+              <a:t>DECISION</a:t>
             </a:r>
             <a:endParaRPr lang="en-US" sz="740" dirty="0"/>
           </a:p>
@@ -6103,7 +6103,27 @@
       </p:sp>
       <p:sp>
         <p:nvSpPr>
-          <p:cNvPr id="121" name="Text 119"/>
+          <p:cNvPr id="121" name="Shape 119"/>
+          <p:cNvSpPr/>
+          <p:nvPr/>
+        </p:nvSpPr>
+        <p:spPr>
+          <a:xfrm>
+            <a:off x="566928" y="4681728"/>
+            <a:ext cx="54864" cy="1225296"/>
+          </a:xfrm>
+          <a:prstGeom prst="rect">
+            <a:avLst/>
+          </a:prstGeom>
+          <a:solidFill>
+            <a:srgbClr val="D31145"/>
+          </a:solidFill>
+          <a:ln/>
+        </p:spPr>
+      </p:sp>
+      <p:sp>
+        <p:nvSpPr>
+          <p:cNvPr id="122" name="Text 120"/>
           <p:cNvSpPr/>
           <p:nvPr/>
         </p:nvSpPr>
@@ -6134,7 +6154,7 @@
                 <a:ea typeface="Arial" pitchFamily="34" charset="-122"/>
                 <a:cs typeface="Arial" pitchFamily="34" charset="-120"/>
               </a:rPr>
-              <a:t>Adopt Concept A, Datum, as the governing system.</a:t>
+              <a:t>Datum is adopted as the governing system.</a:t>
             </a:r>
             <a:endParaRPr lang="en-US" sz="1500" dirty="0"/>
           </a:p>
@@ -6142,7 +6162,7 @@
       </p:sp>
       <p:sp>
         <p:nvSpPr>
-          <p:cNvPr id="122" name="Text 120"/>
+          <p:cNvPr id="123" name="Text 121"/>
           <p:cNvSpPr/>
           <p:nvPr/>
         </p:nvSpPr>
@@ -6176,7 +6196,7 @@
                 <a:ea typeface="Arial" pitchFamily="34" charset="-122"/>
                 <a:cs typeface="Arial" pitchFamily="34" charset="-120"/>
               </a:rPr>
-              <a:t>Take the node and departure device from Concept C as its only dynamic element, used solely to mark decision. Retain the density field from Concept B as texture, rationed to divider surfaces and never behind text.</a:t>
+              <a:t>The node and departure from Concept C are retained as its only dynamic element, used solely to mark decision. The density field from Concept B is retained as texture, rationed to divider surfaces and never behind text. Threshold and Trace are not adopted, and are recorded so the reasons survive the people who rejected them.</a:t>
             </a:r>
             <a:endParaRPr lang="en-US" sz="940" dirty="0"/>
           </a:p>
@@ -6184,7 +6204,7 @@
       </p:sp>
       <p:sp>
         <p:nvSpPr>
-          <p:cNvPr id="123" name="Text 121"/>
+          <p:cNvPr id="124" name="Text 122"/>
           <p:cNvSpPr/>
           <p:nvPr/>
         </p:nvSpPr>
@@ -6215,7 +6235,7 @@
                 <a:ea typeface="Arial" pitchFamily="34" charset="-122"/>
                 <a:cs typeface="Arial" pitchFamily="34" charset="-120"/>
               </a:rPr>
-              <a:t>WHY, AND WHAT IS BEING GIVEN UP</a:t>
+              <a:t>WHY, AND WHAT WAS GIVEN UP</a:t>
             </a:r>
             <a:endParaRPr lang="en-US" sz="740" dirty="0"/>
           </a:p>
@@ -6223,7 +6243,7 @@
       </p:sp>
       <p:sp>
         <p:nvSpPr>
-          <p:cNvPr id="124" name="Shape 122"/>
+          <p:cNvPr id="125" name="Shape 123"/>
           <p:cNvSpPr/>
           <p:nvPr/>
         </p:nvSpPr>
@@ -6243,7 +6263,7 @@
       </p:sp>
       <p:sp>
         <p:nvSpPr>
-          <p:cNvPr id="125" name="Text 123"/>
+          <p:cNvPr id="126" name="Text 124"/>
           <p:cNvSpPr/>
           <p:nvPr/>
         </p:nvSpPr>
@@ -6285,7 +6305,7 @@
       </p:sp>
       <p:sp>
         <p:nvSpPr>
-          <p:cNvPr id="126" name="Text 124"/>
+          <p:cNvPr id="127" name="Text 125"/>
           <p:cNvSpPr/>
           <p:nvPr/>
         </p:nvSpPr>
@@ -6319,7 +6339,7 @@
                 <a:ea typeface="Arial" pitchFamily="34" charset="-122"/>
                 <a:cs typeface="Arial" pitchFamily="34" charset="-120"/>
               </a:rPr>
-              <a:t>What is given up is immediate emotional impact. Threshold is the stronger first impression and it is being deliberately declined, because the objective stated in the brief is trust rather than recognition, and trust is built by the twentieth artefact rather than the first. Trace is the sharpest expression of decision, which is why its node is retained rather than the whole concept: adopted wholesale it would pull the system toward a data-visualisation aesthetic that will age badly.</a:t>
+              <a:t>What was given up is immediate emotional impact. Threshold is the stronger first impression and it was deliberately declined, because the objective stated in the brief is trust rather than recognition, and trust is built by the twentieth artefact rather than the first. Trace is the sharpest expression of decision, which is why its node was retained rather than the whole concept: adopted wholesale it would have pulled the system toward a data-visualisation aesthetic that will age badly.</a:t>
             </a:r>
             <a:endParaRPr lang="en-US" sz="920" dirty="0"/>
           </a:p>
@@ -6327,7 +6347,7 @@
       </p:sp>
       <p:pic>
         <p:nvPicPr>
-          <p:cNvPr id="127" name="Image 0" descr="preencoded.png">    </p:cNvPr>
+          <p:cNvPr id="128" name="Image 0" descr="preencoded.png">    </p:cNvPr>
           <p:cNvPicPr>
             <a:picLocks noChangeAspect="1"/>
           </p:cNvPicPr>
@@ -6351,7 +6371,7 @@
       </p:pic>
       <p:sp>
         <p:nvSpPr>
-          <p:cNvPr id="128" name="Text 125"/>
+          <p:cNvPr id="129" name="Text 126"/>
           <p:cNvSpPr/>
           <p:nvPr/>
         </p:nvSpPr>
@@ -6382,7 +6402,7 @@
                 <a:ea typeface="Arial" pitchFamily="34" charset="-122"/>
                 <a:cs typeface="Arial" pitchFamily="34" charset="-120"/>
               </a:rPr>
-              <a:t>The recommended system: datum as spine, nodes for decision, density rationed to texture. Shown here carrying the five phase framework development programme.</a:t>
+              <a:t>The adopted system: datum as spine, nodes for decision, density rationed to texture. Shown here carrying the five phase framework development programme.</a:t>
             </a:r>
             <a:endParaRPr lang="en-US" sz="780" dirty="0"/>
           </a:p>
@@ -6671,7 +6691,7 @@
                 <a:ea typeface="Arial" pitchFamily="34" charset="-122"/>
                 <a:cs typeface="Arial" pitchFamily="34" charset="-120"/>
               </a:rPr>
-              <a:t>DRAFT V0.5   |   AUGUST 2026</a:t>
+              <a:t>DRAFT V0.6   |   AUGUST 2026</a:t>
             </a:r>
             <a:endParaRPr lang="en-US" sz="600" dirty="0"/>
           </a:p>
@@ -8707,7 +8727,7 @@
                 <a:ea typeface="Arial" pitchFamily="34" charset="-122"/>
                 <a:cs typeface="Arial" pitchFamily="34" charset="-120"/>
               </a:rPr>
-              <a:t>DRAFT V0.5   |   AUGUST 2026</a:t>
+              <a:t>DRAFT V0.6   |   AUGUST 2026</a:t>
             </a:r>
             <a:endParaRPr lang="en-US" sz="600" dirty="0"/>
           </a:p>
@@ -10382,7 +10402,7 @@
                 <a:ea typeface="Arial" pitchFamily="34" charset="-122"/>
                 <a:cs typeface="Arial" pitchFamily="34" charset="-120"/>
               </a:rPr>
-              <a:t>DRAFT V0.5   |   AUGUST 2026</a:t>
+              <a:t>DRAFT V0.6   |   AUGUST 2026</a:t>
             </a:r>
             <a:endParaRPr lang="en-US" sz="600" dirty="0"/>
           </a:p>
@@ -12312,7 +12332,7 @@
                 <a:ea typeface="Arial" pitchFamily="34" charset="-122"/>
                 <a:cs typeface="Arial" pitchFamily="34" charset="-120"/>
               </a:rPr>
-              <a:t>DRAFT V0.5   |   AUGUST 2026</a:t>
+              <a:t>DRAFT V0.6   |   AUGUST 2026</a:t>
             </a:r>
             <a:endParaRPr lang="en-US" sz="600" dirty="0"/>
           </a:p>
@@ -16115,7 +16135,7 @@
                 <a:ea typeface="Arial" pitchFamily="34" charset="-122"/>
                 <a:cs typeface="Arial" pitchFamily="34" charset="-120"/>
               </a:rPr>
-              <a:t>DRAFT V0.5   |   AUGUST 2026</a:t>
+              <a:t>DRAFT V0.6   |   AUGUST 2026</a:t>
             </a:r>
             <a:endParaRPr lang="en-US" sz="600" dirty="0"/>
           </a:p>
@@ -17938,7 +17958,7 @@
                 <a:ea typeface="Arial" pitchFamily="34" charset="-122"/>
                 <a:cs typeface="Arial" pitchFamily="34" charset="-120"/>
               </a:rPr>
-              <a:t>DRAFT V0.5   |   AUGUST 2026</a:t>
+              <a:t>DRAFT V0.6   |   AUGUST 2026</a:t>
             </a:r>
             <a:endParaRPr lang="en-US" sz="600" dirty="0"/>
           </a:p>
@@ -21408,7 +21428,7 @@
                 <a:ea typeface="Arial" pitchFamily="34" charset="-122"/>
                 <a:cs typeface="Arial" pitchFamily="34" charset="-120"/>
               </a:rPr>
-              <a:t>DRAFT V0.5   |   AUGUST 2026</a:t>
+              <a:t>DRAFT V0.6   |   AUGUST 2026</a:t>
             </a:r>
             <a:endParaRPr lang="en-US" sz="600" dirty="0"/>
           </a:p>
@@ -23415,7 +23435,7 @@
                 <a:ea typeface="Arial" pitchFamily="34" charset="-122"/>
                 <a:cs typeface="Arial" pitchFamily="34" charset="-120"/>
               </a:rPr>
-              <a:t>DRAFT V0.5   |   AUGUST 2026</a:t>
+              <a:t>DRAFT V0.6   |   AUGUST 2026</a:t>
             </a:r>
             <a:endParaRPr lang="en-US" sz="600" dirty="0"/>
           </a:p>
@@ -24529,7 +24549,7 @@
                 <a:ea typeface="Arial" pitchFamily="34" charset="-122"/>
                 <a:cs typeface="Arial" pitchFamily="34" charset="-120"/>
               </a:rPr>
-              <a:t>DRAFT V0.5   |   AUGUST 2026</a:t>
+              <a:t>DRAFT V0.6   |   AUGUST 2026</a:t>
             </a:r>
             <a:endParaRPr lang="en-US" sz="600" dirty="0"/>
           </a:p>
@@ -25958,7 +25978,7 @@
                 <a:ea typeface="Arial" pitchFamily="34" charset="-122"/>
                 <a:cs typeface="Arial" pitchFamily="34" charset="-120"/>
               </a:rPr>
-              <a:t>DRAFT V0.5   |   AUGUST 2026</a:t>
+              <a:t>DRAFT V0.6   |   AUGUST 2026</a:t>
             </a:r>
             <a:endParaRPr lang="en-US" sz="600" dirty="0"/>
           </a:p>
@@ -26751,7 +26771,7 @@
                 <a:ea typeface="Arial" pitchFamily="34" charset="-122"/>
                 <a:cs typeface="Arial" pitchFamily="34" charset="-120"/>
               </a:rPr>
-              <a:t>07    Concept A: Datum</a:t>
+              <a:t>07    Selected concept: Datum</a:t>
             </a:r>
             <a:endParaRPr lang="en-US" sz="860" dirty="0"/>
           </a:p>
@@ -26790,7 +26810,7 @@
                 <a:ea typeface="Arial" pitchFamily="34" charset="-122"/>
                 <a:cs typeface="Arial" pitchFamily="34" charset="-120"/>
               </a:rPr>
-              <a:t>08    Concept B: Threshold</a:t>
+              <a:t>08    Considered: Threshold</a:t>
             </a:r>
             <a:endParaRPr lang="en-US" sz="860" dirty="0"/>
           </a:p>
@@ -26829,7 +26849,7 @@
                 <a:ea typeface="Arial" pitchFamily="34" charset="-122"/>
                 <a:cs typeface="Arial" pitchFamily="34" charset="-120"/>
               </a:rPr>
-              <a:t>09    Concept C: Trace</a:t>
+              <a:t>09    Considered: Trace</a:t>
             </a:r>
             <a:endParaRPr lang="en-US" sz="860" dirty="0"/>
           </a:p>
@@ -26868,7 +26888,7 @@
                 <a:ea typeface="Arial" pitchFamily="34" charset="-122"/>
                 <a:cs typeface="Arial" pitchFamily="34" charset="-120"/>
               </a:rPr>
-              <a:t>10    Evaluation and recommendation</a:t>
+              <a:t>10    Evaluation and decision</a:t>
             </a:r>
             <a:endParaRPr lang="en-US" sz="860" dirty="0"/>
           </a:p>
@@ -27625,7 +27645,7 @@
                 <a:ea typeface="Arial" pitchFamily="34" charset="-122"/>
                 <a:cs typeface="Arial" pitchFamily="34" charset="-120"/>
               </a:rPr>
-              <a:t>DRAFT V0.5   |   AUGUST 2026</a:t>
+              <a:t>DRAFT V0.6   |   AUGUST 2026</a:t>
             </a:r>
             <a:endParaRPr lang="en-US" sz="600" dirty="0"/>
           </a:p>
@@ -29513,7 +29533,7 @@
                 <a:ea typeface="Arial" pitchFamily="34" charset="-122"/>
                 <a:cs typeface="Arial" pitchFamily="34" charset="-120"/>
               </a:rPr>
-              <a:t>DRAFT V0.5   |   AUGUST 2026</a:t>
+              <a:t>DRAFT V0.6   |   AUGUST 2026</a:t>
             </a:r>
             <a:endParaRPr lang="en-US" sz="600" dirty="0"/>
           </a:p>
@@ -29959,6 +29979,30 @@
         <p:txBody>
           <a:bodyPr wrap="square" lIns="0" tIns="0" rIns="0" bIns="0" rtlCol="0" anchor="t"/>
           <a:lstStyle/>
+          <a:p>
+            <a:pPr algn="l" marL="177800" indent="-177800">
+              <a:lnSpc>
+                <a:spcPct val="122000"/>
+              </a:lnSpc>
+              <a:spcAft>
+                <a:spcPts val="500"/>
+              </a:spcAft>
+              <a:buSzPct val="100000"/>
+              <a:buChar char="–"/>
+            </a:pPr>
+            <a:r>
+              <a:rPr lang="en-US" sz="840" dirty="0">
+                <a:solidFill>
+                  <a:srgbClr val="1A1A1A"/>
+                </a:solidFill>
+                <a:latin typeface="Arial" pitchFamily="34" charset="0"/>
+                <a:ea typeface="Arial" pitchFamily="34" charset="-122"/>
+                <a:cs typeface="Arial" pitchFamily="34" charset="-120"/>
+              </a:rPr>
+              <a:t>The datum itself. It is the governing device, selected against five criteria, and the system has no second spine.</a:t>
+            </a:r>
+            <a:endParaRPr lang="en-US" sz="840" dirty="0"/>
+          </a:p>
           <a:p>
             <a:pPr algn="l" marL="177800" indent="-177800">
               <a:lnSpc>
@@ -30461,7 +30505,7 @@
                 <a:ea typeface="Arial" pitchFamily="34" charset="-122"/>
                 <a:cs typeface="Arial" pitchFamily="34" charset="-120"/>
               </a:rPr>
-              <a:t>DRAFT V0.5   |   AUGUST 2026</a:t>
+              <a:t>DRAFT V0.6   |   AUGUST 2026</a:t>
             </a:r>
             <a:endParaRPr lang="en-US" sz="600" dirty="0"/>
           </a:p>
@@ -30859,7 +30903,7 @@
                 <a:ea typeface="Arial" pitchFamily="34" charset="-122"/>
                 <a:cs typeface="Arial" pitchFamily="34" charset="-120"/>
               </a:rPr>
-              <a:t>Agree that doctrine and controlled information systems are the visual precedent, without claiming doctrinal status for the framework itself. Everything else follows from this position, and no production assets or enduring templates should be issued before it is settled.</a:t>
+              <a:t>Agree that doctrine and controlled information systems are the visual precedent, without claiming doctrinal status for the framework itself. The governing concept is settled: Datum is adopted, and the review is not asked to reopen it. No production assets or enduring templates should be issued before the position is agreed.</a:t>
             </a:r>
             <a:endParaRPr lang="en-US" sz="860" dirty="0"/>
           </a:p>
@@ -31038,7 +31082,7 @@
                 <a:ea typeface="Arial" pitchFamily="34" charset="-122"/>
                 <a:cs typeface="Arial" pitchFamily="34" charset="-120"/>
               </a:rPr>
-              <a:t>Put the position and the specification to DPA. Expect challenge on the title treatment, the notation family, and the derivation of the field from the Army chevron pattern. Obtain the vector Army logo at the same time.</a:t>
+              <a:t>Put the position, the adopted concept and the specification to DPA. Expect challenge on the title treatment, the notation family, and the derivation of the field from the Army chevron pattern. Obtain the vector Army logo at the same time.</a:t>
             </a:r>
             <a:endParaRPr lang="en-US" sz="860" dirty="0"/>
           </a:p>
@@ -32045,7 +32089,7 @@
                 <a:ea typeface="Arial" pitchFamily="34" charset="-122"/>
                 <a:cs typeface="Arial" pitchFamily="34" charset="-120"/>
               </a:rPr>
-              <a:t>DRAFT V0.5   |   AUGUST 2026</a:t>
+              <a:t>DRAFT V0.6   |   AUGUST 2026</a:t>
             </a:r>
             <a:endParaRPr lang="en-US" sz="600" dirty="0"/>
           </a:p>
@@ -33767,7 +33811,7 @@
                 <a:ea typeface="Arial" pitchFamily="34" charset="-122"/>
                 <a:cs typeface="Arial" pitchFamily="34" charset="-120"/>
               </a:rPr>
-              <a:t>DRAFT V0.5   |   AUGUST 2026</a:t>
+              <a:t>DRAFT V0.6   |   AUGUST 2026</a:t>
             </a:r>
             <a:endParaRPr lang="en-US" sz="600" dirty="0"/>
           </a:p>
@@ -35063,7 +35107,7 @@
                 <a:ea typeface="Arial" pitchFamily="34" charset="-122"/>
                 <a:cs typeface="Arial" pitchFamily="34" charset="-120"/>
               </a:rPr>
-              <a:t>DRAFT V0.5   |   AUGUST 2026</a:t>
+              <a:t>DRAFT V0.6   |   AUGUST 2026</a:t>
             </a:r>
             <a:endParaRPr lang="en-US" sz="600" dirty="0"/>
           </a:p>
@@ -37213,7 +37257,7 @@
                 <a:ea typeface="Arial" pitchFamily="34" charset="-122"/>
                 <a:cs typeface="Arial" pitchFamily="34" charset="-120"/>
               </a:rPr>
-              <a:t>DRAFT V0.5   |   AUGUST 2026</a:t>
+              <a:t>DRAFT V0.6   |   AUGUST 2026</a:t>
             </a:r>
             <a:endParaRPr lang="en-US" sz="600" dirty="0"/>
           </a:p>
@@ -38522,7 +38566,7 @@
                 <a:ea typeface="Arial" pitchFamily="34" charset="-122"/>
                 <a:cs typeface="Arial" pitchFamily="34" charset="-120"/>
               </a:rPr>
-              <a:t>CONCEPT A</a:t>
+              <a:t>SELECTED CONCEPT</a:t>
             </a:r>
             <a:endParaRPr lang="en-US" sz="700" dirty="0"/>
           </a:p>
@@ -38740,7 +38784,7 @@
                 <a:ea typeface="Arial" pitchFamily="34" charset="-122"/>
                 <a:cs typeface="Arial" pitchFamily="34" charset="-120"/>
               </a:rPr>
-              <a:t>DRAFT V0.5   |   AUGUST 2026</a:t>
+              <a:t>DRAFT V0.6   |   AUGUST 2026</a:t>
             </a:r>
             <a:endParaRPr lang="en-US" sz="600" dirty="0"/>
           </a:p>
@@ -38779,26 +38823,85 @@
         <p:spPr>
           <a:xfrm>
             <a:off x="566928" y="3144114"/>
-            <a:ext cx="6428232" cy="12802"/>
+            <a:ext cx="6428232" cy="237744"/>
           </a:xfrm>
           <a:prstGeom prst="rect">
             <a:avLst/>
           </a:prstGeom>
           <a:solidFill>
-            <a:srgbClr val="00261B"/>
+            <a:srgbClr val="1A1A1A"/>
           </a:solidFill>
           <a:ln/>
         </p:spPr>
       </p:sp>
       <p:sp>
         <p:nvSpPr>
-          <p:cNvPr id="11" name="Text 8"/>
-          <p:cNvSpPr/>
-          <p:nvPr/>
-        </p:nvSpPr>
-        <p:spPr>
-          <a:xfrm>
-            <a:off x="566928" y="3436722"/>
+          <p:cNvPr id="11" name="Shape 8"/>
+          <p:cNvSpPr/>
+          <p:nvPr/>
+        </p:nvSpPr>
+        <p:spPr>
+          <a:xfrm>
+            <a:off x="566928" y="3144114"/>
+            <a:ext cx="45720" cy="237744"/>
+          </a:xfrm>
+          <a:prstGeom prst="rect">
+            <a:avLst/>
+          </a:prstGeom>
+          <a:solidFill>
+            <a:srgbClr val="D31145"/>
+          </a:solidFill>
+          <a:ln/>
+        </p:spPr>
+      </p:sp>
+      <p:sp>
+        <p:nvSpPr>
+          <p:cNvPr id="12" name="Text 9"/>
+          <p:cNvSpPr/>
+          <p:nvPr/>
+        </p:nvSpPr>
+        <p:spPr>
+          <a:xfrm>
+            <a:off x="749808" y="3144114"/>
+            <a:ext cx="6062472" cy="237744"/>
+          </a:xfrm>
+          <a:prstGeom prst="rect">
+            <a:avLst/>
+          </a:prstGeom>
+          <a:noFill/>
+          <a:ln/>
+        </p:spPr>
+        <p:txBody>
+          <a:bodyPr wrap="square" lIns="0" tIns="0" rIns="0" bIns="0" rtlCol="0" anchor="ctr"/>
+          <a:lstStyle/>
+          <a:p>
+            <a:pPr algn="l" indent="0" marL="0">
+              <a:buNone/>
+            </a:pPr>
+            <a:r>
+              <a:rPr lang="en-US" sz="820" b="1" spc="60" kern="0" dirty="0">
+                <a:solidFill>
+                  <a:srgbClr val="FFFFFF"/>
+                </a:solidFill>
+                <a:latin typeface="Arial" pitchFamily="34" charset="0"/>
+                <a:ea typeface="Arial" pitchFamily="34" charset="-122"/>
+                <a:cs typeface="Arial" pitchFamily="34" charset="-120"/>
+              </a:rPr>
+              <a:t>SELECTED.  Datum is the governing system for Combat Mindset.</a:t>
+            </a:r>
+            <a:endParaRPr lang="en-US" sz="820" dirty="0"/>
+          </a:p>
+        </p:txBody>
+      </p:sp>
+      <p:sp>
+        <p:nvSpPr>
+          <p:cNvPr id="13" name="Text 10"/>
+          <p:cNvSpPr/>
+          <p:nvPr/>
+        </p:nvSpPr>
+        <p:spPr>
+          <a:xfrm>
+            <a:off x="566928" y="3464154"/>
             <a:ext cx="6428232" cy="182880"/>
           </a:xfrm>
           <a:prstGeom prst="rect">
@@ -38831,13 +38934,13 @@
       </p:sp>
       <p:sp>
         <p:nvSpPr>
-          <p:cNvPr id="12" name="Shape 9"/>
-          <p:cNvSpPr/>
-          <p:nvPr/>
-        </p:nvSpPr>
-        <p:spPr>
-          <a:xfrm>
-            <a:off x="566928" y="3619602"/>
+          <p:cNvPr id="14" name="Shape 11"/>
+          <p:cNvSpPr/>
+          <p:nvPr/>
+        </p:nvSpPr>
+        <p:spPr>
+          <a:xfrm>
+            <a:off x="566928" y="3647034"/>
             <a:ext cx="6428232" cy="7315"/>
           </a:xfrm>
           <a:prstGeom prst="rect">
@@ -38851,13 +38954,13 @@
       </p:sp>
       <p:sp>
         <p:nvSpPr>
-          <p:cNvPr id="13" name="Text 10"/>
-          <p:cNvSpPr/>
-          <p:nvPr/>
-        </p:nvSpPr>
-        <p:spPr>
-          <a:xfrm>
-            <a:off x="566928" y="3729330"/>
+          <p:cNvPr id="15" name="Text 12"/>
+          <p:cNvSpPr/>
+          <p:nvPr/>
+        </p:nvSpPr>
+        <p:spPr>
+          <a:xfrm>
+            <a:off x="566928" y="3756762"/>
             <a:ext cx="6428232" cy="658368"/>
           </a:xfrm>
           <a:prstGeom prst="rect">
@@ -38893,13 +38996,13 @@
       </p:sp>
       <p:sp>
         <p:nvSpPr>
-          <p:cNvPr id="14" name="Text 11"/>
-          <p:cNvSpPr/>
-          <p:nvPr/>
-        </p:nvSpPr>
-        <p:spPr>
-          <a:xfrm>
-            <a:off x="566928" y="4479138"/>
+          <p:cNvPr id="16" name="Text 13"/>
+          <p:cNvSpPr/>
+          <p:nvPr/>
+        </p:nvSpPr>
+        <p:spPr>
+          <a:xfrm>
+            <a:off x="566928" y="4506570"/>
             <a:ext cx="6428232" cy="182880"/>
           </a:xfrm>
           <a:prstGeom prst="rect">
@@ -38932,13 +39035,13 @@
       </p:sp>
       <p:sp>
         <p:nvSpPr>
-          <p:cNvPr id="15" name="Shape 12"/>
-          <p:cNvSpPr/>
-          <p:nvPr/>
-        </p:nvSpPr>
-        <p:spPr>
-          <a:xfrm>
-            <a:off x="566928" y="4662018"/>
+          <p:cNvPr id="17" name="Shape 14"/>
+          <p:cNvSpPr/>
+          <p:nvPr/>
+        </p:nvSpPr>
+        <p:spPr>
+          <a:xfrm>
+            <a:off x="566928" y="4689450"/>
             <a:ext cx="6428232" cy="7315"/>
           </a:xfrm>
           <a:prstGeom prst="rect">
@@ -38952,13 +39055,13 @@
       </p:sp>
       <p:sp>
         <p:nvSpPr>
-          <p:cNvPr id="16" name="Shape 13"/>
-          <p:cNvSpPr/>
-          <p:nvPr/>
-        </p:nvSpPr>
-        <p:spPr>
-          <a:xfrm>
-            <a:off x="566928" y="4771746"/>
+          <p:cNvPr id="18" name="Shape 15"/>
+          <p:cNvSpPr/>
+          <p:nvPr/>
+        </p:nvSpPr>
+        <p:spPr>
+          <a:xfrm>
+            <a:off x="566928" y="4799178"/>
             <a:ext cx="36576" cy="566928"/>
           </a:xfrm>
           <a:prstGeom prst="rect">
@@ -38972,13 +39075,13 @@
       </p:sp>
       <p:sp>
         <p:nvSpPr>
-          <p:cNvPr id="17" name="Text 14"/>
-          <p:cNvSpPr/>
-          <p:nvPr/>
-        </p:nvSpPr>
-        <p:spPr>
-          <a:xfrm>
-            <a:off x="749808" y="4771746"/>
+          <p:cNvPr id="19" name="Text 16"/>
+          <p:cNvSpPr/>
+          <p:nvPr/>
+        </p:nvSpPr>
+        <p:spPr>
+          <a:xfrm>
+            <a:off x="749808" y="4799178"/>
             <a:ext cx="6245352" cy="566928"/>
           </a:xfrm>
           <a:prstGeom prst="rect">
@@ -39014,13 +39117,13 @@
       </p:sp>
       <p:sp>
         <p:nvSpPr>
-          <p:cNvPr id="18" name="Text 15"/>
-          <p:cNvSpPr/>
-          <p:nvPr/>
-        </p:nvSpPr>
-        <p:spPr>
-          <a:xfrm>
-            <a:off x="566928" y="5484978"/>
+          <p:cNvPr id="20" name="Text 17"/>
+          <p:cNvSpPr/>
+          <p:nvPr/>
+        </p:nvSpPr>
+        <p:spPr>
+          <a:xfrm>
+            <a:off x="566928" y="5512410"/>
             <a:ext cx="6428232" cy="182880"/>
           </a:xfrm>
           <a:prstGeom prst="rect">
@@ -39053,13 +39156,13 @@
       </p:sp>
       <p:sp>
         <p:nvSpPr>
-          <p:cNvPr id="19" name="Shape 16"/>
-          <p:cNvSpPr/>
-          <p:nvPr/>
-        </p:nvSpPr>
-        <p:spPr>
-          <a:xfrm>
-            <a:off x="566928" y="5667858"/>
+          <p:cNvPr id="21" name="Shape 18"/>
+          <p:cNvSpPr/>
+          <p:nvPr/>
+        </p:nvSpPr>
+        <p:spPr>
+          <a:xfrm>
+            <a:off x="566928" y="5695290"/>
             <a:ext cx="6428232" cy="7315"/>
           </a:xfrm>
           <a:prstGeom prst="rect">
@@ -39073,13 +39176,13 @@
       </p:sp>
       <p:sp>
         <p:nvSpPr>
-          <p:cNvPr id="20" name="Text 17"/>
-          <p:cNvSpPr/>
-          <p:nvPr/>
-        </p:nvSpPr>
-        <p:spPr>
-          <a:xfrm>
-            <a:off x="3909060" y="5484978"/>
+          <p:cNvPr id="22" name="Text 19"/>
+          <p:cNvSpPr/>
+          <p:nvPr/>
+        </p:nvSpPr>
+        <p:spPr>
+          <a:xfrm>
+            <a:off x="3909060" y="5512410"/>
             <a:ext cx="3086100" cy="182880"/>
           </a:xfrm>
           <a:prstGeom prst="rect">
@@ -39112,13 +39215,13 @@
       </p:sp>
       <p:sp>
         <p:nvSpPr>
-          <p:cNvPr id="21" name="Text 18"/>
-          <p:cNvSpPr/>
-          <p:nvPr/>
-        </p:nvSpPr>
-        <p:spPr>
-          <a:xfrm>
-            <a:off x="566928" y="5777586"/>
+          <p:cNvPr id="23" name="Text 20"/>
+          <p:cNvSpPr/>
+          <p:nvPr/>
+        </p:nvSpPr>
+        <p:spPr>
+          <a:xfrm>
+            <a:off x="566928" y="5805018"/>
             <a:ext cx="3086100" cy="2377440"/>
           </a:xfrm>
           <a:prstGeom prst="rect">
@@ -39230,13 +39333,13 @@
       </p:sp>
       <p:sp>
         <p:nvSpPr>
-          <p:cNvPr id="22" name="Text 19"/>
-          <p:cNvSpPr/>
-          <p:nvPr/>
-        </p:nvSpPr>
-        <p:spPr>
-          <a:xfrm>
-            <a:off x="3909060" y="5777586"/>
+          <p:cNvPr id="24" name="Text 21"/>
+          <p:cNvSpPr/>
+          <p:nvPr/>
+        </p:nvSpPr>
+        <p:spPr>
+          <a:xfrm>
+            <a:off x="3909060" y="5805018"/>
             <a:ext cx="3086100" cy="2377440"/>
           </a:xfrm>
           <a:prstGeom prst="rect">
@@ -39300,7 +39403,7 @@
       </p:sp>
       <p:sp>
         <p:nvSpPr>
-          <p:cNvPr id="23" name="Text 20"/>
+          <p:cNvPr id="25" name="Text 22"/>
           <p:cNvSpPr/>
           <p:nvPr/>
         </p:nvSpPr>
@@ -39339,7 +39442,7 @@
       </p:sp>
       <p:sp>
         <p:nvSpPr>
-          <p:cNvPr id="24" name="Shape 21"/>
+          <p:cNvPr id="26" name="Shape 23"/>
           <p:cNvSpPr/>
           <p:nvPr/>
         </p:nvSpPr>
@@ -39359,7 +39462,7 @@
       </p:sp>
       <p:sp>
         <p:nvSpPr>
-          <p:cNvPr id="25" name="Shape 22"/>
+          <p:cNvPr id="27" name="Shape 24"/>
           <p:cNvSpPr/>
           <p:nvPr/>
         </p:nvSpPr>
@@ -39384,7 +39487,7 @@
       </p:sp>
       <p:pic>
         <p:nvPicPr>
-          <p:cNvPr id="26" name="Image 1" descr="preencoded.png">    </p:cNvPr>
+          <p:cNvPr id="28" name="Image 1" descr="preencoded.png">    </p:cNvPr>
           <p:cNvPicPr>
             <a:picLocks noChangeAspect="1"/>
           </p:cNvPicPr>
@@ -39408,7 +39511,7 @@
       </p:pic>
       <p:sp>
         <p:nvSpPr>
-          <p:cNvPr id="27" name="Text 23"/>
+          <p:cNvPr id="29" name="Text 25"/>
           <p:cNvSpPr/>
           <p:nvPr/>
         </p:nvSpPr>
@@ -39447,7 +39550,7 @@
       </p:sp>
       <p:sp>
         <p:nvSpPr>
-          <p:cNvPr id="28" name="Shape 24"/>
+          <p:cNvPr id="30" name="Shape 26"/>
           <p:cNvSpPr/>
           <p:nvPr/>
         </p:nvSpPr>
@@ -39472,7 +39575,7 @@
       </p:sp>
       <p:pic>
         <p:nvPicPr>
-          <p:cNvPr id="29" name="Image 2" descr="preencoded.png">    </p:cNvPr>
+          <p:cNvPr id="31" name="Image 2" descr="preencoded.png">    </p:cNvPr>
           <p:cNvPicPr>
             <a:picLocks noChangeAspect="1"/>
           </p:cNvPicPr>
@@ -39496,7 +39599,7 @@
       </p:pic>
       <p:sp>
         <p:nvSpPr>
-          <p:cNvPr id="30" name="Text 25"/>
+          <p:cNvPr id="32" name="Text 27"/>
           <p:cNvSpPr/>
           <p:nvPr/>
         </p:nvSpPr>
@@ -39535,7 +39638,7 @@
       </p:sp>
       <p:sp>
         <p:nvSpPr>
-          <p:cNvPr id="31" name="Shape 26"/>
+          <p:cNvPr id="33" name="Shape 28"/>
           <p:cNvSpPr/>
           <p:nvPr/>
         </p:nvSpPr>
@@ -39560,7 +39663,7 @@
       </p:sp>
       <p:pic>
         <p:nvPicPr>
-          <p:cNvPr id="32" name="Image 3" descr="preencoded.png">    </p:cNvPr>
+          <p:cNvPr id="34" name="Image 3" descr="preencoded.png">    </p:cNvPr>
           <p:cNvPicPr>
             <a:picLocks noChangeAspect="1"/>
           </p:cNvPicPr>
@@ -39584,7 +39687,7 @@
       </p:pic>
       <p:sp>
         <p:nvSpPr>
-          <p:cNvPr id="33" name="Text 27"/>
+          <p:cNvPr id="35" name="Text 29"/>
           <p:cNvSpPr/>
           <p:nvPr/>
         </p:nvSpPr>
@@ -39623,7 +39726,7 @@
       </p:sp>
       <p:sp>
         <p:nvSpPr>
-          <p:cNvPr id="34" name="Text 28"/>
+          <p:cNvPr id="36" name="Text 30"/>
           <p:cNvSpPr/>
           <p:nvPr/>
         </p:nvSpPr>
@@ -39728,7 +39831,7 @@
                 <a:ea typeface="Arial" pitchFamily="34" charset="-122"/>
                 <a:cs typeface="Arial" pitchFamily="34" charset="-120"/>
               </a:rPr>
-              <a:t>CONCEPT B</a:t>
+              <a:t>CONSIDERED</a:t>
             </a:r>
             <a:endParaRPr lang="en-US" sz="700" dirty="0"/>
           </a:p>
@@ -39946,7 +40049,7 @@
                 <a:ea typeface="Arial" pitchFamily="34" charset="-122"/>
                 <a:cs typeface="Arial" pitchFamily="34" charset="-120"/>
               </a:rPr>
-              <a:t>DRAFT V0.5   |   AUGUST 2026</a:t>
+              <a:t>DRAFT V0.6   |   AUGUST 2026</a:t>
             </a:r>
             <a:endParaRPr lang="en-US" sz="600" dirty="0"/>
           </a:p>
@@ -39985,13 +40088,13 @@
         <p:spPr>
           <a:xfrm>
             <a:off x="566928" y="3144114"/>
-            <a:ext cx="6428232" cy="12802"/>
+            <a:ext cx="6428232" cy="237744"/>
           </a:xfrm>
           <a:prstGeom prst="rect">
             <a:avLst/>
           </a:prstGeom>
           <a:solidFill>
-            <a:srgbClr val="444D06"/>
+            <a:srgbClr val="F5F5F3"/>
           </a:solidFill>
           <a:ln/>
         </p:spPr>
@@ -40004,7 +40107,46 @@
         </p:nvSpPr>
         <p:spPr>
           <a:xfrm>
-            <a:off x="566928" y="3436722"/>
+            <a:off x="749808" y="3144114"/>
+            <a:ext cx="6062472" cy="237744"/>
+          </a:xfrm>
+          <a:prstGeom prst="rect">
+            <a:avLst/>
+          </a:prstGeom>
+          <a:noFill/>
+          <a:ln/>
+        </p:spPr>
+        <p:txBody>
+          <a:bodyPr wrap="square" lIns="0" tIns="0" rIns="0" bIns="0" rtlCol="0" anchor="ctr"/>
+          <a:lstStyle/>
+          <a:p>
+            <a:pPr algn="l" indent="0" marL="0">
+              <a:buNone/>
+            </a:pPr>
+            <a:r>
+              <a:rPr lang="en-US" sz="820" b="1" spc="60" kern="0" dirty="0">
+                <a:solidFill>
+                  <a:srgbClr val="6E6E6E"/>
+                </a:solidFill>
+                <a:latin typeface="Arial" pitchFamily="34" charset="0"/>
+                <a:ea typeface="Arial" pitchFamily="34" charset="-122"/>
+                <a:cs typeface="Arial" pitchFamily="34" charset="-120"/>
+              </a:rPr>
+              <a:t>NOT ADOPTED.  The density field is retained as rationed texture only.</a:t>
+            </a:r>
+            <a:endParaRPr lang="en-US" sz="820" dirty="0"/>
+          </a:p>
+        </p:txBody>
+      </p:sp>
+      <p:sp>
+        <p:nvSpPr>
+          <p:cNvPr id="12" name="Text 9"/>
+          <p:cNvSpPr/>
+          <p:nvPr/>
+        </p:nvSpPr>
+        <p:spPr>
+          <a:xfrm>
+            <a:off x="566928" y="3464154"/>
             <a:ext cx="6428232" cy="182880"/>
           </a:xfrm>
           <a:prstGeom prst="rect">
@@ -40037,13 +40179,13 @@
       </p:sp>
       <p:sp>
         <p:nvSpPr>
-          <p:cNvPr id="12" name="Shape 9"/>
-          <p:cNvSpPr/>
-          <p:nvPr/>
-        </p:nvSpPr>
-        <p:spPr>
-          <a:xfrm>
-            <a:off x="566928" y="3619602"/>
+          <p:cNvPr id="13" name="Shape 10"/>
+          <p:cNvSpPr/>
+          <p:nvPr/>
+        </p:nvSpPr>
+        <p:spPr>
+          <a:xfrm>
+            <a:off x="566928" y="3647034"/>
             <a:ext cx="6428232" cy="7315"/>
           </a:xfrm>
           <a:prstGeom prst="rect">
@@ -40057,13 +40199,13 @@
       </p:sp>
       <p:sp>
         <p:nvSpPr>
-          <p:cNvPr id="13" name="Text 10"/>
-          <p:cNvSpPr/>
-          <p:nvPr/>
-        </p:nvSpPr>
-        <p:spPr>
-          <a:xfrm>
-            <a:off x="566928" y="3729330"/>
+          <p:cNvPr id="14" name="Text 11"/>
+          <p:cNvSpPr/>
+          <p:nvPr/>
+        </p:nvSpPr>
+        <p:spPr>
+          <a:xfrm>
+            <a:off x="566928" y="3756762"/>
             <a:ext cx="6428232" cy="658368"/>
           </a:xfrm>
           <a:prstGeom prst="rect">
@@ -40099,13 +40241,13 @@
       </p:sp>
       <p:sp>
         <p:nvSpPr>
-          <p:cNvPr id="14" name="Text 11"/>
-          <p:cNvSpPr/>
-          <p:nvPr/>
-        </p:nvSpPr>
-        <p:spPr>
-          <a:xfrm>
-            <a:off x="566928" y="4479138"/>
+          <p:cNvPr id="15" name="Text 12"/>
+          <p:cNvSpPr/>
+          <p:nvPr/>
+        </p:nvSpPr>
+        <p:spPr>
+          <a:xfrm>
+            <a:off x="566928" y="4506570"/>
             <a:ext cx="6428232" cy="182880"/>
           </a:xfrm>
           <a:prstGeom prst="rect">
@@ -40138,13 +40280,13 @@
       </p:sp>
       <p:sp>
         <p:nvSpPr>
-          <p:cNvPr id="15" name="Shape 12"/>
-          <p:cNvSpPr/>
-          <p:nvPr/>
-        </p:nvSpPr>
-        <p:spPr>
-          <a:xfrm>
-            <a:off x="566928" y="4662018"/>
+          <p:cNvPr id="16" name="Shape 13"/>
+          <p:cNvSpPr/>
+          <p:nvPr/>
+        </p:nvSpPr>
+        <p:spPr>
+          <a:xfrm>
+            <a:off x="566928" y="4689450"/>
             <a:ext cx="6428232" cy="7315"/>
           </a:xfrm>
           <a:prstGeom prst="rect">
@@ -40158,13 +40300,13 @@
       </p:sp>
       <p:sp>
         <p:nvSpPr>
-          <p:cNvPr id="16" name="Shape 13"/>
-          <p:cNvSpPr/>
-          <p:nvPr/>
-        </p:nvSpPr>
-        <p:spPr>
-          <a:xfrm>
-            <a:off x="566928" y="4771746"/>
+          <p:cNvPr id="17" name="Shape 14"/>
+          <p:cNvSpPr/>
+          <p:nvPr/>
+        </p:nvSpPr>
+        <p:spPr>
+          <a:xfrm>
+            <a:off x="566928" y="4799178"/>
             <a:ext cx="36576" cy="566928"/>
           </a:xfrm>
           <a:prstGeom prst="rect">
@@ -40178,13 +40320,13 @@
       </p:sp>
       <p:sp>
         <p:nvSpPr>
-          <p:cNvPr id="17" name="Text 14"/>
-          <p:cNvSpPr/>
-          <p:nvPr/>
-        </p:nvSpPr>
-        <p:spPr>
-          <a:xfrm>
-            <a:off x="749808" y="4771746"/>
+          <p:cNvPr id="18" name="Text 15"/>
+          <p:cNvSpPr/>
+          <p:nvPr/>
+        </p:nvSpPr>
+        <p:spPr>
+          <a:xfrm>
+            <a:off x="749808" y="4799178"/>
             <a:ext cx="6245352" cy="566928"/>
           </a:xfrm>
           <a:prstGeom prst="rect">
@@ -40220,13 +40362,13 @@
       </p:sp>
       <p:sp>
         <p:nvSpPr>
-          <p:cNvPr id="18" name="Text 15"/>
-          <p:cNvSpPr/>
-          <p:nvPr/>
-        </p:nvSpPr>
-        <p:spPr>
-          <a:xfrm>
-            <a:off x="566928" y="5484978"/>
+          <p:cNvPr id="19" name="Text 16"/>
+          <p:cNvSpPr/>
+          <p:nvPr/>
+        </p:nvSpPr>
+        <p:spPr>
+          <a:xfrm>
+            <a:off x="566928" y="5512410"/>
             <a:ext cx="6428232" cy="182880"/>
           </a:xfrm>
           <a:prstGeom prst="rect">
@@ -40259,13 +40401,13 @@
       </p:sp>
       <p:sp>
         <p:nvSpPr>
-          <p:cNvPr id="19" name="Shape 16"/>
-          <p:cNvSpPr/>
-          <p:nvPr/>
-        </p:nvSpPr>
-        <p:spPr>
-          <a:xfrm>
-            <a:off x="566928" y="5667858"/>
+          <p:cNvPr id="20" name="Shape 17"/>
+          <p:cNvSpPr/>
+          <p:nvPr/>
+        </p:nvSpPr>
+        <p:spPr>
+          <a:xfrm>
+            <a:off x="566928" y="5695290"/>
             <a:ext cx="6428232" cy="7315"/>
           </a:xfrm>
           <a:prstGeom prst="rect">
@@ -40279,13 +40421,13 @@
       </p:sp>
       <p:sp>
         <p:nvSpPr>
-          <p:cNvPr id="20" name="Text 17"/>
-          <p:cNvSpPr/>
-          <p:nvPr/>
-        </p:nvSpPr>
-        <p:spPr>
-          <a:xfrm>
-            <a:off x="3909060" y="5484978"/>
+          <p:cNvPr id="21" name="Text 18"/>
+          <p:cNvSpPr/>
+          <p:nvPr/>
+        </p:nvSpPr>
+        <p:spPr>
+          <a:xfrm>
+            <a:off x="3909060" y="5512410"/>
             <a:ext cx="3086100" cy="182880"/>
           </a:xfrm>
           <a:prstGeom prst="rect">
@@ -40318,13 +40460,13 @@
       </p:sp>
       <p:sp>
         <p:nvSpPr>
-          <p:cNvPr id="21" name="Text 18"/>
-          <p:cNvSpPr/>
-          <p:nvPr/>
-        </p:nvSpPr>
-        <p:spPr>
-          <a:xfrm>
-            <a:off x="566928" y="5777586"/>
+          <p:cNvPr id="22" name="Text 19"/>
+          <p:cNvSpPr/>
+          <p:nvPr/>
+        </p:nvSpPr>
+        <p:spPr>
+          <a:xfrm>
+            <a:off x="566928" y="5805018"/>
             <a:ext cx="3086100" cy="2377440"/>
           </a:xfrm>
           <a:prstGeom prst="rect">
@@ -40412,13 +40554,13 @@
       </p:sp>
       <p:sp>
         <p:nvSpPr>
-          <p:cNvPr id="22" name="Text 19"/>
-          <p:cNvSpPr/>
-          <p:nvPr/>
-        </p:nvSpPr>
-        <p:spPr>
-          <a:xfrm>
-            <a:off x="3909060" y="5777586"/>
+          <p:cNvPr id="23" name="Text 20"/>
+          <p:cNvSpPr/>
+          <p:nvPr/>
+        </p:nvSpPr>
+        <p:spPr>
+          <a:xfrm>
+            <a:off x="3909060" y="5805018"/>
             <a:ext cx="3086100" cy="2377440"/>
           </a:xfrm>
           <a:prstGeom prst="rect">
@@ -40506,7 +40648,7 @@
       </p:sp>
       <p:sp>
         <p:nvSpPr>
-          <p:cNvPr id="23" name="Text 20"/>
+          <p:cNvPr id="24" name="Text 21"/>
           <p:cNvSpPr/>
           <p:nvPr/>
         </p:nvSpPr>
@@ -40545,7 +40687,7 @@
       </p:sp>
       <p:sp>
         <p:nvSpPr>
-          <p:cNvPr id="24" name="Shape 21"/>
+          <p:cNvPr id="25" name="Shape 22"/>
           <p:cNvSpPr/>
           <p:nvPr/>
         </p:nvSpPr>
@@ -40565,7 +40707,7 @@
       </p:sp>
       <p:sp>
         <p:nvSpPr>
-          <p:cNvPr id="25" name="Shape 22"/>
+          <p:cNvPr id="26" name="Shape 23"/>
           <p:cNvSpPr/>
           <p:nvPr/>
         </p:nvSpPr>
@@ -40590,7 +40732,7 @@
       </p:sp>
       <p:pic>
         <p:nvPicPr>
-          <p:cNvPr id="26" name="Image 1" descr="preencoded.png">    </p:cNvPr>
+          <p:cNvPr id="27" name="Image 1" descr="preencoded.png">    </p:cNvPr>
           <p:cNvPicPr>
             <a:picLocks noChangeAspect="1"/>
           </p:cNvPicPr>
@@ -40614,7 +40756,7 @@
       </p:pic>
       <p:sp>
         <p:nvSpPr>
-          <p:cNvPr id="27" name="Text 23"/>
+          <p:cNvPr id="28" name="Text 24"/>
           <p:cNvSpPr/>
           <p:nvPr/>
         </p:nvSpPr>
@@ -40653,7 +40795,7 @@
       </p:sp>
       <p:sp>
         <p:nvSpPr>
-          <p:cNvPr id="28" name="Shape 24"/>
+          <p:cNvPr id="29" name="Shape 25"/>
           <p:cNvSpPr/>
           <p:nvPr/>
         </p:nvSpPr>
@@ -40678,7 +40820,7 @@
       </p:sp>
       <p:pic>
         <p:nvPicPr>
-          <p:cNvPr id="29" name="Image 2" descr="preencoded.png">    </p:cNvPr>
+          <p:cNvPr id="30" name="Image 2" descr="preencoded.png">    </p:cNvPr>
           <p:cNvPicPr>
             <a:picLocks noChangeAspect="1"/>
           </p:cNvPicPr>
@@ -40702,7 +40844,7 @@
       </p:pic>
       <p:sp>
         <p:nvSpPr>
-          <p:cNvPr id="30" name="Text 25"/>
+          <p:cNvPr id="31" name="Text 26"/>
           <p:cNvSpPr/>
           <p:nvPr/>
         </p:nvSpPr>
@@ -40741,7 +40883,7 @@
       </p:sp>
       <p:sp>
         <p:nvSpPr>
-          <p:cNvPr id="31" name="Shape 26"/>
+          <p:cNvPr id="32" name="Shape 27"/>
           <p:cNvSpPr/>
           <p:nvPr/>
         </p:nvSpPr>
@@ -40766,7 +40908,7 @@
       </p:sp>
       <p:pic>
         <p:nvPicPr>
-          <p:cNvPr id="32" name="Image 3" descr="preencoded.png">    </p:cNvPr>
+          <p:cNvPr id="33" name="Image 3" descr="preencoded.png">    </p:cNvPr>
           <p:cNvPicPr>
             <a:picLocks noChangeAspect="1"/>
           </p:cNvPicPr>
@@ -40790,7 +40932,7 @@
       </p:pic>
       <p:sp>
         <p:nvSpPr>
-          <p:cNvPr id="33" name="Text 27"/>
+          <p:cNvPr id="34" name="Text 28"/>
           <p:cNvSpPr/>
           <p:nvPr/>
         </p:nvSpPr>
@@ -40829,7 +40971,7 @@
       </p:sp>
       <p:sp>
         <p:nvSpPr>
-          <p:cNvPr id="34" name="Text 28"/>
+          <p:cNvPr id="35" name="Text 29"/>
           <p:cNvSpPr/>
           <p:nvPr/>
         </p:nvSpPr>
@@ -40934,7 +41076,7 @@
                 <a:ea typeface="Arial" pitchFamily="34" charset="-122"/>
                 <a:cs typeface="Arial" pitchFamily="34" charset="-120"/>
               </a:rPr>
-              <a:t>CONCEPT C</a:t>
+              <a:t>CONSIDERED</a:t>
             </a:r>
             <a:endParaRPr lang="en-US" sz="700" dirty="0"/>
           </a:p>
@@ -41152,7 +41294,7 @@
                 <a:ea typeface="Arial" pitchFamily="34" charset="-122"/>
                 <a:cs typeface="Arial" pitchFamily="34" charset="-120"/>
               </a:rPr>
-              <a:t>DRAFT V0.5   |   AUGUST 2026</a:t>
+              <a:t>DRAFT V0.6   |   AUGUST 2026</a:t>
             </a:r>
             <a:endParaRPr lang="en-US" sz="600" dirty="0"/>
           </a:p>
@@ -41191,13 +41333,13 @@
         <p:spPr>
           <a:xfrm>
             <a:off x="566928" y="3144114"/>
-            <a:ext cx="6428232" cy="12802"/>
+            <a:ext cx="6428232" cy="237744"/>
           </a:xfrm>
           <a:prstGeom prst="rect">
             <a:avLst/>
           </a:prstGeom>
           <a:solidFill>
-            <a:srgbClr val="B3A650"/>
+            <a:srgbClr val="F5F5F3"/>
           </a:solidFill>
           <a:ln/>
         </p:spPr>
@@ -41210,7 +41352,46 @@
         </p:nvSpPr>
         <p:spPr>
           <a:xfrm>
-            <a:off x="566928" y="3436722"/>
+            <a:off x="749808" y="3144114"/>
+            <a:ext cx="6062472" cy="237744"/>
+          </a:xfrm>
+          <a:prstGeom prst="rect">
+            <a:avLst/>
+          </a:prstGeom>
+          <a:noFill/>
+          <a:ln/>
+        </p:spPr>
+        <p:txBody>
+          <a:bodyPr wrap="square" lIns="0" tIns="0" rIns="0" bIns="0" rtlCol="0" anchor="ctr"/>
+          <a:lstStyle/>
+          <a:p>
+            <a:pPr algn="l" indent="0" marL="0">
+              <a:buNone/>
+            </a:pPr>
+            <a:r>
+              <a:rPr lang="en-US" sz="820" b="1" spc="60" kern="0" dirty="0">
+                <a:solidFill>
+                  <a:srgbClr val="6E6E6E"/>
+                </a:solidFill>
+                <a:latin typeface="Arial" pitchFamily="34" charset="0"/>
+                <a:ea typeface="Arial" pitchFamily="34" charset="-122"/>
+                <a:cs typeface="Arial" pitchFamily="34" charset="-120"/>
+              </a:rPr>
+              <a:t>NOT ADOPTED.  The node and departure are retained to mark decision.</a:t>
+            </a:r>
+            <a:endParaRPr lang="en-US" sz="820" dirty="0"/>
+          </a:p>
+        </p:txBody>
+      </p:sp>
+      <p:sp>
+        <p:nvSpPr>
+          <p:cNvPr id="12" name="Text 9"/>
+          <p:cNvSpPr/>
+          <p:nvPr/>
+        </p:nvSpPr>
+        <p:spPr>
+          <a:xfrm>
+            <a:off x="566928" y="3464154"/>
             <a:ext cx="6428232" cy="182880"/>
           </a:xfrm>
           <a:prstGeom prst="rect">
@@ -41243,13 +41424,13 @@
       </p:sp>
       <p:sp>
         <p:nvSpPr>
-          <p:cNvPr id="12" name="Shape 9"/>
-          <p:cNvSpPr/>
-          <p:nvPr/>
-        </p:nvSpPr>
-        <p:spPr>
-          <a:xfrm>
-            <a:off x="566928" y="3619602"/>
+          <p:cNvPr id="13" name="Shape 10"/>
+          <p:cNvSpPr/>
+          <p:nvPr/>
+        </p:nvSpPr>
+        <p:spPr>
+          <a:xfrm>
+            <a:off x="566928" y="3647034"/>
             <a:ext cx="6428232" cy="7315"/>
           </a:xfrm>
           <a:prstGeom prst="rect">
@@ -41263,13 +41444,13 @@
       </p:sp>
       <p:sp>
         <p:nvSpPr>
-          <p:cNvPr id="13" name="Text 10"/>
-          <p:cNvSpPr/>
-          <p:nvPr/>
-        </p:nvSpPr>
-        <p:spPr>
-          <a:xfrm>
-            <a:off x="566928" y="3729330"/>
+          <p:cNvPr id="14" name="Text 11"/>
+          <p:cNvSpPr/>
+          <p:nvPr/>
+        </p:nvSpPr>
+        <p:spPr>
+          <a:xfrm>
+            <a:off x="566928" y="3756762"/>
             <a:ext cx="6428232" cy="658368"/>
           </a:xfrm>
           <a:prstGeom prst="rect">
@@ -41305,13 +41486,13 @@
       </p:sp>
       <p:sp>
         <p:nvSpPr>
-          <p:cNvPr id="14" name="Text 11"/>
-          <p:cNvSpPr/>
-          <p:nvPr/>
-        </p:nvSpPr>
-        <p:spPr>
-          <a:xfrm>
-            <a:off x="566928" y="4479138"/>
+          <p:cNvPr id="15" name="Text 12"/>
+          <p:cNvSpPr/>
+          <p:nvPr/>
+        </p:nvSpPr>
+        <p:spPr>
+          <a:xfrm>
+            <a:off x="566928" y="4506570"/>
             <a:ext cx="6428232" cy="182880"/>
           </a:xfrm>
           <a:prstGeom prst="rect">
@@ -41344,13 +41525,13 @@
       </p:sp>
       <p:sp>
         <p:nvSpPr>
-          <p:cNvPr id="15" name="Shape 12"/>
-          <p:cNvSpPr/>
-          <p:nvPr/>
-        </p:nvSpPr>
-        <p:spPr>
-          <a:xfrm>
-            <a:off x="566928" y="4662018"/>
+          <p:cNvPr id="16" name="Shape 13"/>
+          <p:cNvSpPr/>
+          <p:nvPr/>
+        </p:nvSpPr>
+        <p:spPr>
+          <a:xfrm>
+            <a:off x="566928" y="4689450"/>
             <a:ext cx="6428232" cy="7315"/>
           </a:xfrm>
           <a:prstGeom prst="rect">
@@ -41364,13 +41545,13 @@
       </p:sp>
       <p:sp>
         <p:nvSpPr>
-          <p:cNvPr id="16" name="Shape 13"/>
-          <p:cNvSpPr/>
-          <p:nvPr/>
-        </p:nvSpPr>
-        <p:spPr>
-          <a:xfrm>
-            <a:off x="566928" y="4771746"/>
+          <p:cNvPr id="17" name="Shape 14"/>
+          <p:cNvSpPr/>
+          <p:nvPr/>
+        </p:nvSpPr>
+        <p:spPr>
+          <a:xfrm>
+            <a:off x="566928" y="4799178"/>
             <a:ext cx="36576" cy="566928"/>
           </a:xfrm>
           <a:prstGeom prst="rect">
@@ -41384,13 +41565,13 @@
       </p:sp>
       <p:sp>
         <p:nvSpPr>
-          <p:cNvPr id="17" name="Text 14"/>
-          <p:cNvSpPr/>
-          <p:nvPr/>
-        </p:nvSpPr>
-        <p:spPr>
-          <a:xfrm>
-            <a:off x="749808" y="4771746"/>
+          <p:cNvPr id="18" name="Text 15"/>
+          <p:cNvSpPr/>
+          <p:nvPr/>
+        </p:nvSpPr>
+        <p:spPr>
+          <a:xfrm>
+            <a:off x="749808" y="4799178"/>
             <a:ext cx="6245352" cy="566928"/>
           </a:xfrm>
           <a:prstGeom prst="rect">
@@ -41426,13 +41607,13 @@
       </p:sp>
       <p:sp>
         <p:nvSpPr>
-          <p:cNvPr id="18" name="Text 15"/>
-          <p:cNvSpPr/>
-          <p:nvPr/>
-        </p:nvSpPr>
-        <p:spPr>
-          <a:xfrm>
-            <a:off x="566928" y="5484978"/>
+          <p:cNvPr id="19" name="Text 16"/>
+          <p:cNvSpPr/>
+          <p:nvPr/>
+        </p:nvSpPr>
+        <p:spPr>
+          <a:xfrm>
+            <a:off x="566928" y="5512410"/>
             <a:ext cx="6428232" cy="182880"/>
           </a:xfrm>
           <a:prstGeom prst="rect">
@@ -41465,13 +41646,13 @@
       </p:sp>
       <p:sp>
         <p:nvSpPr>
-          <p:cNvPr id="19" name="Shape 16"/>
-          <p:cNvSpPr/>
-          <p:nvPr/>
-        </p:nvSpPr>
-        <p:spPr>
-          <a:xfrm>
-            <a:off x="566928" y="5667858"/>
+          <p:cNvPr id="20" name="Shape 17"/>
+          <p:cNvSpPr/>
+          <p:nvPr/>
+        </p:nvSpPr>
+        <p:spPr>
+          <a:xfrm>
+            <a:off x="566928" y="5695290"/>
             <a:ext cx="6428232" cy="7315"/>
           </a:xfrm>
           <a:prstGeom prst="rect">
@@ -41485,13 +41666,13 @@
       </p:sp>
       <p:sp>
         <p:nvSpPr>
-          <p:cNvPr id="20" name="Text 17"/>
-          <p:cNvSpPr/>
-          <p:nvPr/>
-        </p:nvSpPr>
-        <p:spPr>
-          <a:xfrm>
-            <a:off x="3909060" y="5484978"/>
+          <p:cNvPr id="21" name="Text 18"/>
+          <p:cNvSpPr/>
+          <p:nvPr/>
+        </p:nvSpPr>
+        <p:spPr>
+          <a:xfrm>
+            <a:off x="3909060" y="5512410"/>
             <a:ext cx="3086100" cy="182880"/>
           </a:xfrm>
           <a:prstGeom prst="rect">
@@ -41524,13 +41705,13 @@
       </p:sp>
       <p:sp>
         <p:nvSpPr>
-          <p:cNvPr id="21" name="Text 18"/>
-          <p:cNvSpPr/>
-          <p:nvPr/>
-        </p:nvSpPr>
-        <p:spPr>
-          <a:xfrm>
-            <a:off x="566928" y="5777586"/>
+          <p:cNvPr id="22" name="Text 19"/>
+          <p:cNvSpPr/>
+          <p:nvPr/>
+        </p:nvSpPr>
+        <p:spPr>
+          <a:xfrm>
+            <a:off x="566928" y="5805018"/>
             <a:ext cx="3086100" cy="2377440"/>
           </a:xfrm>
           <a:prstGeom prst="rect">
@@ -41618,13 +41799,13 @@
       </p:sp>
       <p:sp>
         <p:nvSpPr>
-          <p:cNvPr id="22" name="Text 19"/>
-          <p:cNvSpPr/>
-          <p:nvPr/>
-        </p:nvSpPr>
-        <p:spPr>
-          <a:xfrm>
-            <a:off x="3909060" y="5777586"/>
+          <p:cNvPr id="23" name="Text 20"/>
+          <p:cNvSpPr/>
+          <p:nvPr/>
+        </p:nvSpPr>
+        <p:spPr>
+          <a:xfrm>
+            <a:off x="3909060" y="5805018"/>
             <a:ext cx="3086100" cy="2377440"/>
           </a:xfrm>
           <a:prstGeom prst="rect">
@@ -41712,7 +41893,7 @@
       </p:sp>
       <p:sp>
         <p:nvSpPr>
-          <p:cNvPr id="23" name="Text 20"/>
+          <p:cNvPr id="24" name="Text 21"/>
           <p:cNvSpPr/>
           <p:nvPr/>
         </p:nvSpPr>
@@ -41751,7 +41932,7 @@
       </p:sp>
       <p:sp>
         <p:nvSpPr>
-          <p:cNvPr id="24" name="Shape 21"/>
+          <p:cNvPr id="25" name="Shape 22"/>
           <p:cNvSpPr/>
           <p:nvPr/>
         </p:nvSpPr>
@@ -41771,7 +41952,7 @@
       </p:sp>
       <p:sp>
         <p:nvSpPr>
-          <p:cNvPr id="25" name="Shape 22"/>
+          <p:cNvPr id="26" name="Shape 23"/>
           <p:cNvSpPr/>
           <p:nvPr/>
         </p:nvSpPr>
@@ -41796,7 +41977,7 @@
       </p:sp>
       <p:pic>
         <p:nvPicPr>
-          <p:cNvPr id="26" name="Image 1" descr="preencoded.png">    </p:cNvPr>
+          <p:cNvPr id="27" name="Image 1" descr="preencoded.png">    </p:cNvPr>
           <p:cNvPicPr>
             <a:picLocks noChangeAspect="1"/>
           </p:cNvPicPr>
@@ -41820,7 +42001,7 @@
       </p:pic>
       <p:sp>
         <p:nvSpPr>
-          <p:cNvPr id="27" name="Text 23"/>
+          <p:cNvPr id="28" name="Text 24"/>
           <p:cNvSpPr/>
           <p:nvPr/>
         </p:nvSpPr>
@@ -41859,7 +42040,7 @@
       </p:sp>
       <p:sp>
         <p:nvSpPr>
-          <p:cNvPr id="28" name="Shape 24"/>
+          <p:cNvPr id="29" name="Shape 25"/>
           <p:cNvSpPr/>
           <p:nvPr/>
         </p:nvSpPr>
@@ -41884,7 +42065,7 @@
       </p:sp>
       <p:pic>
         <p:nvPicPr>
-          <p:cNvPr id="29" name="Image 2" descr="preencoded.png">    </p:cNvPr>
+          <p:cNvPr id="30" name="Image 2" descr="preencoded.png">    </p:cNvPr>
           <p:cNvPicPr>
             <a:picLocks noChangeAspect="1"/>
           </p:cNvPicPr>
@@ -41908,7 +42089,7 @@
       </p:pic>
       <p:sp>
         <p:nvSpPr>
-          <p:cNvPr id="30" name="Text 25"/>
+          <p:cNvPr id="31" name="Text 26"/>
           <p:cNvSpPr/>
           <p:nvPr/>
         </p:nvSpPr>
@@ -41947,7 +42128,7 @@
       </p:sp>
       <p:sp>
         <p:nvSpPr>
-          <p:cNvPr id="31" name="Shape 26"/>
+          <p:cNvPr id="32" name="Shape 27"/>
           <p:cNvSpPr/>
           <p:nvPr/>
         </p:nvSpPr>
@@ -41972,7 +42153,7 @@
       </p:sp>
       <p:pic>
         <p:nvPicPr>
-          <p:cNvPr id="32" name="Image 3" descr="preencoded.png">    </p:cNvPr>
+          <p:cNvPr id="33" name="Image 3" descr="preencoded.png">    </p:cNvPr>
           <p:cNvPicPr>
             <a:picLocks noChangeAspect="1"/>
           </p:cNvPicPr>
@@ -41996,7 +42177,7 @@
       </p:pic>
       <p:sp>
         <p:nvSpPr>
-          <p:cNvPr id="33" name="Text 27"/>
+          <p:cNvPr id="34" name="Text 28"/>
           <p:cNvSpPr/>
           <p:nvPr/>
         </p:nvSpPr>
@@ -42035,7 +42216,7 @@
       </p:sp>
       <p:sp>
         <p:nvSpPr>
-          <p:cNvPr id="34" name="Text 28"/>
+          <p:cNvPr id="35" name="Text 29"/>
           <p:cNvSpPr/>
           <p:nvPr/>
         </p:nvSpPr>

</xml_diff>